<commit_message>
Missing values more than expected
</commit_message>
<xml_diff>
--- a/assets/ppt/data_exploration.pptx
+++ b/assets/ppt/data_exploration.pptx
@@ -13,14 +13,14 @@
     <p:sldId id="256" r:id="rId4"/>
     <p:sldId id="266" r:id="rId5"/>
     <p:sldId id="258" r:id="rId6"/>
-    <p:sldId id="280" r:id="rId7"/>
-    <p:sldId id="281" r:id="rId8"/>
-    <p:sldId id="262" r:id="rId9"/>
-    <p:sldId id="260" r:id="rId10"/>
-    <p:sldId id="261" r:id="rId11"/>
-    <p:sldId id="265" r:id="rId12"/>
-    <p:sldId id="264" r:id="rId13"/>
-    <p:sldId id="263" r:id="rId14"/>
+    <p:sldId id="281" r:id="rId7"/>
+    <p:sldId id="262" r:id="rId8"/>
+    <p:sldId id="260" r:id="rId9"/>
+    <p:sldId id="261" r:id="rId10"/>
+    <p:sldId id="265" r:id="rId11"/>
+    <p:sldId id="264" r:id="rId12"/>
+    <p:sldId id="263" r:id="rId13"/>
+    <p:sldId id="280" r:id="rId14"/>
     <p:sldId id="282" r:id="rId15"/>
     <p:sldId id="283" r:id="rId16"/>
     <p:sldId id="284" r:id="rId17"/>
@@ -1525,7 +1525,7 @@
   </p:clrMapOvr>
   <mc:AlternateContent xmlns:mc="http://schemas.openxmlformats.org/markup-compatibility/2006" xmlns:p159="http://schemas.microsoft.com/office/powerpoint/2015/09/main">
     <mc:Choice Requires="p159">
-      <p:transition xmlns:p14="http://schemas.microsoft.com/office/powerpoint/2010/main" spd="slow" p14:dur="2000">
+      <p:transition spd="slow">
         <p159:morph option="byObject"/>
       </p:transition>
     </mc:Choice>
@@ -1737,7 +1737,7 @@
   </p:clrMapOvr>
   <mc:AlternateContent xmlns:mc="http://schemas.openxmlformats.org/markup-compatibility/2006" xmlns:p159="http://schemas.microsoft.com/office/powerpoint/2015/09/main">
     <mc:Choice Requires="p159">
-      <p:transition xmlns:p14="http://schemas.microsoft.com/office/powerpoint/2010/main" spd="slow" p14:dur="2000">
+      <p:transition spd="slow">
         <p159:morph option="byObject"/>
       </p:transition>
     </mc:Choice>
@@ -1959,7 +1959,7 @@
   </p:clrMapOvr>
   <mc:AlternateContent xmlns:mc="http://schemas.openxmlformats.org/markup-compatibility/2006" xmlns:p159="http://schemas.microsoft.com/office/powerpoint/2015/09/main">
     <mc:Choice Requires="p159">
-      <p:transition xmlns:p14="http://schemas.microsoft.com/office/powerpoint/2010/main" spd="slow" p14:dur="2000">
+      <p:transition spd="slow">
         <p159:morph option="byObject"/>
       </p:transition>
     </mc:Choice>
@@ -2171,7 +2171,7 @@
   </p:clrMapOvr>
   <mc:AlternateContent xmlns:mc="http://schemas.openxmlformats.org/markup-compatibility/2006" xmlns:p159="http://schemas.microsoft.com/office/powerpoint/2015/09/main">
     <mc:Choice Requires="p159">
-      <p:transition xmlns:p14="http://schemas.microsoft.com/office/powerpoint/2010/main" spd="slow" p14:dur="2000">
+      <p:transition spd="slow">
         <p159:morph option="byObject"/>
       </p:transition>
     </mc:Choice>
@@ -2459,7 +2459,7 @@
   </p:clrMapOvr>
   <mc:AlternateContent xmlns:mc="http://schemas.openxmlformats.org/markup-compatibility/2006" xmlns:p159="http://schemas.microsoft.com/office/powerpoint/2015/09/main">
     <mc:Choice Requires="p159">
-      <p:transition xmlns:p14="http://schemas.microsoft.com/office/powerpoint/2010/main" spd="slow" p14:dur="2000">
+      <p:transition spd="slow">
         <p159:morph option="byObject"/>
       </p:transition>
     </mc:Choice>
@@ -2739,7 +2739,7 @@
   </p:clrMapOvr>
   <mc:AlternateContent xmlns:mc="http://schemas.openxmlformats.org/markup-compatibility/2006" xmlns:p159="http://schemas.microsoft.com/office/powerpoint/2015/09/main">
     <mc:Choice Requires="p159">
-      <p:transition xmlns:p14="http://schemas.microsoft.com/office/powerpoint/2010/main" spd="slow" p14:dur="2000">
+      <p:transition spd="slow">
         <p159:morph option="byObject"/>
       </p:transition>
     </mc:Choice>
@@ -3166,7 +3166,7 @@
   </p:clrMapOvr>
   <mc:AlternateContent xmlns:mc="http://schemas.openxmlformats.org/markup-compatibility/2006" xmlns:p159="http://schemas.microsoft.com/office/powerpoint/2015/09/main">
     <mc:Choice Requires="p159">
-      <p:transition xmlns:p14="http://schemas.microsoft.com/office/powerpoint/2010/main" spd="slow" p14:dur="2000">
+      <p:transition spd="slow">
         <p159:morph option="byObject"/>
       </p:transition>
     </mc:Choice>
@@ -3320,7 +3320,7 @@
   </p:clrMapOvr>
   <mc:AlternateContent xmlns:mc="http://schemas.openxmlformats.org/markup-compatibility/2006" xmlns:p159="http://schemas.microsoft.com/office/powerpoint/2015/09/main">
     <mc:Choice Requires="p159">
-      <p:transition xmlns:p14="http://schemas.microsoft.com/office/powerpoint/2010/main" spd="slow" p14:dur="2000">
+      <p:transition spd="slow">
         <p159:morph option="byObject"/>
       </p:transition>
     </mc:Choice>
@@ -3445,7 +3445,7 @@
   </p:clrMapOvr>
   <mc:AlternateContent xmlns:mc="http://schemas.openxmlformats.org/markup-compatibility/2006" xmlns:p159="http://schemas.microsoft.com/office/powerpoint/2015/09/main">
     <mc:Choice Requires="p159">
-      <p:transition xmlns:p14="http://schemas.microsoft.com/office/powerpoint/2010/main" spd="slow" p14:dur="2000">
+      <p:transition spd="slow">
         <p159:morph option="byObject"/>
       </p:transition>
     </mc:Choice>
@@ -3770,7 +3770,7 @@
   </p:clrMapOvr>
   <mc:AlternateContent xmlns:mc="http://schemas.openxmlformats.org/markup-compatibility/2006" xmlns:p159="http://schemas.microsoft.com/office/powerpoint/2015/09/main">
     <mc:Choice Requires="p159">
-      <p:transition xmlns:p14="http://schemas.microsoft.com/office/powerpoint/2010/main" spd="slow" p14:dur="2000">
+      <p:transition spd="slow">
         <p159:morph option="byObject"/>
       </p:transition>
     </mc:Choice>
@@ -4071,7 +4071,7 @@
   </p:clrMapOvr>
   <mc:AlternateContent xmlns:mc="http://schemas.openxmlformats.org/markup-compatibility/2006" xmlns:p159="http://schemas.microsoft.com/office/powerpoint/2015/09/main">
     <mc:Choice Requires="p159">
-      <p:transition xmlns:p14="http://schemas.microsoft.com/office/powerpoint/2010/main" spd="slow" p14:dur="2000">
+      <p:transition spd="slow">
         <p159:morph option="byObject"/>
       </p:transition>
     </mc:Choice>
@@ -4373,7 +4373,7 @@
   </p:sldLayoutIdLst>
   <mc:AlternateContent xmlns:mc="http://schemas.openxmlformats.org/markup-compatibility/2006" xmlns:p159="http://schemas.microsoft.com/office/powerpoint/2015/09/main">
     <mc:Choice Requires="p159">
-      <p:transition xmlns:p14="http://schemas.microsoft.com/office/powerpoint/2010/main" spd="slow" p14:dur="2000">
+      <p:transition spd="slow">
         <p159:morph option="byObject"/>
       </p:transition>
     </mc:Choice>
@@ -4725,7 +4725,7 @@
   </p:clrMapOvr>
   <mc:AlternateContent xmlns:mc="http://schemas.openxmlformats.org/markup-compatibility/2006" xmlns:p159="http://schemas.microsoft.com/office/powerpoint/2015/09/main">
     <mc:Choice Requires="p159">
-      <p:transition xmlns:p14="http://schemas.microsoft.com/office/powerpoint/2010/main" spd="slow" p14:dur="2000">
+      <p:transition spd="slow">
         <p159:morph option="byObject"/>
       </p:transition>
     </mc:Choice>
@@ -4757,10 +4757,10 @@
       </p:grpSpPr>
       <p:pic>
         <p:nvPicPr>
-          <p:cNvPr id="3" name="Graphic 2">
-            <a:extLst>
-              <a:ext uri="{FF2B5EF4-FFF2-40B4-BE49-F238E27FC236}">
-                <a16:creationId xmlns:a16="http://schemas.microsoft.com/office/drawing/2014/main" id="{5104F63A-8305-48CC-A7C8-38D27F499ADB}"/>
+          <p:cNvPr id="4" name="Picture 3">
+            <a:extLst>
+              <a:ext uri="{FF2B5EF4-FFF2-40B4-BE49-F238E27FC236}">
+                <a16:creationId xmlns:a16="http://schemas.microsoft.com/office/drawing/2014/main" id="{50D4D3CB-2C2F-4524-B868-41FAEA9F06E8}"/>
               </a:ext>
             </a:extLst>
           </p:cNvPr>
@@ -4770,229 +4770,147 @@
           <p:nvPr/>
         </p:nvPicPr>
         <p:blipFill>
-          <a:blip r:embed="rId2">
-            <a:extLst>
-              <a:ext uri="{28A0092B-C50C-407E-A947-70E740481C1C}">
-                <a14:useLocalDpi xmlns:a14="http://schemas.microsoft.com/office/drawing/2010/main" val="0"/>
-              </a:ext>
-              <a:ext uri="{96DAC541-7B7A-43D3-8B79-37D633B846F1}">
-                <asvg:svgBlip xmlns:asvg="http://schemas.microsoft.com/office/drawing/2016/SVG/main" r:embed="rId3"/>
-              </a:ext>
-            </a:extLst>
-          </a:blip>
+          <a:blip r:embed="rId2"/>
           <a:stretch>
             <a:fillRect/>
           </a:stretch>
         </p:blipFill>
         <p:spPr>
           <a:xfrm>
-            <a:off x="6955860" y="3300410"/>
-            <a:ext cx="4471895" cy="3357563"/>
+            <a:off x="4014497" y="2219156"/>
+            <a:ext cx="4163006" cy="2419688"/>
           </a:xfrm>
           <a:prstGeom prst="rect">
             <a:avLst/>
           </a:prstGeom>
         </p:spPr>
       </p:pic>
-      <p:pic>
-        <p:nvPicPr>
-          <p:cNvPr id="5" name="Graphic 4">
-            <a:extLst>
-              <a:ext uri="{FF2B5EF4-FFF2-40B4-BE49-F238E27FC236}">
-                <a16:creationId xmlns:a16="http://schemas.microsoft.com/office/drawing/2014/main" id="{B68B9AC6-63AF-4D04-8412-F617E4BD1E25}"/>
-              </a:ext>
-            </a:extLst>
-          </p:cNvPr>
-          <p:cNvPicPr>
-            <a:picLocks noChangeAspect="1"/>
-          </p:cNvPicPr>
+      <p:sp>
+        <p:nvSpPr>
+          <p:cNvPr id="5" name="TextBox 4">
+            <a:extLst>
+              <a:ext uri="{FF2B5EF4-FFF2-40B4-BE49-F238E27FC236}">
+                <a16:creationId xmlns:a16="http://schemas.microsoft.com/office/drawing/2014/main" id="{D514EC3D-B477-4A30-911C-BD0F244670E3}"/>
+              </a:ext>
+            </a:extLst>
+          </p:cNvPr>
+          <p:cNvSpPr txBox="1"/>
           <p:nvPr/>
-        </p:nvPicPr>
-        <p:blipFill>
-          <a:blip r:embed="rId4">
-            <a:extLst>
-              <a:ext uri="{28A0092B-C50C-407E-A947-70E740481C1C}">
-                <a14:useLocalDpi xmlns:a14="http://schemas.microsoft.com/office/drawing/2010/main" val="0"/>
-              </a:ext>
-              <a:ext uri="{96DAC541-7B7A-43D3-8B79-37D633B846F1}">
-                <asvg:svgBlip xmlns:asvg="http://schemas.microsoft.com/office/drawing/2016/SVG/main" r:embed="rId5"/>
-              </a:ext>
-            </a:extLst>
-          </a:blip>
-          <a:stretch>
-            <a:fillRect/>
-          </a:stretch>
-        </p:blipFill>
+        </p:nvSpPr>
         <p:spPr>
           <a:xfrm>
-            <a:off x="915392" y="3300411"/>
-            <a:ext cx="4471895" cy="3357563"/>
+            <a:off x="0" y="0"/>
+            <a:ext cx="2289908" cy="369332"/>
           </a:xfrm>
           <a:prstGeom prst="rect">
             <a:avLst/>
           </a:prstGeom>
+          <a:noFill/>
         </p:spPr>
-      </p:pic>
-      <p:pic>
-        <p:nvPicPr>
-          <p:cNvPr id="7" name="Graphic 6">
-            <a:extLst>
-              <a:ext uri="{FF2B5EF4-FFF2-40B4-BE49-F238E27FC236}">
-                <a16:creationId xmlns:a16="http://schemas.microsoft.com/office/drawing/2014/main" id="{A67BD1E4-1078-48C8-A0CC-A8F92079F4D0}"/>
-              </a:ext>
-            </a:extLst>
-          </p:cNvPr>
-          <p:cNvPicPr>
-            <a:picLocks noChangeAspect="1"/>
-          </p:cNvPicPr>
+        <p:txBody>
+          <a:bodyPr wrap="square" rtlCol="0">
+            <a:spAutoFit/>
+          </a:bodyPr>
+          <a:lstStyle/>
+          <a:p>
+            <a:r>
+              <a:rPr lang="it-IT" u="sng" dirty="0"/>
+              <a:t>MICE Forest</a:t>
+            </a:r>
+            <a:endParaRPr lang="nl-NL" u="sng" dirty="0"/>
+          </a:p>
+        </p:txBody>
+      </p:sp>
+      <p:sp>
+        <p:nvSpPr>
+          <p:cNvPr id="7" name="Arrow: Down 6">
+            <a:extLst>
+              <a:ext uri="{FF2B5EF4-FFF2-40B4-BE49-F238E27FC236}">
+                <a16:creationId xmlns:a16="http://schemas.microsoft.com/office/drawing/2014/main" id="{A2FC79F2-6630-4E33-A4C3-8D9A42B46FEF}"/>
+              </a:ext>
+            </a:extLst>
+          </p:cNvPr>
+          <p:cNvSpPr/>
           <p:nvPr/>
-        </p:nvPicPr>
-        <p:blipFill>
-          <a:blip r:embed="rId6">
-            <a:extLst>
-              <a:ext uri="{28A0092B-C50C-407E-A947-70E740481C1C}">
-                <a14:useLocalDpi xmlns:a14="http://schemas.microsoft.com/office/drawing/2010/main" val="0"/>
-              </a:ext>
-              <a:ext uri="{96DAC541-7B7A-43D3-8B79-37D633B846F1}">
-                <asvg:svgBlip xmlns:asvg="http://schemas.microsoft.com/office/drawing/2016/SVG/main" r:embed="rId7"/>
-              </a:ext>
-            </a:extLst>
-          </a:blip>
-          <a:stretch>
-            <a:fillRect/>
-          </a:stretch>
-        </p:blipFill>
+        </p:nvSpPr>
+        <p:spPr>
+          <a:xfrm rot="4638552">
+            <a:off x="7604369" y="3141785"/>
+            <a:ext cx="140677" cy="1742831"/>
+          </a:xfrm>
+          <a:prstGeom prst="downArrow">
+            <a:avLst/>
+          </a:prstGeom>
+        </p:spPr>
+        <p:style>
+          <a:lnRef idx="0">
+            <a:schemeClr val="accent1"/>
+          </a:lnRef>
+          <a:fillRef idx="3">
+            <a:schemeClr val="accent1"/>
+          </a:fillRef>
+          <a:effectRef idx="3">
+            <a:schemeClr val="accent1"/>
+          </a:effectRef>
+          <a:fontRef idx="minor">
+            <a:schemeClr val="lt1"/>
+          </a:fontRef>
+        </p:style>
+        <p:txBody>
+          <a:bodyPr rtlCol="0" anchor="ctr"/>
+          <a:lstStyle/>
+          <a:p>
+            <a:pPr algn="ctr"/>
+            <a:endParaRPr lang="nl-NL"/>
+          </a:p>
+        </p:txBody>
+      </p:sp>
+      <p:sp>
+        <p:nvSpPr>
+          <p:cNvPr id="8" name="TextBox 7">
+            <a:extLst>
+              <a:ext uri="{FF2B5EF4-FFF2-40B4-BE49-F238E27FC236}">
+                <a16:creationId xmlns:a16="http://schemas.microsoft.com/office/drawing/2014/main" id="{F80A6ACB-2D2C-4E4F-96F1-0D3837C836FC}"/>
+              </a:ext>
+            </a:extLst>
+          </p:cNvPr>
+          <p:cNvSpPr txBox="1"/>
+          <p:nvPr/>
+        </p:nvSpPr>
         <p:spPr>
           <a:xfrm>
-            <a:off x="8416461" y="0"/>
-            <a:ext cx="4471895" cy="3357563"/>
+            <a:off x="8519452" y="3476396"/>
+            <a:ext cx="2360246" cy="646331"/>
           </a:xfrm>
           <a:prstGeom prst="rect">
             <a:avLst/>
           </a:prstGeom>
+          <a:noFill/>
         </p:spPr>
-      </p:pic>
-      <p:pic>
-        <p:nvPicPr>
-          <p:cNvPr id="9" name="Graphic 8">
-            <a:extLst>
-              <a:ext uri="{FF2B5EF4-FFF2-40B4-BE49-F238E27FC236}">
-                <a16:creationId xmlns:a16="http://schemas.microsoft.com/office/drawing/2014/main" id="{9FBB4D53-4F61-4420-B2EA-5DBB2190FBDD}"/>
-              </a:ext>
-            </a:extLst>
-          </p:cNvPr>
-          <p:cNvPicPr>
-            <a:picLocks noChangeAspect="1"/>
-          </p:cNvPicPr>
-          <p:nvPr/>
-        </p:nvPicPr>
-        <p:blipFill>
-          <a:blip r:embed="rId8">
-            <a:extLst>
-              <a:ext uri="{28A0092B-C50C-407E-A947-70E740481C1C}">
-                <a14:useLocalDpi xmlns:a14="http://schemas.microsoft.com/office/drawing/2010/main" val="0"/>
-              </a:ext>
-              <a:ext uri="{96DAC541-7B7A-43D3-8B79-37D633B846F1}">
-                <asvg:svgBlip xmlns:asvg="http://schemas.microsoft.com/office/drawing/2016/SVG/main" r:embed="rId9"/>
-              </a:ext>
-            </a:extLst>
-          </a:blip>
-          <a:stretch>
-            <a:fillRect/>
-          </a:stretch>
-        </p:blipFill>
-        <p:spPr>
-          <a:xfrm>
-            <a:off x="5405166" y="0"/>
-            <a:ext cx="4471895" cy="3357563"/>
-          </a:xfrm>
-          <a:prstGeom prst="rect">
-            <a:avLst/>
-          </a:prstGeom>
-        </p:spPr>
-      </p:pic>
-      <p:pic>
-        <p:nvPicPr>
-          <p:cNvPr id="11" name="Graphic 10">
-            <a:extLst>
-              <a:ext uri="{FF2B5EF4-FFF2-40B4-BE49-F238E27FC236}">
-                <a16:creationId xmlns:a16="http://schemas.microsoft.com/office/drawing/2014/main" id="{9947BBB5-44C5-48CF-969E-441FAF4420ED}"/>
-              </a:ext>
-            </a:extLst>
-          </p:cNvPr>
-          <p:cNvPicPr>
-            <a:picLocks noChangeAspect="1"/>
-          </p:cNvPicPr>
-          <p:nvPr/>
-        </p:nvPicPr>
-        <p:blipFill>
-          <a:blip r:embed="rId10">
-            <a:extLst>
-              <a:ext uri="{28A0092B-C50C-407E-A947-70E740481C1C}">
-                <a14:useLocalDpi xmlns:a14="http://schemas.microsoft.com/office/drawing/2010/main" val="0"/>
-              </a:ext>
-              <a:ext uri="{96DAC541-7B7A-43D3-8B79-37D633B846F1}">
-                <asvg:svgBlip xmlns:asvg="http://schemas.microsoft.com/office/drawing/2016/SVG/main" r:embed="rId11"/>
-              </a:ext>
-            </a:extLst>
-          </a:blip>
-          <a:stretch>
-            <a:fillRect/>
-          </a:stretch>
-        </p:blipFill>
-        <p:spPr>
-          <a:xfrm>
-            <a:off x="2314940" y="0"/>
-            <a:ext cx="4471895" cy="3357563"/>
-          </a:xfrm>
-          <a:prstGeom prst="rect">
-            <a:avLst/>
-          </a:prstGeom>
-        </p:spPr>
-      </p:pic>
-      <p:pic>
-        <p:nvPicPr>
-          <p:cNvPr id="13" name="Graphic 12">
-            <a:extLst>
-              <a:ext uri="{FF2B5EF4-FFF2-40B4-BE49-F238E27FC236}">
-                <a16:creationId xmlns:a16="http://schemas.microsoft.com/office/drawing/2014/main" id="{FC69359F-A5B2-4EC6-BD2E-74DFBA522CFC}"/>
-              </a:ext>
-            </a:extLst>
-          </p:cNvPr>
-          <p:cNvPicPr>
-            <a:picLocks noChangeAspect="1"/>
-          </p:cNvPicPr>
-          <p:nvPr/>
-        </p:nvPicPr>
-        <p:blipFill>
-          <a:blip r:embed="rId12">
-            <a:extLst>
-              <a:ext uri="{28A0092B-C50C-407E-A947-70E740481C1C}">
-                <a14:useLocalDpi xmlns:a14="http://schemas.microsoft.com/office/drawing/2010/main" val="0"/>
-              </a:ext>
-              <a:ext uri="{96DAC541-7B7A-43D3-8B79-37D633B846F1}">
-                <asvg:svgBlip xmlns:asvg="http://schemas.microsoft.com/office/drawing/2016/SVG/main" r:embed="rId13"/>
-              </a:ext>
-            </a:extLst>
-          </a:blip>
-          <a:stretch>
-            <a:fillRect/>
-          </a:stretch>
-        </p:blipFill>
-        <p:spPr>
-          <a:xfrm>
-            <a:off x="-859675" y="-28577"/>
-            <a:ext cx="4471895" cy="3357563"/>
-          </a:xfrm>
-          <a:prstGeom prst="rect">
-            <a:avLst/>
-          </a:prstGeom>
-        </p:spPr>
-      </p:pic>
+        <p:txBody>
+          <a:bodyPr wrap="square" rtlCol="0">
+            <a:spAutoFit/>
+          </a:bodyPr>
+          <a:lstStyle/>
+          <a:p>
+            <a:r>
+              <a:rPr lang="it-IT" dirty="0"/>
+              <a:t>Gradient Boosting</a:t>
+            </a:r>
+          </a:p>
+          <a:p>
+            <a:r>
+              <a:rPr lang="it-IT" dirty="0"/>
+              <a:t>Decision Trees</a:t>
+            </a:r>
+            <a:endParaRPr lang="nl-NL" dirty="0"/>
+          </a:p>
+        </p:txBody>
+      </p:sp>
     </p:spTree>
     <p:extLst>
       <p:ext uri="{BB962C8B-B14F-4D97-AF65-F5344CB8AC3E}">
-        <p14:creationId xmlns:p14="http://schemas.microsoft.com/office/powerpoint/2010/main" val="2926366783"/>
+        <p14:creationId xmlns:p14="http://schemas.microsoft.com/office/powerpoint/2010/main" val="3620443842"/>
       </p:ext>
     </p:extLst>
   </p:cSld>
@@ -5001,7 +4919,7 @@
   </p:clrMapOvr>
   <mc:AlternateContent xmlns:mc="http://schemas.openxmlformats.org/markup-compatibility/2006" xmlns:p159="http://schemas.microsoft.com/office/powerpoint/2015/09/main">
     <mc:Choice Requires="p159">
-      <p:transition xmlns:p14="http://schemas.microsoft.com/office/powerpoint/2010/main" spd="slow" p14:dur="2000">
+      <p:transition spd="slow">
         <p159:morph option="byObject"/>
       </p:transition>
     </mc:Choice>
@@ -5033,10 +4951,10 @@
       </p:grpSpPr>
       <p:pic>
         <p:nvPicPr>
-          <p:cNvPr id="4" name="Picture 3">
-            <a:extLst>
-              <a:ext uri="{FF2B5EF4-FFF2-40B4-BE49-F238E27FC236}">
-                <a16:creationId xmlns:a16="http://schemas.microsoft.com/office/drawing/2014/main" id="{50D4D3CB-2C2F-4524-B868-41FAEA9F06E8}"/>
+          <p:cNvPr id="5" name="Picture 4">
+            <a:extLst>
+              <a:ext uri="{FF2B5EF4-FFF2-40B4-BE49-F238E27FC236}">
+                <a16:creationId xmlns:a16="http://schemas.microsoft.com/office/drawing/2014/main" id="{959EC944-F65A-4355-9EE4-D17542B2E581}"/>
               </a:ext>
             </a:extLst>
           </p:cNvPr>
@@ -5046,15 +4964,21 @@
           <p:nvPr/>
         </p:nvPicPr>
         <p:blipFill>
-          <a:blip r:embed="rId2"/>
+          <a:blip r:embed="rId2">
+            <a:extLst>
+              <a:ext uri="{28A0092B-C50C-407E-A947-70E740481C1C}">
+                <a14:useLocalDpi xmlns:a14="http://schemas.microsoft.com/office/drawing/2010/main" val="0"/>
+              </a:ext>
+            </a:extLst>
+          </a:blip>
           <a:stretch>
             <a:fillRect/>
           </a:stretch>
         </p:blipFill>
         <p:spPr>
           <a:xfrm>
-            <a:off x="4014497" y="2219156"/>
-            <a:ext cx="4163006" cy="2419688"/>
+            <a:off x="0" y="552432"/>
+            <a:ext cx="12192000" cy="5753136"/>
           </a:xfrm>
           <a:prstGeom prst="rect">
             <a:avLst/>
@@ -5063,10 +4987,10 @@
       </p:pic>
       <p:sp>
         <p:nvSpPr>
-          <p:cNvPr id="5" name="TextBox 4">
-            <a:extLst>
-              <a:ext uri="{FF2B5EF4-FFF2-40B4-BE49-F238E27FC236}">
-                <a16:creationId xmlns:a16="http://schemas.microsoft.com/office/drawing/2014/main" id="{D514EC3D-B477-4A30-911C-BD0F244670E3}"/>
+          <p:cNvPr id="6" name="TextBox 5">
+            <a:extLst>
+              <a:ext uri="{FF2B5EF4-FFF2-40B4-BE49-F238E27FC236}">
+                <a16:creationId xmlns:a16="http://schemas.microsoft.com/office/drawing/2014/main" id="{49B55110-826E-47CF-A5A8-A85A55A8AEE0}"/>
               </a:ext>
             </a:extLst>
           </p:cNvPr>
@@ -5075,8 +4999,8 @@
         </p:nvSpPr>
         <p:spPr>
           <a:xfrm>
-            <a:off x="0" y="0"/>
-            <a:ext cx="2289908" cy="369332"/>
+            <a:off x="0" y="-5807"/>
+            <a:ext cx="2524369" cy="369332"/>
           </a:xfrm>
           <a:prstGeom prst="rect">
             <a:avLst/>
@@ -5091,102 +5015,16 @@
           <a:p>
             <a:r>
               <a:rPr lang="it-IT" u="sng" dirty="0"/>
-              <a:t>MICE Forest</a:t>
+              <a:t>Imputed Values</a:t>
             </a:r>
             <a:endParaRPr lang="nl-NL" u="sng" dirty="0"/>
-          </a:p>
-        </p:txBody>
-      </p:sp>
-      <p:sp>
-        <p:nvSpPr>
-          <p:cNvPr id="7" name="Arrow: Down 6">
-            <a:extLst>
-              <a:ext uri="{FF2B5EF4-FFF2-40B4-BE49-F238E27FC236}">
-                <a16:creationId xmlns:a16="http://schemas.microsoft.com/office/drawing/2014/main" id="{A2FC79F2-6630-4E33-A4C3-8D9A42B46FEF}"/>
-              </a:ext>
-            </a:extLst>
-          </p:cNvPr>
-          <p:cNvSpPr/>
-          <p:nvPr/>
-        </p:nvSpPr>
-        <p:spPr>
-          <a:xfrm rot="4638552">
-            <a:off x="7604369" y="3141785"/>
-            <a:ext cx="140677" cy="1742831"/>
-          </a:xfrm>
-          <a:prstGeom prst="downArrow">
-            <a:avLst/>
-          </a:prstGeom>
-        </p:spPr>
-        <p:style>
-          <a:lnRef idx="0">
-            <a:schemeClr val="accent1"/>
-          </a:lnRef>
-          <a:fillRef idx="3">
-            <a:schemeClr val="accent1"/>
-          </a:fillRef>
-          <a:effectRef idx="3">
-            <a:schemeClr val="accent1"/>
-          </a:effectRef>
-          <a:fontRef idx="minor">
-            <a:schemeClr val="lt1"/>
-          </a:fontRef>
-        </p:style>
-        <p:txBody>
-          <a:bodyPr rtlCol="0" anchor="ctr"/>
-          <a:lstStyle/>
-          <a:p>
-            <a:pPr algn="ctr"/>
-            <a:endParaRPr lang="nl-NL"/>
-          </a:p>
-        </p:txBody>
-      </p:sp>
-      <p:sp>
-        <p:nvSpPr>
-          <p:cNvPr id="8" name="TextBox 7">
-            <a:extLst>
-              <a:ext uri="{FF2B5EF4-FFF2-40B4-BE49-F238E27FC236}">
-                <a16:creationId xmlns:a16="http://schemas.microsoft.com/office/drawing/2014/main" id="{F80A6ACB-2D2C-4E4F-96F1-0D3837C836FC}"/>
-              </a:ext>
-            </a:extLst>
-          </p:cNvPr>
-          <p:cNvSpPr txBox="1"/>
-          <p:nvPr/>
-        </p:nvSpPr>
-        <p:spPr>
-          <a:xfrm>
-            <a:off x="8519452" y="3476396"/>
-            <a:ext cx="2360246" cy="646331"/>
-          </a:xfrm>
-          <a:prstGeom prst="rect">
-            <a:avLst/>
-          </a:prstGeom>
-          <a:noFill/>
-        </p:spPr>
-        <p:txBody>
-          <a:bodyPr wrap="square" rtlCol="0">
-            <a:spAutoFit/>
-          </a:bodyPr>
-          <a:lstStyle/>
-          <a:p>
-            <a:r>
-              <a:rPr lang="it-IT" dirty="0"/>
-              <a:t>Gradient Boosting</a:t>
-            </a:r>
-          </a:p>
-          <a:p>
-            <a:r>
-              <a:rPr lang="it-IT" dirty="0"/>
-              <a:t>Decision Trees</a:t>
-            </a:r>
-            <a:endParaRPr lang="nl-NL" dirty="0"/>
           </a:p>
         </p:txBody>
       </p:sp>
     </p:spTree>
     <p:extLst>
       <p:ext uri="{BB962C8B-B14F-4D97-AF65-F5344CB8AC3E}">
-        <p14:creationId xmlns:p14="http://schemas.microsoft.com/office/powerpoint/2010/main" val="3620443842"/>
+        <p14:creationId xmlns:p14="http://schemas.microsoft.com/office/powerpoint/2010/main" val="1759352546"/>
       </p:ext>
     </p:extLst>
   </p:cSld>
@@ -5195,7 +5033,7 @@
   </p:clrMapOvr>
   <mc:AlternateContent xmlns:mc="http://schemas.openxmlformats.org/markup-compatibility/2006" xmlns:p159="http://schemas.microsoft.com/office/powerpoint/2015/09/main">
     <mc:Choice Requires="p159">
-      <p:transition xmlns:p14="http://schemas.microsoft.com/office/powerpoint/2010/main" spd="slow" p14:dur="2000">
+      <p:transition spd="slow">
         <p159:morph option="byObject"/>
       </p:transition>
     </mc:Choice>
@@ -5230,7 +5068,7 @@
           <p:cNvPr id="5" name="Picture 4">
             <a:extLst>
               <a:ext uri="{FF2B5EF4-FFF2-40B4-BE49-F238E27FC236}">
-                <a16:creationId xmlns:a16="http://schemas.microsoft.com/office/drawing/2014/main" id="{959EC944-F65A-4355-9EE4-D17542B2E581}"/>
+                <a16:creationId xmlns:a16="http://schemas.microsoft.com/office/drawing/2014/main" id="{70962B23-E15F-4BCF-9983-5A40DD11EB79}"/>
               </a:ext>
             </a:extLst>
           </p:cNvPr>
@@ -5253,8 +5091,8 @@
         </p:blipFill>
         <p:spPr>
           <a:xfrm>
-            <a:off x="0" y="552432"/>
-            <a:ext cx="12192000" cy="5753136"/>
+            <a:off x="1810565" y="214923"/>
+            <a:ext cx="8570870" cy="6428153"/>
           </a:xfrm>
           <a:prstGeom prst="rect">
             <a:avLst/>
@@ -5266,7 +5104,7 @@
           <p:cNvPr id="6" name="TextBox 5">
             <a:extLst>
               <a:ext uri="{FF2B5EF4-FFF2-40B4-BE49-F238E27FC236}">
-                <a16:creationId xmlns:a16="http://schemas.microsoft.com/office/drawing/2014/main" id="{49B55110-826E-47CF-A5A8-A85A55A8AEE0}"/>
+                <a16:creationId xmlns:a16="http://schemas.microsoft.com/office/drawing/2014/main" id="{4BE0656D-44CA-4A22-BC1D-23F23E963B16}"/>
               </a:ext>
             </a:extLst>
           </p:cNvPr>
@@ -5275,8 +5113,8 @@
         </p:nvSpPr>
         <p:spPr>
           <a:xfrm>
-            <a:off x="0" y="-5807"/>
-            <a:ext cx="2524369" cy="369332"/>
+            <a:off x="0" y="0"/>
+            <a:ext cx="2289908" cy="369332"/>
           </a:xfrm>
           <a:prstGeom prst="rect">
             <a:avLst/>
@@ -5291,7 +5129,7 @@
           <a:p>
             <a:r>
               <a:rPr lang="it-IT" u="sng" dirty="0"/>
-              <a:t>Imputed Values</a:t>
+              <a:t>MICE Forest</a:t>
             </a:r>
             <a:endParaRPr lang="nl-NL" u="sng" dirty="0"/>
           </a:p>
@@ -5300,7 +5138,7 @@
     </p:spTree>
     <p:extLst>
       <p:ext uri="{BB962C8B-B14F-4D97-AF65-F5344CB8AC3E}">
-        <p14:creationId xmlns:p14="http://schemas.microsoft.com/office/powerpoint/2010/main" val="1759352546"/>
+        <p14:creationId xmlns:p14="http://schemas.microsoft.com/office/powerpoint/2010/main" val="1608275626"/>
       </p:ext>
     </p:extLst>
   </p:cSld>
@@ -5309,7 +5147,7 @@
   </p:clrMapOvr>
   <mc:AlternateContent xmlns:mc="http://schemas.openxmlformats.org/markup-compatibility/2006" xmlns:p159="http://schemas.microsoft.com/office/powerpoint/2015/09/main">
     <mc:Choice Requires="p159">
-      <p:transition xmlns:p14="http://schemas.microsoft.com/office/powerpoint/2010/main" spd="slow" p14:dur="2000">
+      <p:transition spd="slow">
         <p159:morph option="byObject"/>
       </p:transition>
     </mc:Choice>
@@ -5339,48 +5177,12 @@
           <a:chExt cx="0" cy="0"/>
         </a:xfrm>
       </p:grpSpPr>
-      <p:pic>
-        <p:nvPicPr>
-          <p:cNvPr id="5" name="Picture 4">
-            <a:extLst>
-              <a:ext uri="{FF2B5EF4-FFF2-40B4-BE49-F238E27FC236}">
-                <a16:creationId xmlns:a16="http://schemas.microsoft.com/office/drawing/2014/main" id="{70962B23-E15F-4BCF-9983-5A40DD11EB79}"/>
-              </a:ext>
-            </a:extLst>
-          </p:cNvPr>
-          <p:cNvPicPr>
-            <a:picLocks noChangeAspect="1"/>
-          </p:cNvPicPr>
-          <p:nvPr/>
-        </p:nvPicPr>
-        <p:blipFill>
-          <a:blip r:embed="rId2">
-            <a:extLst>
-              <a:ext uri="{28A0092B-C50C-407E-A947-70E740481C1C}">
-                <a14:useLocalDpi xmlns:a14="http://schemas.microsoft.com/office/drawing/2010/main" val="0"/>
-              </a:ext>
-            </a:extLst>
-          </a:blip>
-          <a:stretch>
-            <a:fillRect/>
-          </a:stretch>
-        </p:blipFill>
-        <p:spPr>
-          <a:xfrm>
-            <a:off x="1810565" y="214923"/>
-            <a:ext cx="8570870" cy="6428153"/>
-          </a:xfrm>
-          <a:prstGeom prst="rect">
-            <a:avLst/>
-          </a:prstGeom>
-        </p:spPr>
-      </p:pic>
       <p:sp>
         <p:nvSpPr>
-          <p:cNvPr id="6" name="TextBox 5">
-            <a:extLst>
-              <a:ext uri="{FF2B5EF4-FFF2-40B4-BE49-F238E27FC236}">
-                <a16:creationId xmlns:a16="http://schemas.microsoft.com/office/drawing/2014/main" id="{4BE0656D-44CA-4A22-BC1D-23F23E963B16}"/>
+          <p:cNvPr id="4" name="TextBox 3">
+            <a:extLst>
+              <a:ext uri="{FF2B5EF4-FFF2-40B4-BE49-F238E27FC236}">
+                <a16:creationId xmlns:a16="http://schemas.microsoft.com/office/drawing/2014/main" id="{99122CDA-8054-4F30-AA24-7864527ED42D}"/>
               </a:ext>
             </a:extLst>
           </p:cNvPr>
@@ -5390,7 +5192,7 @@
         <p:spPr>
           <a:xfrm>
             <a:off x="0" y="0"/>
-            <a:ext cx="2289908" cy="369332"/>
+            <a:ext cx="4708358" cy="369332"/>
           </a:xfrm>
           <a:prstGeom prst="rect">
             <a:avLst/>
@@ -5405,16 +5207,52 @@
           <a:p>
             <a:r>
               <a:rPr lang="it-IT" u="sng" dirty="0"/>
-              <a:t>MICE Forest</a:t>
+              <a:t>Original Chemical Subs distributions</a:t>
             </a:r>
             <a:endParaRPr lang="nl-NL" u="sng" dirty="0"/>
           </a:p>
         </p:txBody>
       </p:sp>
+      <p:pic>
+        <p:nvPicPr>
+          <p:cNvPr id="6" name="Picture 5">
+            <a:extLst>
+              <a:ext uri="{FF2B5EF4-FFF2-40B4-BE49-F238E27FC236}">
+                <a16:creationId xmlns:a16="http://schemas.microsoft.com/office/drawing/2014/main" id="{62B614DA-B9E5-44DA-9D9F-C33D5F9B5334}"/>
+              </a:ext>
+            </a:extLst>
+          </p:cNvPr>
+          <p:cNvPicPr>
+            <a:picLocks noChangeAspect="1"/>
+          </p:cNvPicPr>
+          <p:nvPr/>
+        </p:nvPicPr>
+        <p:blipFill>
+          <a:blip r:embed="rId2">
+            <a:extLst>
+              <a:ext uri="{28A0092B-C50C-407E-A947-70E740481C1C}">
+                <a14:useLocalDpi xmlns:a14="http://schemas.microsoft.com/office/drawing/2010/main" val="0"/>
+              </a:ext>
+            </a:extLst>
+          </a:blip>
+          <a:stretch>
+            <a:fillRect/>
+          </a:stretch>
+        </p:blipFill>
+        <p:spPr>
+          <a:xfrm>
+            <a:off x="152400" y="538130"/>
+            <a:ext cx="11887200" cy="5958202"/>
+          </a:xfrm>
+          <a:prstGeom prst="rect">
+            <a:avLst/>
+          </a:prstGeom>
+        </p:spPr>
+      </p:pic>
     </p:spTree>
     <p:extLst>
       <p:ext uri="{BB962C8B-B14F-4D97-AF65-F5344CB8AC3E}">
-        <p14:creationId xmlns:p14="http://schemas.microsoft.com/office/powerpoint/2010/main" val="1608275626"/>
+        <p14:creationId xmlns:p14="http://schemas.microsoft.com/office/powerpoint/2010/main" val="1013586166"/>
       </p:ext>
     </p:extLst>
   </p:cSld>
@@ -5423,7 +5261,7 @@
   </p:clrMapOvr>
   <mc:AlternateContent xmlns:mc="http://schemas.openxmlformats.org/markup-compatibility/2006" xmlns:p159="http://schemas.microsoft.com/office/powerpoint/2015/09/main">
     <mc:Choice Requires="p159">
-      <p:transition xmlns:p14="http://schemas.microsoft.com/office/powerpoint/2010/main" spd="slow" p14:dur="2000">
+      <p:transition spd="slow">
         <p159:morph option="byObject"/>
       </p:transition>
     </mc:Choice>
@@ -5537,7 +5375,7 @@
   </p:clrMapOvr>
   <mc:AlternateContent xmlns:mc="http://schemas.openxmlformats.org/markup-compatibility/2006" xmlns:p159="http://schemas.microsoft.com/office/powerpoint/2015/09/main">
     <mc:Choice Requires="p159">
-      <p:transition xmlns:p14="http://schemas.microsoft.com/office/powerpoint/2010/main" spd="slow" p14:dur="2000">
+      <p:transition spd="slow">
         <p159:morph option="byObject"/>
       </p:transition>
     </mc:Choice>
@@ -5761,7 +5599,7 @@
   </p:clrMapOvr>
   <mc:AlternateContent xmlns:mc="http://schemas.openxmlformats.org/markup-compatibility/2006" xmlns:p159="http://schemas.microsoft.com/office/powerpoint/2015/09/main">
     <mc:Choice Requires="p159">
-      <p:transition xmlns:p14="http://schemas.microsoft.com/office/powerpoint/2010/main" spd="slow" p14:dur="2000">
+      <p:transition spd="slow">
         <p159:morph option="byObject"/>
       </p:transition>
     </mc:Choice>
@@ -5803,7 +5641,7 @@
   </p:clrMapOvr>
   <mc:AlternateContent xmlns:mc="http://schemas.openxmlformats.org/markup-compatibility/2006" xmlns:p159="http://schemas.microsoft.com/office/powerpoint/2015/09/main">
     <mc:Choice Requires="p159">
-      <p:transition xmlns:p14="http://schemas.microsoft.com/office/powerpoint/2010/main" spd="slow" p14:dur="2000">
+      <p:transition spd="slow">
         <p159:morph option="byObject"/>
       </p:transition>
     </mc:Choice>
@@ -5874,7 +5712,7 @@
   </p:clrMapOvr>
   <mc:AlternateContent xmlns:mc="http://schemas.openxmlformats.org/markup-compatibility/2006" xmlns:p159="http://schemas.microsoft.com/office/powerpoint/2015/09/main">
     <mc:Choice Requires="p159">
-      <p:transition xmlns:p14="http://schemas.microsoft.com/office/powerpoint/2010/main" spd="slow" p14:dur="2000">
+      <p:transition spd="slow">
         <p159:morph option="byObject"/>
       </p:transition>
     </mc:Choice>
@@ -5916,7 +5754,7 @@
   </p:clrMapOvr>
   <mc:AlternateContent xmlns:mc="http://schemas.openxmlformats.org/markup-compatibility/2006" xmlns:p159="http://schemas.microsoft.com/office/powerpoint/2015/09/main">
     <mc:Choice Requires="p159">
-      <p:transition xmlns:p14="http://schemas.microsoft.com/office/powerpoint/2010/main" spd="slow" p14:dur="2000">
+      <p:transition spd="slow">
         <p159:morph option="byObject"/>
       </p:transition>
     </mc:Choice>
@@ -6012,7 +5850,7 @@
   </p:clrMapOvr>
   <mc:AlternateContent xmlns:mc="http://schemas.openxmlformats.org/markup-compatibility/2006" xmlns:p159="http://schemas.microsoft.com/office/powerpoint/2015/09/main">
     <mc:Choice Requires="p159">
-      <p:transition xmlns:p14="http://schemas.microsoft.com/office/powerpoint/2010/main" spd="slow" p14:dur="2000">
+      <p:transition spd="slow">
         <p159:morph option="byObject"/>
       </p:transition>
     </mc:Choice>
@@ -6166,7 +6004,7 @@
   </p:clrMapOvr>
   <mc:AlternateContent xmlns:mc="http://schemas.openxmlformats.org/markup-compatibility/2006" xmlns:p159="http://schemas.microsoft.com/office/powerpoint/2015/09/main">
     <mc:Choice Requires="p159">
-      <p:transition xmlns:p14="http://schemas.microsoft.com/office/powerpoint/2010/main" spd="slow" p14:dur="2000">
+      <p:transition spd="slow">
         <p159:morph option="byObject"/>
       </p:transition>
     </mc:Choice>
@@ -6208,7 +6046,7 @@
   </p:clrMapOvr>
   <mc:AlternateContent xmlns:mc="http://schemas.openxmlformats.org/markup-compatibility/2006" xmlns:p159="http://schemas.microsoft.com/office/powerpoint/2015/09/main">
     <mc:Choice Requires="p159">
-      <p:transition xmlns:p14="http://schemas.microsoft.com/office/powerpoint/2010/main" spd="slow" p14:dur="2000">
+      <p:transition spd="slow">
         <p159:morph option="byObject"/>
       </p:transition>
     </mc:Choice>
@@ -6304,7 +6142,7 @@
   </p:clrMapOvr>
   <mc:AlternateContent xmlns:mc="http://schemas.openxmlformats.org/markup-compatibility/2006" xmlns:p159="http://schemas.microsoft.com/office/powerpoint/2015/09/main">
     <mc:Choice Requires="p159">
-      <p:transition xmlns:p14="http://schemas.microsoft.com/office/powerpoint/2010/main" spd="slow" p14:dur="2000">
+      <p:transition spd="slow">
         <p159:morph option="byObject"/>
       </p:transition>
     </mc:Choice>
@@ -7229,7 +7067,7 @@
   </p:clrMapOvr>
   <mc:AlternateContent xmlns:mc="http://schemas.openxmlformats.org/markup-compatibility/2006" xmlns:p159="http://schemas.microsoft.com/office/powerpoint/2015/09/main">
     <mc:Choice Requires="p159">
-      <p:transition xmlns:p14="http://schemas.microsoft.com/office/powerpoint/2010/main" spd="slow" p14:dur="2000">
+      <p:transition spd="slow">
         <p159:morph option="byObject"/>
       </p:transition>
     </mc:Choice>
@@ -7410,7 +7248,7 @@
   </p:clrMapOvr>
   <mc:AlternateContent xmlns:mc="http://schemas.openxmlformats.org/markup-compatibility/2006" xmlns:p159="http://schemas.microsoft.com/office/powerpoint/2015/09/main">
     <mc:Choice Requires="p159">
-      <p:transition xmlns:p14="http://schemas.microsoft.com/office/powerpoint/2010/main" spd="slow" p14:dur="2000">
+      <p:transition spd="slow">
         <p159:morph option="byObject"/>
       </p:transition>
     </mc:Choice>
@@ -7487,7 +7325,7 @@
   </p:clrMapOvr>
   <mc:AlternateContent xmlns:mc="http://schemas.openxmlformats.org/markup-compatibility/2006" xmlns:p159="http://schemas.microsoft.com/office/powerpoint/2015/09/main">
     <mc:Choice Requires="p159">
-      <p:transition xmlns:p14="http://schemas.microsoft.com/office/powerpoint/2010/main" spd="slow" p14:dur="2000">
+      <p:transition spd="slow">
         <p159:morph option="byObject"/>
       </p:transition>
     </mc:Choice>
@@ -7838,7 +7676,7 @@
   </p:clrMapOvr>
   <mc:AlternateContent xmlns:mc="http://schemas.openxmlformats.org/markup-compatibility/2006" xmlns:p159="http://schemas.microsoft.com/office/powerpoint/2015/09/main">
     <mc:Choice Requires="p159">
-      <p:transition xmlns:p14="http://schemas.microsoft.com/office/powerpoint/2010/main" spd="slow" p14:dur="2000">
+      <p:transition spd="slow">
         <p159:morph option="byObject"/>
       </p:transition>
     </mc:Choice>
@@ -8207,7 +8045,7 @@
   </p:clrMapOvr>
   <mc:AlternateContent xmlns:mc="http://schemas.openxmlformats.org/markup-compatibility/2006" xmlns:p159="http://schemas.microsoft.com/office/powerpoint/2015/09/main">
     <mc:Choice Requires="p159">
-      <p:transition xmlns:p14="http://schemas.microsoft.com/office/powerpoint/2010/main" spd="slow" p14:dur="2000">
+      <p:transition spd="slow">
         <p159:morph option="byObject"/>
       </p:transition>
     </mc:Choice>
@@ -8699,7 +8537,7 @@
   </p:clrMapOvr>
   <mc:AlternateContent xmlns:mc="http://schemas.openxmlformats.org/markup-compatibility/2006" xmlns:p159="http://schemas.microsoft.com/office/powerpoint/2015/09/main">
     <mc:Choice Requires="p159">
-      <p:transition xmlns:p14="http://schemas.microsoft.com/office/powerpoint/2010/main" spd="slow" p14:dur="2000">
+      <p:transition spd="slow">
         <p159:morph option="byObject"/>
       </p:transition>
     </mc:Choice>
@@ -8909,7 +8747,7 @@
   </p:clrMapOvr>
   <mc:AlternateContent xmlns:mc="http://schemas.openxmlformats.org/markup-compatibility/2006" xmlns:p159="http://schemas.microsoft.com/office/powerpoint/2015/09/main">
     <mc:Choice Requires="p159">
-      <p:transition xmlns:p14="http://schemas.microsoft.com/office/powerpoint/2010/main" spd="slow" p14:dur="2000">
+      <p:transition spd="slow">
         <p159:morph option="byObject"/>
       </p:transition>
     </mc:Choice>
@@ -8980,7 +8818,7 @@
   </p:clrMapOvr>
   <mc:AlternateContent xmlns:mc="http://schemas.openxmlformats.org/markup-compatibility/2006" xmlns:p159="http://schemas.microsoft.com/office/powerpoint/2015/09/main">
     <mc:Choice Requires="p159">
-      <p:transition xmlns:p14="http://schemas.microsoft.com/office/powerpoint/2010/main" spd="slow" p14:dur="2000">
+      <p:transition spd="slow">
         <p159:morph option="byObject"/>
       </p:transition>
     </mc:Choice>
@@ -9391,7 +9229,7 @@
   </p:clrMapOvr>
   <mc:AlternateContent xmlns:mc="http://schemas.openxmlformats.org/markup-compatibility/2006" xmlns:p159="http://schemas.microsoft.com/office/powerpoint/2015/09/main">
     <mc:Choice Requires="p159">
-      <p:transition xmlns:p14="http://schemas.microsoft.com/office/powerpoint/2010/main" spd="slow" p14:dur="2000">
+      <p:transition spd="slow">
         <p159:morph option="byObject"/>
       </p:transition>
     </mc:Choice>
@@ -9462,7 +9300,7 @@
   </p:clrMapOvr>
   <mc:AlternateContent xmlns:mc="http://schemas.openxmlformats.org/markup-compatibility/2006" xmlns:p159="http://schemas.microsoft.com/office/powerpoint/2015/09/main">
     <mc:Choice Requires="p159">
-      <p:transition xmlns:p14="http://schemas.microsoft.com/office/powerpoint/2010/main" spd="slow" p14:dur="2000">
+      <p:transition spd="slow">
         <p159:morph option="byObject"/>
       </p:transition>
     </mc:Choice>
@@ -9494,10 +9332,10 @@
       </p:grpSpPr>
       <p:sp>
         <p:nvSpPr>
-          <p:cNvPr id="4" name="TextBox 3">
-            <a:extLst>
-              <a:ext uri="{FF2B5EF4-FFF2-40B4-BE49-F238E27FC236}">
-                <a16:creationId xmlns:a16="http://schemas.microsoft.com/office/drawing/2014/main" id="{99122CDA-8054-4F30-AA24-7864527ED42D}"/>
+          <p:cNvPr id="2" name="TextBox 1">
+            <a:extLst>
+              <a:ext uri="{FF2B5EF4-FFF2-40B4-BE49-F238E27FC236}">
+                <a16:creationId xmlns:a16="http://schemas.microsoft.com/office/drawing/2014/main" id="{A60B4FD1-F66A-46C8-A96B-C6DD32132922}"/>
               </a:ext>
             </a:extLst>
           </p:cNvPr>
@@ -9522,120 +9360,6 @@
           <a:p>
             <a:r>
               <a:rPr lang="it-IT" u="sng" dirty="0"/>
-              <a:t>Original Chemical Subs distributions</a:t>
-            </a:r>
-            <a:endParaRPr lang="nl-NL" u="sng" dirty="0"/>
-          </a:p>
-        </p:txBody>
-      </p:sp>
-      <p:pic>
-        <p:nvPicPr>
-          <p:cNvPr id="6" name="Picture 5">
-            <a:extLst>
-              <a:ext uri="{FF2B5EF4-FFF2-40B4-BE49-F238E27FC236}">
-                <a16:creationId xmlns:a16="http://schemas.microsoft.com/office/drawing/2014/main" id="{62B614DA-B9E5-44DA-9D9F-C33D5F9B5334}"/>
-              </a:ext>
-            </a:extLst>
-          </p:cNvPr>
-          <p:cNvPicPr>
-            <a:picLocks noChangeAspect="1"/>
-          </p:cNvPicPr>
-          <p:nvPr/>
-        </p:nvPicPr>
-        <p:blipFill>
-          <a:blip r:embed="rId2">
-            <a:extLst>
-              <a:ext uri="{28A0092B-C50C-407E-A947-70E740481C1C}">
-                <a14:useLocalDpi xmlns:a14="http://schemas.microsoft.com/office/drawing/2010/main" val="0"/>
-              </a:ext>
-            </a:extLst>
-          </a:blip>
-          <a:stretch>
-            <a:fillRect/>
-          </a:stretch>
-        </p:blipFill>
-        <p:spPr>
-          <a:xfrm>
-            <a:off x="152400" y="538130"/>
-            <a:ext cx="11887200" cy="5958202"/>
-          </a:xfrm>
-          <a:prstGeom prst="rect">
-            <a:avLst/>
-          </a:prstGeom>
-        </p:spPr>
-      </p:pic>
-    </p:spTree>
-    <p:extLst>
-      <p:ext uri="{BB962C8B-B14F-4D97-AF65-F5344CB8AC3E}">
-        <p14:creationId xmlns:p14="http://schemas.microsoft.com/office/powerpoint/2010/main" val="1013586166"/>
-      </p:ext>
-    </p:extLst>
-  </p:cSld>
-  <p:clrMapOvr>
-    <a:masterClrMapping/>
-  </p:clrMapOvr>
-  <mc:AlternateContent xmlns:mc="http://schemas.openxmlformats.org/markup-compatibility/2006" xmlns:p159="http://schemas.microsoft.com/office/powerpoint/2015/09/main">
-    <mc:Choice Requires="p159">
-      <p:transition xmlns:p14="http://schemas.microsoft.com/office/powerpoint/2010/main" spd="slow" p14:dur="2000">
-        <p159:morph option="byObject"/>
-      </p:transition>
-    </mc:Choice>
-    <mc:Fallback xmlns="">
-      <p:transition spd="slow">
-        <p:fade/>
-      </p:transition>
-    </mc:Fallback>
-  </mc:AlternateContent>
-</p:sld>
-</file>
-
-<file path=ppt/slides/slide7.xml><?xml version="1.0" encoding="utf-8"?>
-<p:sld xmlns:a="http://schemas.openxmlformats.org/drawingml/2006/main" xmlns:r="http://schemas.openxmlformats.org/officeDocument/2006/relationships" xmlns:p="http://schemas.openxmlformats.org/presentationml/2006/main">
-  <p:cSld>
-    <p:spTree>
-      <p:nvGrpSpPr>
-        <p:cNvPr id="1" name=""/>
-        <p:cNvGrpSpPr/>
-        <p:nvPr/>
-      </p:nvGrpSpPr>
-      <p:grpSpPr>
-        <a:xfrm>
-          <a:off x="0" y="0"/>
-          <a:ext cx="0" cy="0"/>
-          <a:chOff x="0" y="0"/>
-          <a:chExt cx="0" cy="0"/>
-        </a:xfrm>
-      </p:grpSpPr>
-      <p:sp>
-        <p:nvSpPr>
-          <p:cNvPr id="2" name="TextBox 1">
-            <a:extLst>
-              <a:ext uri="{FF2B5EF4-FFF2-40B4-BE49-F238E27FC236}">
-                <a16:creationId xmlns:a16="http://schemas.microsoft.com/office/drawing/2014/main" id="{A60B4FD1-F66A-46C8-A96B-C6DD32132922}"/>
-              </a:ext>
-            </a:extLst>
-          </p:cNvPr>
-          <p:cNvSpPr txBox="1"/>
-          <p:nvPr/>
-        </p:nvSpPr>
-        <p:spPr>
-          <a:xfrm>
-            <a:off x="0" y="0"/>
-            <a:ext cx="4708358" cy="369332"/>
-          </a:xfrm>
-          <a:prstGeom prst="rect">
-            <a:avLst/>
-          </a:prstGeom>
-          <a:noFill/>
-        </p:spPr>
-        <p:txBody>
-          <a:bodyPr wrap="square" rtlCol="0">
-            <a:spAutoFit/>
-          </a:bodyPr>
-          <a:lstStyle/>
-          <a:p>
-            <a:r>
-              <a:rPr lang="it-IT" u="sng" dirty="0"/>
               <a:t>Instrumental Resolutions</a:t>
             </a:r>
             <a:endParaRPr lang="nl-NL" u="sng" dirty="0"/>
@@ -9657,7 +9381,7 @@
           <p:nvPr>
             <p:extLst>
               <p:ext uri="{D42A27DB-BD31-4B8C-83A1-F6EECF244321}">
-                <p14:modId xmlns:p14="http://schemas.microsoft.com/office/powerpoint/2010/main" val="4286925606"/>
+                <p14:modId xmlns:p14="http://schemas.microsoft.com/office/powerpoint/2010/main" val="436792572"/>
               </p:ext>
             </p:extLst>
           </p:nvPr>
@@ -10291,12 +10015,12 @@
                     <a:p>
                       <a:pPr algn="ctr" fontAlgn="ctr"/>
                       <a:r>
-                        <a:rPr lang="nl-NL" sz="1600" u="none" strike="noStrike">
+                        <a:rPr lang="nl-NL" sz="1600" u="none" strike="noStrike" dirty="0">
                           <a:effectLst/>
                         </a:rPr>
-                        <a:t>195</a:t>
+                        <a:t>195*</a:t>
                       </a:r>
-                      <a:endParaRPr lang="nl-NL" sz="1600" b="0" i="0" u="none" strike="noStrike">
+                      <a:endParaRPr lang="nl-NL" sz="1600" b="0" i="0" u="none" strike="noStrike" dirty="0">
                         <a:solidFill>
                           <a:srgbClr val="000000"/>
                         </a:solidFill>
@@ -11315,7 +11039,12 @@
             <p:ph type="ftr" sz="quarter" idx="11"/>
           </p:nvPr>
         </p:nvSpPr>
-        <p:spPr/>
+        <p:spPr>
+          <a:xfrm>
+            <a:off x="4038600" y="6225545"/>
+            <a:ext cx="4114800" cy="365125"/>
+          </a:xfrm>
+        </p:spPr>
         <p:txBody>
           <a:bodyPr/>
           <a:lstStyle/>
@@ -11324,6 +11053,49 @@
               <a:rPr lang="nl-NL"/>
               <a:t>Ref: https://www.umcutrecht.nl/bepalingenwijzer</a:t>
             </a:r>
+          </a:p>
+        </p:txBody>
+      </p:sp>
+      <p:sp>
+        <p:nvSpPr>
+          <p:cNvPr id="4" name="TextBox 3">
+            <a:extLst>
+              <a:ext uri="{FF2B5EF4-FFF2-40B4-BE49-F238E27FC236}">
+                <a16:creationId xmlns:a16="http://schemas.microsoft.com/office/drawing/2014/main" id="{06F0FF0B-34D3-4B7E-B257-2C2107C39FA2}"/>
+              </a:ext>
+            </a:extLst>
+          </p:cNvPr>
+          <p:cNvSpPr txBox="1"/>
+          <p:nvPr/>
+        </p:nvSpPr>
+        <p:spPr>
+          <a:xfrm>
+            <a:off x="5081336" y="6590670"/>
+            <a:ext cx="1788695" cy="261610"/>
+          </a:xfrm>
+          <a:prstGeom prst="rect">
+            <a:avLst/>
+          </a:prstGeom>
+          <a:noFill/>
+        </p:spPr>
+        <p:txBody>
+          <a:bodyPr wrap="square" rtlCol="0">
+            <a:spAutoFit/>
+          </a:bodyPr>
+          <a:lstStyle/>
+          <a:p>
+            <a:pPr algn="ctr"/>
+            <a:r>
+              <a:rPr lang="it-IT" sz="1050" dirty="0"/>
+              <a:t>*</a:t>
+            </a:r>
+            <a:r>
+              <a:rPr lang="it-IT" sz="1050" dirty="0">
+                <a:hlinkClick r:id="rId2" action="ppaction://hlinkfile"/>
+              </a:rPr>
+              <a:t>Machine Reference Manual</a:t>
+            </a:r>
+            <a:endParaRPr lang="nl-NL" sz="1050" dirty="0"/>
           </a:p>
         </p:txBody>
       </p:sp>
@@ -11339,7 +11111,121 @@
   </p:clrMapOvr>
   <mc:AlternateContent xmlns:mc="http://schemas.openxmlformats.org/markup-compatibility/2006" xmlns:p159="http://schemas.microsoft.com/office/powerpoint/2015/09/main">
     <mc:Choice Requires="p159">
-      <p:transition xmlns:p14="http://schemas.microsoft.com/office/powerpoint/2010/main" spd="slow" p14:dur="2000">
+      <p:transition spd="slow">
+        <p159:morph option="byObject"/>
+      </p:transition>
+    </mc:Choice>
+    <mc:Fallback xmlns="">
+      <p:transition spd="slow">
+        <p:fade/>
+      </p:transition>
+    </mc:Fallback>
+  </mc:AlternateContent>
+</p:sld>
+</file>
+
+<file path=ppt/slides/slide7.xml><?xml version="1.0" encoding="utf-8"?>
+<p:sld xmlns:a="http://schemas.openxmlformats.org/drawingml/2006/main" xmlns:r="http://schemas.openxmlformats.org/officeDocument/2006/relationships" xmlns:p="http://schemas.openxmlformats.org/presentationml/2006/main">
+  <p:cSld>
+    <p:spTree>
+      <p:nvGrpSpPr>
+        <p:cNvPr id="1" name=""/>
+        <p:cNvGrpSpPr/>
+        <p:nvPr/>
+      </p:nvGrpSpPr>
+      <p:grpSpPr>
+        <a:xfrm>
+          <a:off x="0" y="0"/>
+          <a:ext cx="0" cy="0"/>
+          <a:chOff x="0" y="0"/>
+          <a:chExt cx="0" cy="0"/>
+        </a:xfrm>
+      </p:grpSpPr>
+      <p:sp>
+        <p:nvSpPr>
+          <p:cNvPr id="4" name="TextBox 3">
+            <a:extLst>
+              <a:ext uri="{FF2B5EF4-FFF2-40B4-BE49-F238E27FC236}">
+                <a16:creationId xmlns:a16="http://schemas.microsoft.com/office/drawing/2014/main" id="{B40CC955-9822-4C97-8EA5-CCA925BF2200}"/>
+              </a:ext>
+            </a:extLst>
+          </p:cNvPr>
+          <p:cNvSpPr txBox="1"/>
+          <p:nvPr/>
+        </p:nvSpPr>
+        <p:spPr>
+          <a:xfrm>
+            <a:off x="0" y="2009"/>
+            <a:ext cx="3430954" cy="369332"/>
+          </a:xfrm>
+          <a:prstGeom prst="rect">
+            <a:avLst/>
+          </a:prstGeom>
+          <a:noFill/>
+        </p:spPr>
+        <p:txBody>
+          <a:bodyPr wrap="square" rtlCol="0">
+            <a:spAutoFit/>
+          </a:bodyPr>
+          <a:lstStyle/>
+          <a:p>
+            <a:r>
+              <a:rPr lang="it-IT" u="sng" dirty="0"/>
+              <a:t>Missing Values</a:t>
+            </a:r>
+            <a:endParaRPr lang="nl-NL" u="sng" dirty="0"/>
+          </a:p>
+        </p:txBody>
+      </p:sp>
+      <p:pic>
+        <p:nvPicPr>
+          <p:cNvPr id="3" name="Picture 2">
+            <a:extLst>
+              <a:ext uri="{FF2B5EF4-FFF2-40B4-BE49-F238E27FC236}">
+                <a16:creationId xmlns:a16="http://schemas.microsoft.com/office/drawing/2014/main" id="{6C52EDD9-3028-4E42-A5D9-F1DB5004F6CA}"/>
+              </a:ext>
+            </a:extLst>
+          </p:cNvPr>
+          <p:cNvPicPr>
+            <a:picLocks noChangeAspect="1"/>
+          </p:cNvPicPr>
+          <p:nvPr/>
+        </p:nvPicPr>
+        <p:blipFill>
+          <a:blip r:embed="rId2">
+            <a:extLst>
+              <a:ext uri="{28A0092B-C50C-407E-A947-70E740481C1C}">
+                <a14:useLocalDpi xmlns:a14="http://schemas.microsoft.com/office/drawing/2010/main" val="0"/>
+              </a:ext>
+            </a:extLst>
+          </a:blip>
+          <a:stretch>
+            <a:fillRect/>
+          </a:stretch>
+        </p:blipFill>
+        <p:spPr>
+          <a:xfrm>
+            <a:off x="2868297" y="0"/>
+            <a:ext cx="6455405" cy="6858000"/>
+          </a:xfrm>
+          <a:prstGeom prst="rect">
+            <a:avLst/>
+          </a:prstGeom>
+        </p:spPr>
+      </p:pic>
+    </p:spTree>
+    <p:extLst>
+      <p:ext uri="{BB962C8B-B14F-4D97-AF65-F5344CB8AC3E}">
+        <p14:creationId xmlns:p14="http://schemas.microsoft.com/office/powerpoint/2010/main" val="2771455475"/>
+      </p:ext>
+    </p:extLst>
+  </p:cSld>
+  <p:clrMapOvr>
+    <a:masterClrMapping/>
+  </p:clrMapOvr>
+  <mc:AlternateContent xmlns:mc="http://schemas.openxmlformats.org/markup-compatibility/2006" xmlns:p159="http://schemas.microsoft.com/office/powerpoint/2015/09/main">
+    <mc:Choice Requires="p159">
+      <p:transition spd="slow">
         <p159:morph option="byObject"/>
       </p:transition>
     </mc:Choice>
@@ -11369,48 +11255,12 @@
           <a:chExt cx="0" cy="0"/>
         </a:xfrm>
       </p:grpSpPr>
-      <p:sp>
-        <p:nvSpPr>
-          <p:cNvPr id="4" name="TextBox 3">
-            <a:extLst>
-              <a:ext uri="{FF2B5EF4-FFF2-40B4-BE49-F238E27FC236}">
-                <a16:creationId xmlns:a16="http://schemas.microsoft.com/office/drawing/2014/main" id="{B40CC955-9822-4C97-8EA5-CCA925BF2200}"/>
-              </a:ext>
-            </a:extLst>
-          </p:cNvPr>
-          <p:cNvSpPr txBox="1"/>
-          <p:nvPr/>
-        </p:nvSpPr>
-        <p:spPr>
-          <a:xfrm>
-            <a:off x="0" y="2009"/>
-            <a:ext cx="3430954" cy="369332"/>
-          </a:xfrm>
-          <a:prstGeom prst="rect">
-            <a:avLst/>
-          </a:prstGeom>
-          <a:noFill/>
-        </p:spPr>
-        <p:txBody>
-          <a:bodyPr wrap="square" rtlCol="0">
-            <a:spAutoFit/>
-          </a:bodyPr>
-          <a:lstStyle/>
-          <a:p>
-            <a:r>
-              <a:rPr lang="it-IT" u="sng" dirty="0"/>
-              <a:t>Missing Values</a:t>
-            </a:r>
-            <a:endParaRPr lang="nl-NL" u="sng" dirty="0"/>
-          </a:p>
-        </p:txBody>
-      </p:sp>
       <p:pic>
         <p:nvPicPr>
-          <p:cNvPr id="5" name="Picture 4">
-            <a:extLst>
-              <a:ext uri="{FF2B5EF4-FFF2-40B4-BE49-F238E27FC236}">
-                <a16:creationId xmlns:a16="http://schemas.microsoft.com/office/drawing/2014/main" id="{634625C7-DC4A-4491-AF1E-52984F047015}"/>
+          <p:cNvPr id="56" name="Graphic 55">
+            <a:extLst>
+              <a:ext uri="{FF2B5EF4-FFF2-40B4-BE49-F238E27FC236}">
+                <a16:creationId xmlns:a16="http://schemas.microsoft.com/office/drawing/2014/main" id="{52414F87-F631-4D89-AA4B-5432D50060F8}"/>
               </a:ext>
             </a:extLst>
           </p:cNvPr>
@@ -11419,21 +11269,220 @@
           </p:cNvPicPr>
           <p:nvPr/>
         </p:nvPicPr>
-        <p:blipFill rotWithShape="1">
+        <p:blipFill>
           <a:blip r:embed="rId2">
             <a:extLst>
               <a:ext uri="{28A0092B-C50C-407E-A947-70E740481C1C}">
                 <a14:useLocalDpi xmlns:a14="http://schemas.microsoft.com/office/drawing/2010/main" val="0"/>
               </a:ext>
+              <a:ext uri="{96DAC541-7B7A-43D3-8B79-37D633B846F1}">
+                <asvg:svgBlip xmlns:asvg="http://schemas.microsoft.com/office/drawing/2016/SVG/main" r:embed="rId3"/>
+              </a:ext>
             </a:extLst>
           </a:blip>
-          <a:srcRect t="3309"/>
-          <a:stretch/>
+          <a:stretch>
+            <a:fillRect/>
+          </a:stretch>
         </p:blipFill>
         <p:spPr>
           <a:xfrm>
-            <a:off x="2424139" y="352927"/>
-            <a:ext cx="7343722" cy="6503064"/>
+            <a:off x="6935099" y="3299436"/>
+            <a:ext cx="4394477" cy="3299436"/>
+          </a:xfrm>
+          <a:prstGeom prst="rect">
+            <a:avLst/>
+          </a:prstGeom>
+        </p:spPr>
+      </p:pic>
+      <p:pic>
+        <p:nvPicPr>
+          <p:cNvPr id="58" name="Graphic 57">
+            <a:extLst>
+              <a:ext uri="{FF2B5EF4-FFF2-40B4-BE49-F238E27FC236}">
+                <a16:creationId xmlns:a16="http://schemas.microsoft.com/office/drawing/2014/main" id="{68FD5771-5A2A-484D-A31C-D9D6B471123F}"/>
+              </a:ext>
+            </a:extLst>
+          </p:cNvPr>
+          <p:cNvPicPr>
+            <a:picLocks noChangeAspect="1"/>
+          </p:cNvPicPr>
+          <p:nvPr/>
+        </p:nvPicPr>
+        <p:blipFill>
+          <a:blip r:embed="rId4">
+            <a:extLst>
+              <a:ext uri="{28A0092B-C50C-407E-A947-70E740481C1C}">
+                <a14:useLocalDpi xmlns:a14="http://schemas.microsoft.com/office/drawing/2010/main" val="0"/>
+              </a:ext>
+              <a:ext uri="{96DAC541-7B7A-43D3-8B79-37D633B846F1}">
+                <asvg:svgBlip xmlns:asvg="http://schemas.microsoft.com/office/drawing/2016/SVG/main" r:embed="rId5"/>
+              </a:ext>
+            </a:extLst>
+          </a:blip>
+          <a:stretch>
+            <a:fillRect/>
+          </a:stretch>
+        </p:blipFill>
+        <p:spPr>
+          <a:xfrm>
+            <a:off x="862424" y="3299436"/>
+            <a:ext cx="4394477" cy="3299436"/>
+          </a:xfrm>
+          <a:prstGeom prst="rect">
+            <a:avLst/>
+          </a:prstGeom>
+        </p:spPr>
+      </p:pic>
+      <p:pic>
+        <p:nvPicPr>
+          <p:cNvPr id="60" name="Graphic 59">
+            <a:extLst>
+              <a:ext uri="{FF2B5EF4-FFF2-40B4-BE49-F238E27FC236}">
+                <a16:creationId xmlns:a16="http://schemas.microsoft.com/office/drawing/2014/main" id="{A666AFF7-F3EA-45A7-9012-B02B8CF613E5}"/>
+              </a:ext>
+            </a:extLst>
+          </p:cNvPr>
+          <p:cNvPicPr>
+            <a:picLocks noChangeAspect="1"/>
+          </p:cNvPicPr>
+          <p:nvPr/>
+        </p:nvPicPr>
+        <p:blipFill>
+          <a:blip r:embed="rId6">
+            <a:extLst>
+              <a:ext uri="{28A0092B-C50C-407E-A947-70E740481C1C}">
+                <a14:useLocalDpi xmlns:a14="http://schemas.microsoft.com/office/drawing/2010/main" val="0"/>
+              </a:ext>
+              <a:ext uri="{96DAC541-7B7A-43D3-8B79-37D633B846F1}">
+                <asvg:svgBlip xmlns:asvg="http://schemas.microsoft.com/office/drawing/2016/SVG/main" r:embed="rId7"/>
+              </a:ext>
+            </a:extLst>
+          </a:blip>
+          <a:stretch>
+            <a:fillRect/>
+          </a:stretch>
+        </p:blipFill>
+        <p:spPr>
+          <a:xfrm>
+            <a:off x="8214104" y="0"/>
+            <a:ext cx="4394477" cy="3299436"/>
+          </a:xfrm>
+          <a:prstGeom prst="rect">
+            <a:avLst/>
+          </a:prstGeom>
+        </p:spPr>
+      </p:pic>
+      <p:pic>
+        <p:nvPicPr>
+          <p:cNvPr id="62" name="Graphic 61">
+            <a:extLst>
+              <a:ext uri="{FF2B5EF4-FFF2-40B4-BE49-F238E27FC236}">
+                <a16:creationId xmlns:a16="http://schemas.microsoft.com/office/drawing/2014/main" id="{BC051BED-6050-4585-8170-AF9657F7F502}"/>
+              </a:ext>
+            </a:extLst>
+          </p:cNvPr>
+          <p:cNvPicPr>
+            <a:picLocks noChangeAspect="1"/>
+          </p:cNvPicPr>
+          <p:nvPr/>
+        </p:nvPicPr>
+        <p:blipFill>
+          <a:blip r:embed="rId8">
+            <a:extLst>
+              <a:ext uri="{28A0092B-C50C-407E-A947-70E740481C1C}">
+                <a14:useLocalDpi xmlns:a14="http://schemas.microsoft.com/office/drawing/2010/main" val="0"/>
+              </a:ext>
+              <a:ext uri="{96DAC541-7B7A-43D3-8B79-37D633B846F1}">
+                <asvg:svgBlip xmlns:asvg="http://schemas.microsoft.com/office/drawing/2016/SVG/main" r:embed="rId9"/>
+              </a:ext>
+            </a:extLst>
+          </a:blip>
+          <a:stretch>
+            <a:fillRect/>
+          </a:stretch>
+        </p:blipFill>
+        <p:spPr>
+          <a:xfrm>
+            <a:off x="5256901" y="0"/>
+            <a:ext cx="4394477" cy="3299436"/>
+          </a:xfrm>
+          <a:prstGeom prst="rect">
+            <a:avLst/>
+          </a:prstGeom>
+        </p:spPr>
+      </p:pic>
+      <p:pic>
+        <p:nvPicPr>
+          <p:cNvPr id="64" name="Graphic 63">
+            <a:extLst>
+              <a:ext uri="{FF2B5EF4-FFF2-40B4-BE49-F238E27FC236}">
+                <a16:creationId xmlns:a16="http://schemas.microsoft.com/office/drawing/2014/main" id="{FC29D5F6-41B5-4C6C-A664-E5758A41131A}"/>
+              </a:ext>
+            </a:extLst>
+          </p:cNvPr>
+          <p:cNvPicPr>
+            <a:picLocks noChangeAspect="1"/>
+          </p:cNvPicPr>
+          <p:nvPr/>
+        </p:nvPicPr>
+        <p:blipFill>
+          <a:blip r:embed="rId10">
+            <a:extLst>
+              <a:ext uri="{28A0092B-C50C-407E-A947-70E740481C1C}">
+                <a14:useLocalDpi xmlns:a14="http://schemas.microsoft.com/office/drawing/2010/main" val="0"/>
+              </a:ext>
+              <a:ext uri="{96DAC541-7B7A-43D3-8B79-37D633B846F1}">
+                <asvg:svgBlip xmlns:asvg="http://schemas.microsoft.com/office/drawing/2016/SVG/main" r:embed="rId11"/>
+              </a:ext>
+            </a:extLst>
+          </a:blip>
+          <a:stretch>
+            <a:fillRect/>
+          </a:stretch>
+        </p:blipFill>
+        <p:spPr>
+          <a:xfrm>
+            <a:off x="2299699" y="0"/>
+            <a:ext cx="4394477" cy="3299436"/>
+          </a:xfrm>
+          <a:prstGeom prst="rect">
+            <a:avLst/>
+          </a:prstGeom>
+        </p:spPr>
+      </p:pic>
+      <p:pic>
+        <p:nvPicPr>
+          <p:cNvPr id="66" name="Graphic 65">
+            <a:extLst>
+              <a:ext uri="{FF2B5EF4-FFF2-40B4-BE49-F238E27FC236}">
+                <a16:creationId xmlns:a16="http://schemas.microsoft.com/office/drawing/2014/main" id="{E40859BE-F25B-48B1-B7CF-10C7F1E45D9A}"/>
+              </a:ext>
+            </a:extLst>
+          </p:cNvPr>
+          <p:cNvPicPr>
+            <a:picLocks noChangeAspect="1"/>
+          </p:cNvPicPr>
+          <p:nvPr/>
+        </p:nvPicPr>
+        <p:blipFill>
+          <a:blip r:embed="rId12">
+            <a:extLst>
+              <a:ext uri="{28A0092B-C50C-407E-A947-70E740481C1C}">
+                <a14:useLocalDpi xmlns:a14="http://schemas.microsoft.com/office/drawing/2010/main" val="0"/>
+              </a:ext>
+              <a:ext uri="{96DAC541-7B7A-43D3-8B79-37D633B846F1}">
+                <asvg:svgBlip xmlns:asvg="http://schemas.microsoft.com/office/drawing/2016/SVG/main" r:embed="rId13"/>
+              </a:ext>
+            </a:extLst>
+          </a:blip>
+          <a:stretch>
+            <a:fillRect/>
+          </a:stretch>
+        </p:blipFill>
+        <p:spPr>
+          <a:xfrm>
+            <a:off x="-657503" y="0"/>
+            <a:ext cx="4394477" cy="3299436"/>
           </a:xfrm>
           <a:prstGeom prst="rect">
             <a:avLst/>
@@ -11443,7 +11492,7 @@
     </p:spTree>
     <p:extLst>
       <p:ext uri="{BB962C8B-B14F-4D97-AF65-F5344CB8AC3E}">
-        <p14:creationId xmlns:p14="http://schemas.microsoft.com/office/powerpoint/2010/main" val="2771455475"/>
+        <p14:creationId xmlns:p14="http://schemas.microsoft.com/office/powerpoint/2010/main" val="2692764115"/>
       </p:ext>
     </p:extLst>
   </p:cSld>
@@ -11452,7 +11501,7 @@
   </p:clrMapOvr>
   <mc:AlternateContent xmlns:mc="http://schemas.openxmlformats.org/markup-compatibility/2006" xmlns:p159="http://schemas.microsoft.com/office/powerpoint/2015/09/main">
     <mc:Choice Requires="p159">
-      <p:transition xmlns:p14="http://schemas.microsoft.com/office/powerpoint/2010/main" spd="slow" p14:dur="2000">
+      <p:transition spd="slow">
         <p159:morph option="byObject"/>
       </p:transition>
     </mc:Choice>
@@ -11484,10 +11533,10 @@
       </p:grpSpPr>
       <p:pic>
         <p:nvPicPr>
-          <p:cNvPr id="56" name="Graphic 55">
-            <a:extLst>
-              <a:ext uri="{FF2B5EF4-FFF2-40B4-BE49-F238E27FC236}">
-                <a16:creationId xmlns:a16="http://schemas.microsoft.com/office/drawing/2014/main" id="{52414F87-F631-4D89-AA4B-5432D50060F8}"/>
+          <p:cNvPr id="3" name="Graphic 2">
+            <a:extLst>
+              <a:ext uri="{FF2B5EF4-FFF2-40B4-BE49-F238E27FC236}">
+                <a16:creationId xmlns:a16="http://schemas.microsoft.com/office/drawing/2014/main" id="{5104F63A-8305-48CC-A7C8-38D27F499ADB}"/>
               </a:ext>
             </a:extLst>
           </p:cNvPr>
@@ -11513,8 +11562,8 @@
         </p:blipFill>
         <p:spPr>
           <a:xfrm>
-            <a:off x="6935099" y="3299436"/>
-            <a:ext cx="4394477" cy="3299436"/>
+            <a:off x="6955860" y="3300410"/>
+            <a:ext cx="4471895" cy="3357563"/>
           </a:xfrm>
           <a:prstGeom prst="rect">
             <a:avLst/>
@@ -11523,10 +11572,10 @@
       </p:pic>
       <p:pic>
         <p:nvPicPr>
-          <p:cNvPr id="58" name="Graphic 57">
-            <a:extLst>
-              <a:ext uri="{FF2B5EF4-FFF2-40B4-BE49-F238E27FC236}">
-                <a16:creationId xmlns:a16="http://schemas.microsoft.com/office/drawing/2014/main" id="{68FD5771-5A2A-484D-A31C-D9D6B471123F}"/>
+          <p:cNvPr id="5" name="Graphic 4">
+            <a:extLst>
+              <a:ext uri="{FF2B5EF4-FFF2-40B4-BE49-F238E27FC236}">
+                <a16:creationId xmlns:a16="http://schemas.microsoft.com/office/drawing/2014/main" id="{B68B9AC6-63AF-4D04-8412-F617E4BD1E25}"/>
               </a:ext>
             </a:extLst>
           </p:cNvPr>
@@ -11552,8 +11601,8 @@
         </p:blipFill>
         <p:spPr>
           <a:xfrm>
-            <a:off x="862424" y="3299436"/>
-            <a:ext cx="4394477" cy="3299436"/>
+            <a:off x="915392" y="3300411"/>
+            <a:ext cx="4471895" cy="3357563"/>
           </a:xfrm>
           <a:prstGeom prst="rect">
             <a:avLst/>
@@ -11562,10 +11611,10 @@
       </p:pic>
       <p:pic>
         <p:nvPicPr>
-          <p:cNvPr id="60" name="Graphic 59">
-            <a:extLst>
-              <a:ext uri="{FF2B5EF4-FFF2-40B4-BE49-F238E27FC236}">
-                <a16:creationId xmlns:a16="http://schemas.microsoft.com/office/drawing/2014/main" id="{A666AFF7-F3EA-45A7-9012-B02B8CF613E5}"/>
+          <p:cNvPr id="7" name="Graphic 6">
+            <a:extLst>
+              <a:ext uri="{FF2B5EF4-FFF2-40B4-BE49-F238E27FC236}">
+                <a16:creationId xmlns:a16="http://schemas.microsoft.com/office/drawing/2014/main" id="{A67BD1E4-1078-48C8-A0CC-A8F92079F4D0}"/>
               </a:ext>
             </a:extLst>
           </p:cNvPr>
@@ -11591,8 +11640,8 @@
         </p:blipFill>
         <p:spPr>
           <a:xfrm>
-            <a:off x="8214104" y="0"/>
-            <a:ext cx="4394477" cy="3299436"/>
+            <a:off x="8416461" y="0"/>
+            <a:ext cx="4471895" cy="3357563"/>
           </a:xfrm>
           <a:prstGeom prst="rect">
             <a:avLst/>
@@ -11601,10 +11650,10 @@
       </p:pic>
       <p:pic>
         <p:nvPicPr>
-          <p:cNvPr id="62" name="Graphic 61">
-            <a:extLst>
-              <a:ext uri="{FF2B5EF4-FFF2-40B4-BE49-F238E27FC236}">
-                <a16:creationId xmlns:a16="http://schemas.microsoft.com/office/drawing/2014/main" id="{BC051BED-6050-4585-8170-AF9657F7F502}"/>
+          <p:cNvPr id="9" name="Graphic 8">
+            <a:extLst>
+              <a:ext uri="{FF2B5EF4-FFF2-40B4-BE49-F238E27FC236}">
+                <a16:creationId xmlns:a16="http://schemas.microsoft.com/office/drawing/2014/main" id="{9FBB4D53-4F61-4420-B2EA-5DBB2190FBDD}"/>
               </a:ext>
             </a:extLst>
           </p:cNvPr>
@@ -11630,8 +11679,8 @@
         </p:blipFill>
         <p:spPr>
           <a:xfrm>
-            <a:off x="5256901" y="0"/>
-            <a:ext cx="4394477" cy="3299436"/>
+            <a:off x="5405166" y="0"/>
+            <a:ext cx="4471895" cy="3357563"/>
           </a:xfrm>
           <a:prstGeom prst="rect">
             <a:avLst/>
@@ -11640,10 +11689,10 @@
       </p:pic>
       <p:pic>
         <p:nvPicPr>
-          <p:cNvPr id="64" name="Graphic 63">
-            <a:extLst>
-              <a:ext uri="{FF2B5EF4-FFF2-40B4-BE49-F238E27FC236}">
-                <a16:creationId xmlns:a16="http://schemas.microsoft.com/office/drawing/2014/main" id="{FC29D5F6-41B5-4C6C-A664-E5758A41131A}"/>
+          <p:cNvPr id="11" name="Graphic 10">
+            <a:extLst>
+              <a:ext uri="{FF2B5EF4-FFF2-40B4-BE49-F238E27FC236}">
+                <a16:creationId xmlns:a16="http://schemas.microsoft.com/office/drawing/2014/main" id="{9947BBB5-44C5-48CF-969E-441FAF4420ED}"/>
               </a:ext>
             </a:extLst>
           </p:cNvPr>
@@ -11669,8 +11718,8 @@
         </p:blipFill>
         <p:spPr>
           <a:xfrm>
-            <a:off x="2299699" y="0"/>
-            <a:ext cx="4394477" cy="3299436"/>
+            <a:off x="2314940" y="0"/>
+            <a:ext cx="4471895" cy="3357563"/>
           </a:xfrm>
           <a:prstGeom prst="rect">
             <a:avLst/>
@@ -11679,10 +11728,10 @@
       </p:pic>
       <p:pic>
         <p:nvPicPr>
-          <p:cNvPr id="66" name="Graphic 65">
-            <a:extLst>
-              <a:ext uri="{FF2B5EF4-FFF2-40B4-BE49-F238E27FC236}">
-                <a16:creationId xmlns:a16="http://schemas.microsoft.com/office/drawing/2014/main" id="{E40859BE-F25B-48B1-B7CF-10C7F1E45D9A}"/>
+          <p:cNvPr id="13" name="Graphic 12">
+            <a:extLst>
+              <a:ext uri="{FF2B5EF4-FFF2-40B4-BE49-F238E27FC236}">
+                <a16:creationId xmlns:a16="http://schemas.microsoft.com/office/drawing/2014/main" id="{FC69359F-A5B2-4EC6-BD2E-74DFBA522CFC}"/>
               </a:ext>
             </a:extLst>
           </p:cNvPr>
@@ -11708,8 +11757,8 @@
         </p:blipFill>
         <p:spPr>
           <a:xfrm>
-            <a:off x="-657503" y="0"/>
-            <a:ext cx="4394477" cy="3299436"/>
+            <a:off x="-859675" y="-28577"/>
+            <a:ext cx="4471895" cy="3357563"/>
           </a:xfrm>
           <a:prstGeom prst="rect">
             <a:avLst/>
@@ -11719,7 +11768,7 @@
     </p:spTree>
     <p:extLst>
       <p:ext uri="{BB962C8B-B14F-4D97-AF65-F5344CB8AC3E}">
-        <p14:creationId xmlns:p14="http://schemas.microsoft.com/office/powerpoint/2010/main" val="2692764115"/>
+        <p14:creationId xmlns:p14="http://schemas.microsoft.com/office/powerpoint/2010/main" val="2926366783"/>
       </p:ext>
     </p:extLst>
   </p:cSld>
@@ -11728,7 +11777,7 @@
   </p:clrMapOvr>
   <mc:AlternateContent xmlns:mc="http://schemas.openxmlformats.org/markup-compatibility/2006" xmlns:p159="http://schemas.microsoft.com/office/powerpoint/2015/09/main">
     <mc:Choice Requires="p159">
-      <p:transition xmlns:p14="http://schemas.microsoft.com/office/powerpoint/2010/main" spd="slow" p14:dur="2000">
+      <p:transition spd="slow">
         <p159:morph option="byObject"/>
       </p:transition>
     </mc:Choice>

</xml_diff>

<commit_message>
r script delta time added to wavg
</commit_message>
<xml_diff>
--- a/assets/ppt/data_exploration.pptx
+++ b/assets/ppt/data_exploration.pptx
@@ -5,7 +5,7 @@
     <p:sldMasterId id="2147483648" r:id="rId1"/>
   </p:sldMasterIdLst>
   <p:notesMasterIdLst>
-    <p:notesMasterId r:id="rId35"/>
+    <p:notesMasterId r:id="rId39"/>
   </p:notesMasterIdLst>
   <p:sldIdLst>
     <p:sldId id="257" r:id="rId2"/>
@@ -28,19 +28,23 @@
     <p:sldId id="284" r:id="rId19"/>
     <p:sldId id="289" r:id="rId20"/>
     <p:sldId id="288" r:id="rId21"/>
-    <p:sldId id="287" r:id="rId22"/>
-    <p:sldId id="259" r:id="rId23"/>
-    <p:sldId id="274" r:id="rId24"/>
-    <p:sldId id="275" r:id="rId25"/>
-    <p:sldId id="279" r:id="rId26"/>
-    <p:sldId id="278" r:id="rId27"/>
-    <p:sldId id="276" r:id="rId28"/>
-    <p:sldId id="277" r:id="rId29"/>
-    <p:sldId id="268" r:id="rId30"/>
-    <p:sldId id="269" r:id="rId31"/>
-    <p:sldId id="271" r:id="rId32"/>
-    <p:sldId id="272" r:id="rId33"/>
-    <p:sldId id="267" r:id="rId34"/>
+    <p:sldId id="291" r:id="rId22"/>
+    <p:sldId id="287" r:id="rId23"/>
+    <p:sldId id="290" r:id="rId24"/>
+    <p:sldId id="292" r:id="rId25"/>
+    <p:sldId id="293" r:id="rId26"/>
+    <p:sldId id="259" r:id="rId27"/>
+    <p:sldId id="274" r:id="rId28"/>
+    <p:sldId id="275" r:id="rId29"/>
+    <p:sldId id="279" r:id="rId30"/>
+    <p:sldId id="278" r:id="rId31"/>
+    <p:sldId id="276" r:id="rId32"/>
+    <p:sldId id="277" r:id="rId33"/>
+    <p:sldId id="268" r:id="rId34"/>
+    <p:sldId id="269" r:id="rId35"/>
+    <p:sldId id="271" r:id="rId36"/>
+    <p:sldId id="272" r:id="rId37"/>
+    <p:sldId id="267" r:id="rId38"/>
   </p:sldIdLst>
   <p:sldSz cx="12192000" cy="6858000"/>
   <p:notesSz cx="6858000" cy="9144000"/>
@@ -1052,7 +1056,7 @@
           <a:p>
             <a:fld id="{511A67EE-E303-4967-962F-9A28980F7F51}" type="datetimeFigureOut">
               <a:rPr lang="nl-NL" smtClean="0"/>
-              <a:t>28-8-2024</a:t>
+              <a:t>29-8-2024</a:t>
             </a:fld>
             <a:endParaRPr lang="nl-NL"/>
           </a:p>
@@ -1469,7 +1473,7 @@
           <a:p>
             <a:fld id="{FED566F3-1D76-4AEC-ABE9-AFABCF495913}" type="datetime1">
               <a:rPr lang="nl-NL" smtClean="0"/>
-              <a:t>28-8-2024</a:t>
+              <a:t>29-8-2024</a:t>
             </a:fld>
             <a:endParaRPr lang="nl-NL"/>
           </a:p>
@@ -1681,7 +1685,7 @@
           <a:p>
             <a:fld id="{BC7E55A1-B228-4CF1-BFC3-6AC3B8574AC2}" type="datetime1">
               <a:rPr lang="nl-NL" smtClean="0"/>
-              <a:t>28-8-2024</a:t>
+              <a:t>29-8-2024</a:t>
             </a:fld>
             <a:endParaRPr lang="nl-NL"/>
           </a:p>
@@ -1903,7 +1907,7 @@
           <a:p>
             <a:fld id="{31AEBC58-6519-439D-8982-F0178170B57B}" type="datetime1">
               <a:rPr lang="nl-NL" smtClean="0"/>
-              <a:t>28-8-2024</a:t>
+              <a:t>29-8-2024</a:t>
             </a:fld>
             <a:endParaRPr lang="nl-NL"/>
           </a:p>
@@ -2115,7 +2119,7 @@
           <a:p>
             <a:fld id="{86DED964-D172-498F-BB83-2F7DE2692B37}" type="datetime1">
               <a:rPr lang="nl-NL" smtClean="0"/>
-              <a:t>28-8-2024</a:t>
+              <a:t>29-8-2024</a:t>
             </a:fld>
             <a:endParaRPr lang="nl-NL"/>
           </a:p>
@@ -2403,7 +2407,7 @@
           <a:p>
             <a:fld id="{230F72AC-D91D-48F5-81B4-4889AEA39D06}" type="datetime1">
               <a:rPr lang="nl-NL" smtClean="0"/>
-              <a:t>28-8-2024</a:t>
+              <a:t>29-8-2024</a:t>
             </a:fld>
             <a:endParaRPr lang="nl-NL"/>
           </a:p>
@@ -2683,7 +2687,7 @@
           <a:p>
             <a:fld id="{A0669485-26A9-497C-AD22-BCEA88DF9055}" type="datetime1">
               <a:rPr lang="nl-NL" smtClean="0"/>
-              <a:t>28-8-2024</a:t>
+              <a:t>29-8-2024</a:t>
             </a:fld>
             <a:endParaRPr lang="nl-NL"/>
           </a:p>
@@ -3110,7 +3114,7 @@
           <a:p>
             <a:fld id="{6216D00C-0C62-40DF-B6FF-B9A70701552F}" type="datetime1">
               <a:rPr lang="nl-NL" smtClean="0"/>
-              <a:t>28-8-2024</a:t>
+              <a:t>29-8-2024</a:t>
             </a:fld>
             <a:endParaRPr lang="nl-NL"/>
           </a:p>
@@ -3264,7 +3268,7 @@
           <a:p>
             <a:fld id="{88FE9515-DD39-459B-B4EF-789D74C861A5}" type="datetime1">
               <a:rPr lang="nl-NL" smtClean="0"/>
-              <a:t>28-8-2024</a:t>
+              <a:t>29-8-2024</a:t>
             </a:fld>
             <a:endParaRPr lang="nl-NL"/>
           </a:p>
@@ -3389,7 +3393,7 @@
           <a:p>
             <a:fld id="{DFA27954-A76F-4E23-8576-A7D9667CDBCC}" type="datetime1">
               <a:rPr lang="nl-NL" smtClean="0"/>
-              <a:t>28-8-2024</a:t>
+              <a:t>29-8-2024</a:t>
             </a:fld>
             <a:endParaRPr lang="nl-NL"/>
           </a:p>
@@ -3714,7 +3718,7 @@
           <a:p>
             <a:fld id="{53C17D54-D850-41AA-94F6-0F7316E4F326}" type="datetime1">
               <a:rPr lang="nl-NL" smtClean="0"/>
-              <a:t>28-8-2024</a:t>
+              <a:t>29-8-2024</a:t>
             </a:fld>
             <a:endParaRPr lang="nl-NL"/>
           </a:p>
@@ -4015,7 +4019,7 @@
           <a:p>
             <a:fld id="{0596A96E-3739-43D3-93E5-DAA507EA7B79}" type="datetime1">
               <a:rPr lang="nl-NL" smtClean="0"/>
-              <a:t>28-8-2024</a:t>
+              <a:t>29-8-2024</a:t>
             </a:fld>
             <a:endParaRPr lang="nl-NL"/>
           </a:p>
@@ -4270,7 +4274,7 @@
           <a:p>
             <a:fld id="{CFBB0748-A22F-4137-ADB1-6D5A09F7B1DF}" type="datetime1">
               <a:rPr lang="nl-NL" smtClean="0"/>
-              <a:t>28-8-2024</a:t>
+              <a:t>29-8-2024</a:t>
             </a:fld>
             <a:endParaRPr lang="nl-NL"/>
           </a:p>
@@ -6170,7 +6174,7 @@
             <a:pPr algn="ctr"/>
             <a:r>
               <a:rPr lang="it-IT" sz="3200" dirty="0"/>
-              <a:t>New Strategy</a:t>
+              <a:t>Strategy 2</a:t>
             </a:r>
             <a:endParaRPr lang="nl-NL" sz="3200" dirty="0"/>
           </a:p>
@@ -9202,10 +9206,47 @@
           <a:chExt cx="0" cy="0"/>
         </a:xfrm>
       </p:grpSpPr>
+      <p:sp>
+        <p:nvSpPr>
+          <p:cNvPr id="2" name="TextBox 1">
+            <a:extLst>
+              <a:ext uri="{FF2B5EF4-FFF2-40B4-BE49-F238E27FC236}">
+                <a16:creationId xmlns:a16="http://schemas.microsoft.com/office/drawing/2014/main" id="{6E0A7A84-3B9F-4444-9267-CAFBABDBBBA3}"/>
+              </a:ext>
+            </a:extLst>
+          </p:cNvPr>
+          <p:cNvSpPr txBox="1"/>
+          <p:nvPr/>
+        </p:nvSpPr>
+        <p:spPr>
+          <a:xfrm>
+            <a:off x="3709737" y="3136612"/>
+            <a:ext cx="4772526" cy="584775"/>
+          </a:xfrm>
+          <a:prstGeom prst="rect">
+            <a:avLst/>
+          </a:prstGeom>
+          <a:noFill/>
+        </p:spPr>
+        <p:txBody>
+          <a:bodyPr wrap="square" rtlCol="0">
+            <a:spAutoFit/>
+          </a:bodyPr>
+          <a:lstStyle/>
+          <a:p>
+            <a:pPr algn="ctr"/>
+            <a:r>
+              <a:rPr lang="it-IT" sz="3200" dirty="0"/>
+              <a:t>Definetly not working...</a:t>
+            </a:r>
+            <a:endParaRPr lang="nl-NL" sz="3200" dirty="0"/>
+          </a:p>
+        </p:txBody>
+      </p:sp>
     </p:spTree>
     <p:extLst>
       <p:ext uri="{BB962C8B-B14F-4D97-AF65-F5344CB8AC3E}">
-        <p14:creationId xmlns:p14="http://schemas.microsoft.com/office/powerpoint/2010/main" val="1927968865"/>
+        <p14:creationId xmlns:p14="http://schemas.microsoft.com/office/powerpoint/2010/main" val="95477958"/>
       </p:ext>
     </p:extLst>
   </p:cSld>
@@ -9246,6 +9287,969 @@
       </p:grpSpPr>
       <p:sp>
         <p:nvSpPr>
+          <p:cNvPr id="2" name="TextBox 1">
+            <a:extLst>
+              <a:ext uri="{FF2B5EF4-FFF2-40B4-BE49-F238E27FC236}">
+                <a16:creationId xmlns:a16="http://schemas.microsoft.com/office/drawing/2014/main" id="{A2173A06-E055-4964-BA41-68DADB5DF996}"/>
+              </a:ext>
+            </a:extLst>
+          </p:cNvPr>
+          <p:cNvSpPr txBox="1"/>
+          <p:nvPr/>
+        </p:nvSpPr>
+        <p:spPr>
+          <a:xfrm>
+            <a:off x="3709737" y="3136612"/>
+            <a:ext cx="4772526" cy="584775"/>
+          </a:xfrm>
+          <a:prstGeom prst="rect">
+            <a:avLst/>
+          </a:prstGeom>
+          <a:noFill/>
+        </p:spPr>
+        <p:txBody>
+          <a:bodyPr wrap="square" rtlCol="0">
+            <a:spAutoFit/>
+          </a:bodyPr>
+          <a:lstStyle/>
+          <a:p>
+            <a:pPr algn="ctr"/>
+            <a:r>
+              <a:rPr lang="it-IT" sz="3200" dirty="0"/>
+              <a:t>Strategy 3</a:t>
+            </a:r>
+            <a:endParaRPr lang="nl-NL" sz="3200" dirty="0"/>
+          </a:p>
+        </p:txBody>
+      </p:sp>
+    </p:spTree>
+    <p:extLst>
+      <p:ext uri="{BB962C8B-B14F-4D97-AF65-F5344CB8AC3E}">
+        <p14:creationId xmlns:p14="http://schemas.microsoft.com/office/powerpoint/2010/main" val="1927968865"/>
+      </p:ext>
+    </p:extLst>
+  </p:cSld>
+  <p:clrMapOvr>
+    <a:masterClrMapping/>
+  </p:clrMapOvr>
+  <mc:AlternateContent xmlns:mc="http://schemas.openxmlformats.org/markup-compatibility/2006" xmlns:p159="http://schemas.microsoft.com/office/powerpoint/2015/09/main">
+    <mc:Choice Requires="p159">
+      <p:transition spd="slow">
+        <p159:morph option="byObject"/>
+      </p:transition>
+    </mc:Choice>
+    <mc:Fallback xmlns="">
+      <p:transition spd="slow">
+        <p:fade/>
+      </p:transition>
+    </mc:Fallback>
+  </mc:AlternateContent>
+</p:sld>
+</file>
+
+<file path=ppt/slides/slide23.xml><?xml version="1.0" encoding="utf-8"?>
+<p:sld xmlns:a="http://schemas.openxmlformats.org/drawingml/2006/main" xmlns:r="http://schemas.openxmlformats.org/officeDocument/2006/relationships" xmlns:p="http://schemas.openxmlformats.org/presentationml/2006/main">
+  <p:cSld>
+    <p:spTree>
+      <p:nvGrpSpPr>
+        <p:cNvPr id="1" name=""/>
+        <p:cNvGrpSpPr/>
+        <p:nvPr/>
+      </p:nvGrpSpPr>
+      <p:grpSpPr>
+        <a:xfrm>
+          <a:off x="0" y="0"/>
+          <a:ext cx="0" cy="0"/>
+          <a:chOff x="0" y="0"/>
+          <a:chExt cx="0" cy="0"/>
+        </a:xfrm>
+      </p:grpSpPr>
+      <p:pic>
+        <p:nvPicPr>
+          <p:cNvPr id="2" name="Graphic 1" descr="Database">
+            <a:extLst>
+              <a:ext uri="{FF2B5EF4-FFF2-40B4-BE49-F238E27FC236}">
+                <a16:creationId xmlns:a16="http://schemas.microsoft.com/office/drawing/2014/main" id="{449AF60D-4D6F-4DF7-80E8-163F21B1FABD}"/>
+              </a:ext>
+            </a:extLst>
+          </p:cNvPr>
+          <p:cNvPicPr>
+            <a:picLocks noChangeAspect="1"/>
+          </p:cNvPicPr>
+          <p:nvPr/>
+        </p:nvPicPr>
+        <p:blipFill>
+          <a:blip r:embed="rId2">
+            <a:extLst>
+              <a:ext uri="{28A0092B-C50C-407E-A947-70E740481C1C}">
+                <a14:useLocalDpi xmlns:a14="http://schemas.microsoft.com/office/drawing/2010/main" val="0"/>
+              </a:ext>
+              <a:ext uri="{96DAC541-7B7A-43D3-8B79-37D633B846F1}">
+                <asvg:svgBlip xmlns:asvg="http://schemas.microsoft.com/office/drawing/2016/SVG/main" r:embed="rId3"/>
+              </a:ext>
+            </a:extLst>
+          </a:blip>
+          <a:stretch>
+            <a:fillRect/>
+          </a:stretch>
+        </p:blipFill>
+        <p:spPr>
+          <a:xfrm>
+            <a:off x="1676400" y="2964920"/>
+            <a:ext cx="914400" cy="914400"/>
+          </a:xfrm>
+          <a:prstGeom prst="rect">
+            <a:avLst/>
+          </a:prstGeom>
+        </p:spPr>
+      </p:pic>
+      <p:sp>
+        <p:nvSpPr>
+          <p:cNvPr id="3" name="TextBox 2">
+            <a:extLst>
+              <a:ext uri="{FF2B5EF4-FFF2-40B4-BE49-F238E27FC236}">
+                <a16:creationId xmlns:a16="http://schemas.microsoft.com/office/drawing/2014/main" id="{EF4B8F17-68DE-42EB-9D5E-7551561D7CEB}"/>
+              </a:ext>
+            </a:extLst>
+          </p:cNvPr>
+          <p:cNvSpPr txBox="1"/>
+          <p:nvPr/>
+        </p:nvSpPr>
+        <p:spPr>
+          <a:xfrm>
+            <a:off x="1275348" y="2704556"/>
+            <a:ext cx="1716502" cy="369332"/>
+          </a:xfrm>
+          <a:prstGeom prst="rect">
+            <a:avLst/>
+          </a:prstGeom>
+          <a:noFill/>
+        </p:spPr>
+        <p:txBody>
+          <a:bodyPr wrap="square" rtlCol="0">
+            <a:spAutoFit/>
+          </a:bodyPr>
+          <a:lstStyle/>
+          <a:p>
+            <a:pPr algn="ctr"/>
+            <a:r>
+              <a:rPr lang="it-IT" dirty="0"/>
+              <a:t>Data with NaNs</a:t>
+            </a:r>
+            <a:endParaRPr lang="nl-NL" dirty="0"/>
+          </a:p>
+        </p:txBody>
+      </p:sp>
+      <p:sp>
+        <p:nvSpPr>
+          <p:cNvPr id="4" name="TextBox 3">
+            <a:extLst>
+              <a:ext uri="{FF2B5EF4-FFF2-40B4-BE49-F238E27FC236}">
+                <a16:creationId xmlns:a16="http://schemas.microsoft.com/office/drawing/2014/main" id="{4BDE646C-1375-4835-99F9-196DF7430ACD}"/>
+              </a:ext>
+            </a:extLst>
+          </p:cNvPr>
+          <p:cNvSpPr txBox="1"/>
+          <p:nvPr/>
+        </p:nvSpPr>
+        <p:spPr>
+          <a:xfrm>
+            <a:off x="0" y="0"/>
+            <a:ext cx="3457074" cy="369332"/>
+          </a:xfrm>
+          <a:prstGeom prst="rect">
+            <a:avLst/>
+          </a:prstGeom>
+          <a:noFill/>
+        </p:spPr>
+        <p:txBody>
+          <a:bodyPr wrap="square" rtlCol="0">
+            <a:spAutoFit/>
+          </a:bodyPr>
+          <a:lstStyle/>
+          <a:p>
+            <a:r>
+              <a:rPr lang="it-IT" u="sng" dirty="0"/>
+              <a:t>Data processing - Pipeline</a:t>
+            </a:r>
+            <a:endParaRPr lang="nl-NL" u="sng" dirty="0"/>
+          </a:p>
+        </p:txBody>
+      </p:sp>
+      <p:cxnSp>
+        <p:nvCxnSpPr>
+          <p:cNvPr id="6" name="Straight Arrow Connector 5">
+            <a:extLst>
+              <a:ext uri="{FF2B5EF4-FFF2-40B4-BE49-F238E27FC236}">
+                <a16:creationId xmlns:a16="http://schemas.microsoft.com/office/drawing/2014/main" id="{D26349C7-BE7C-45C8-AC0A-95708985B7ED}"/>
+              </a:ext>
+            </a:extLst>
+          </p:cNvPr>
+          <p:cNvCxnSpPr>
+            <a:cxnSpLocks/>
+            <a:stCxn id="2" idx="3"/>
+            <a:endCxn id="8" idx="1"/>
+          </p:cNvCxnSpPr>
+          <p:nvPr/>
+        </p:nvCxnSpPr>
+        <p:spPr>
+          <a:xfrm>
+            <a:off x="2590800" y="3422120"/>
+            <a:ext cx="1315452" cy="0"/>
+          </a:xfrm>
+          <a:prstGeom prst="straightConnector1">
+            <a:avLst/>
+          </a:prstGeom>
+          <a:ln>
+            <a:tailEnd type="triangle"/>
+          </a:ln>
+        </p:spPr>
+        <p:style>
+          <a:lnRef idx="1">
+            <a:schemeClr val="accent1"/>
+          </a:lnRef>
+          <a:fillRef idx="0">
+            <a:schemeClr val="accent1"/>
+          </a:fillRef>
+          <a:effectRef idx="0">
+            <a:schemeClr val="accent1"/>
+          </a:effectRef>
+          <a:fontRef idx="minor">
+            <a:schemeClr val="tx1"/>
+          </a:fontRef>
+        </p:style>
+      </p:cxnSp>
+      <p:sp>
+        <p:nvSpPr>
+          <p:cNvPr id="8" name="Rectangle: Rounded Corners 7">
+            <a:extLst>
+              <a:ext uri="{FF2B5EF4-FFF2-40B4-BE49-F238E27FC236}">
+                <a16:creationId xmlns:a16="http://schemas.microsoft.com/office/drawing/2014/main" id="{D795A676-9415-4002-B1B7-7025F9D91A94}"/>
+              </a:ext>
+            </a:extLst>
+          </p:cNvPr>
+          <p:cNvSpPr/>
+          <p:nvPr/>
+        </p:nvSpPr>
+        <p:spPr>
+          <a:xfrm>
+            <a:off x="3906252" y="3007532"/>
+            <a:ext cx="2053389" cy="829176"/>
+          </a:xfrm>
+          <a:prstGeom prst="roundRect">
+            <a:avLst/>
+          </a:prstGeom>
+        </p:spPr>
+        <p:style>
+          <a:lnRef idx="2">
+            <a:schemeClr val="accent1">
+              <a:shade val="50000"/>
+            </a:schemeClr>
+          </a:lnRef>
+          <a:fillRef idx="1">
+            <a:schemeClr val="accent1"/>
+          </a:fillRef>
+          <a:effectRef idx="0">
+            <a:schemeClr val="accent1"/>
+          </a:effectRef>
+          <a:fontRef idx="minor">
+            <a:schemeClr val="lt1"/>
+          </a:fontRef>
+        </p:style>
+        <p:txBody>
+          <a:bodyPr rtlCol="0" anchor="ctr"/>
+          <a:lstStyle/>
+          <a:p>
+            <a:pPr algn="ctr"/>
+            <a:r>
+              <a:rPr lang="it-IT" dirty="0"/>
+              <a:t>Weighted AVG if pt has undergo that meas</a:t>
+            </a:r>
+            <a:endParaRPr lang="nl-NL" dirty="0"/>
+          </a:p>
+        </p:txBody>
+      </p:sp>
+      <p:sp>
+        <p:nvSpPr>
+          <p:cNvPr id="11" name="Rectangle: Rounded Corners 10">
+            <a:extLst>
+              <a:ext uri="{FF2B5EF4-FFF2-40B4-BE49-F238E27FC236}">
+                <a16:creationId xmlns:a16="http://schemas.microsoft.com/office/drawing/2014/main" id="{B3356680-ECA9-49AE-AFFD-FBCE91A67EC0}"/>
+              </a:ext>
+            </a:extLst>
+          </p:cNvPr>
+          <p:cNvSpPr/>
+          <p:nvPr/>
+        </p:nvSpPr>
+        <p:spPr>
+          <a:xfrm>
+            <a:off x="6874043" y="3014412"/>
+            <a:ext cx="1588168" cy="829176"/>
+          </a:xfrm>
+          <a:prstGeom prst="roundRect">
+            <a:avLst/>
+          </a:prstGeom>
+        </p:spPr>
+        <p:style>
+          <a:lnRef idx="2">
+            <a:schemeClr val="accent1">
+              <a:shade val="50000"/>
+            </a:schemeClr>
+          </a:lnRef>
+          <a:fillRef idx="1">
+            <a:schemeClr val="accent1"/>
+          </a:fillRef>
+          <a:effectRef idx="0">
+            <a:schemeClr val="accent1"/>
+          </a:effectRef>
+          <a:fontRef idx="minor">
+            <a:schemeClr val="lt1"/>
+          </a:fontRef>
+        </p:style>
+        <p:txBody>
+          <a:bodyPr rtlCol="0" anchor="ctr"/>
+          <a:lstStyle/>
+          <a:p>
+            <a:pPr algn="ctr"/>
+            <a:r>
+              <a:rPr lang="it-IT" dirty="0"/>
+              <a:t>MICE Forest</a:t>
+            </a:r>
+            <a:endParaRPr lang="nl-NL" dirty="0"/>
+          </a:p>
+        </p:txBody>
+      </p:sp>
+      <p:cxnSp>
+        <p:nvCxnSpPr>
+          <p:cNvPr id="14" name="Straight Arrow Connector 13">
+            <a:extLst>
+              <a:ext uri="{FF2B5EF4-FFF2-40B4-BE49-F238E27FC236}">
+                <a16:creationId xmlns:a16="http://schemas.microsoft.com/office/drawing/2014/main" id="{E5BC7136-27F3-4AF0-A650-313ACCC5D9F3}"/>
+              </a:ext>
+            </a:extLst>
+          </p:cNvPr>
+          <p:cNvCxnSpPr>
+            <a:stCxn id="8" idx="3"/>
+            <a:endCxn id="11" idx="1"/>
+          </p:cNvCxnSpPr>
+          <p:nvPr/>
+        </p:nvCxnSpPr>
+        <p:spPr>
+          <a:xfrm>
+            <a:off x="5959641" y="3422120"/>
+            <a:ext cx="914402" cy="6880"/>
+          </a:xfrm>
+          <a:prstGeom prst="straightConnector1">
+            <a:avLst/>
+          </a:prstGeom>
+          <a:ln>
+            <a:tailEnd type="triangle"/>
+          </a:ln>
+        </p:spPr>
+        <p:style>
+          <a:lnRef idx="1">
+            <a:schemeClr val="accent1"/>
+          </a:lnRef>
+          <a:fillRef idx="0">
+            <a:schemeClr val="accent1"/>
+          </a:fillRef>
+          <a:effectRef idx="0">
+            <a:schemeClr val="accent1"/>
+          </a:effectRef>
+          <a:fontRef idx="minor">
+            <a:schemeClr val="tx1"/>
+          </a:fontRef>
+        </p:style>
+      </p:cxnSp>
+      <p:pic>
+        <p:nvPicPr>
+          <p:cNvPr id="16" name="Graphic 15" descr="Database">
+            <a:extLst>
+              <a:ext uri="{FF2B5EF4-FFF2-40B4-BE49-F238E27FC236}">
+                <a16:creationId xmlns:a16="http://schemas.microsoft.com/office/drawing/2014/main" id="{CFA01DF2-1837-46C5-9A16-1B6A46866A9D}"/>
+              </a:ext>
+            </a:extLst>
+          </p:cNvPr>
+          <p:cNvPicPr>
+            <a:picLocks noChangeAspect="1"/>
+          </p:cNvPicPr>
+          <p:nvPr/>
+        </p:nvPicPr>
+        <p:blipFill>
+          <a:blip r:embed="rId2">
+            <a:extLst>
+              <a:ext uri="{28A0092B-C50C-407E-A947-70E740481C1C}">
+                <a14:useLocalDpi xmlns:a14="http://schemas.microsoft.com/office/drawing/2010/main" val="0"/>
+              </a:ext>
+              <a:ext uri="{96DAC541-7B7A-43D3-8B79-37D633B846F1}">
+                <asvg:svgBlip xmlns:asvg="http://schemas.microsoft.com/office/drawing/2016/SVG/main" r:embed="rId3"/>
+              </a:ext>
+            </a:extLst>
+          </a:blip>
+          <a:stretch>
+            <a:fillRect/>
+          </a:stretch>
+        </p:blipFill>
+        <p:spPr>
+          <a:xfrm>
+            <a:off x="9841833" y="2964920"/>
+            <a:ext cx="914400" cy="914400"/>
+          </a:xfrm>
+          <a:prstGeom prst="rect">
+            <a:avLst/>
+          </a:prstGeom>
+        </p:spPr>
+      </p:pic>
+      <p:cxnSp>
+        <p:nvCxnSpPr>
+          <p:cNvPr id="18" name="Straight Arrow Connector 17">
+            <a:extLst>
+              <a:ext uri="{FF2B5EF4-FFF2-40B4-BE49-F238E27FC236}">
+                <a16:creationId xmlns:a16="http://schemas.microsoft.com/office/drawing/2014/main" id="{D9696F83-8425-432B-8C85-9DE9D194F48A}"/>
+              </a:ext>
+            </a:extLst>
+          </p:cNvPr>
+          <p:cNvCxnSpPr>
+            <a:cxnSpLocks/>
+            <a:stCxn id="11" idx="3"/>
+            <a:endCxn id="16" idx="1"/>
+          </p:cNvCxnSpPr>
+          <p:nvPr/>
+        </p:nvCxnSpPr>
+        <p:spPr>
+          <a:xfrm flipV="1">
+            <a:off x="8462211" y="3422120"/>
+            <a:ext cx="1379622" cy="6880"/>
+          </a:xfrm>
+          <a:prstGeom prst="straightConnector1">
+            <a:avLst/>
+          </a:prstGeom>
+          <a:ln>
+            <a:tailEnd type="triangle"/>
+          </a:ln>
+        </p:spPr>
+        <p:style>
+          <a:lnRef idx="1">
+            <a:schemeClr val="accent1"/>
+          </a:lnRef>
+          <a:fillRef idx="0">
+            <a:schemeClr val="accent1"/>
+          </a:fillRef>
+          <a:effectRef idx="0">
+            <a:schemeClr val="accent1"/>
+          </a:effectRef>
+          <a:fontRef idx="minor">
+            <a:schemeClr val="tx1"/>
+          </a:fontRef>
+        </p:style>
+      </p:cxnSp>
+      <p:sp>
+        <p:nvSpPr>
+          <p:cNvPr id="21" name="TextBox 20">
+            <a:extLst>
+              <a:ext uri="{FF2B5EF4-FFF2-40B4-BE49-F238E27FC236}">
+                <a16:creationId xmlns:a16="http://schemas.microsoft.com/office/drawing/2014/main" id="{A5A0CE27-29B8-440B-BD89-3EC604551F54}"/>
+              </a:ext>
+            </a:extLst>
+          </p:cNvPr>
+          <p:cNvSpPr txBox="1"/>
+          <p:nvPr/>
+        </p:nvSpPr>
+        <p:spPr>
+          <a:xfrm>
+            <a:off x="9220201" y="2602468"/>
+            <a:ext cx="2157664" cy="369332"/>
+          </a:xfrm>
+          <a:prstGeom prst="rect">
+            <a:avLst/>
+          </a:prstGeom>
+          <a:noFill/>
+        </p:spPr>
+        <p:txBody>
+          <a:bodyPr wrap="square" rtlCol="0">
+            <a:spAutoFit/>
+          </a:bodyPr>
+          <a:lstStyle/>
+          <a:p>
+            <a:pPr algn="ctr"/>
+            <a:r>
+              <a:rPr lang="it-IT" dirty="0"/>
+              <a:t>Complete Data</a:t>
+            </a:r>
+            <a:endParaRPr lang="nl-NL" dirty="0"/>
+          </a:p>
+        </p:txBody>
+      </p:sp>
+      <p:sp>
+        <p:nvSpPr>
+          <p:cNvPr id="22" name="Oval 21">
+            <a:extLst>
+              <a:ext uri="{FF2B5EF4-FFF2-40B4-BE49-F238E27FC236}">
+                <a16:creationId xmlns:a16="http://schemas.microsoft.com/office/drawing/2014/main" id="{D3304676-921B-4925-BDF9-B8B88E00BC32}"/>
+              </a:ext>
+            </a:extLst>
+          </p:cNvPr>
+          <p:cNvSpPr/>
+          <p:nvPr/>
+        </p:nvSpPr>
+        <p:spPr>
+          <a:xfrm>
+            <a:off x="1772651" y="3508347"/>
+            <a:ext cx="192505" cy="192505"/>
+          </a:xfrm>
+          <a:prstGeom prst="ellipse">
+            <a:avLst/>
+          </a:prstGeom>
+          <a:solidFill>
+            <a:schemeClr val="bg1"/>
+          </a:solidFill>
+          <a:ln>
+            <a:solidFill>
+              <a:schemeClr val="bg1"/>
+            </a:solidFill>
+          </a:ln>
+        </p:spPr>
+        <p:style>
+          <a:lnRef idx="2">
+            <a:schemeClr val="accent1">
+              <a:shade val="50000"/>
+            </a:schemeClr>
+          </a:lnRef>
+          <a:fillRef idx="1">
+            <a:schemeClr val="accent1"/>
+          </a:fillRef>
+          <a:effectRef idx="0">
+            <a:schemeClr val="accent1"/>
+          </a:effectRef>
+          <a:fontRef idx="minor">
+            <a:schemeClr val="lt1"/>
+          </a:fontRef>
+        </p:style>
+        <p:txBody>
+          <a:bodyPr rtlCol="0" anchor="ctr"/>
+          <a:lstStyle/>
+          <a:p>
+            <a:pPr algn="ctr"/>
+            <a:endParaRPr lang="nl-NL"/>
+          </a:p>
+        </p:txBody>
+      </p:sp>
+      <p:sp>
+        <p:nvSpPr>
+          <p:cNvPr id="23" name="Oval 22">
+            <a:extLst>
+              <a:ext uri="{FF2B5EF4-FFF2-40B4-BE49-F238E27FC236}">
+                <a16:creationId xmlns:a16="http://schemas.microsoft.com/office/drawing/2014/main" id="{A69C32AA-03CD-473E-B6C7-9E2DC28AAEE0}"/>
+              </a:ext>
+            </a:extLst>
+          </p:cNvPr>
+          <p:cNvSpPr/>
+          <p:nvPr/>
+        </p:nvSpPr>
+        <p:spPr>
+          <a:xfrm>
+            <a:off x="2045367" y="3303809"/>
+            <a:ext cx="192505" cy="192505"/>
+          </a:xfrm>
+          <a:prstGeom prst="ellipse">
+            <a:avLst/>
+          </a:prstGeom>
+          <a:solidFill>
+            <a:schemeClr val="bg1"/>
+          </a:solidFill>
+          <a:ln>
+            <a:solidFill>
+              <a:schemeClr val="bg1"/>
+            </a:solidFill>
+          </a:ln>
+        </p:spPr>
+        <p:style>
+          <a:lnRef idx="2">
+            <a:schemeClr val="accent1">
+              <a:shade val="50000"/>
+            </a:schemeClr>
+          </a:lnRef>
+          <a:fillRef idx="1">
+            <a:schemeClr val="accent1"/>
+          </a:fillRef>
+          <a:effectRef idx="0">
+            <a:schemeClr val="accent1"/>
+          </a:effectRef>
+          <a:fontRef idx="minor">
+            <a:schemeClr val="lt1"/>
+          </a:fontRef>
+        </p:style>
+        <p:txBody>
+          <a:bodyPr rtlCol="0" anchor="ctr"/>
+          <a:lstStyle/>
+          <a:p>
+            <a:pPr algn="ctr"/>
+            <a:endParaRPr lang="nl-NL"/>
+          </a:p>
+        </p:txBody>
+      </p:sp>
+      <p:sp>
+        <p:nvSpPr>
+          <p:cNvPr id="24" name="Oval 23">
+            <a:extLst>
+              <a:ext uri="{FF2B5EF4-FFF2-40B4-BE49-F238E27FC236}">
+                <a16:creationId xmlns:a16="http://schemas.microsoft.com/office/drawing/2014/main" id="{D9BD3E5E-5C45-4437-96FD-C757152F3A79}"/>
+              </a:ext>
+            </a:extLst>
+          </p:cNvPr>
+          <p:cNvSpPr/>
+          <p:nvPr/>
+        </p:nvSpPr>
+        <p:spPr>
+          <a:xfrm>
+            <a:off x="2237872" y="3623286"/>
+            <a:ext cx="192505" cy="192505"/>
+          </a:xfrm>
+          <a:prstGeom prst="ellipse">
+            <a:avLst/>
+          </a:prstGeom>
+          <a:solidFill>
+            <a:schemeClr val="bg1"/>
+          </a:solidFill>
+          <a:ln>
+            <a:solidFill>
+              <a:schemeClr val="bg1"/>
+            </a:solidFill>
+          </a:ln>
+        </p:spPr>
+        <p:style>
+          <a:lnRef idx="2">
+            <a:schemeClr val="accent1">
+              <a:shade val="50000"/>
+            </a:schemeClr>
+          </a:lnRef>
+          <a:fillRef idx="1">
+            <a:schemeClr val="accent1"/>
+          </a:fillRef>
+          <a:effectRef idx="0">
+            <a:schemeClr val="accent1"/>
+          </a:effectRef>
+          <a:fontRef idx="minor">
+            <a:schemeClr val="lt1"/>
+          </a:fontRef>
+        </p:style>
+        <p:txBody>
+          <a:bodyPr rtlCol="0" anchor="ctr"/>
+          <a:lstStyle/>
+          <a:p>
+            <a:pPr algn="ctr"/>
+            <a:endParaRPr lang="nl-NL"/>
+          </a:p>
+        </p:txBody>
+      </p:sp>
+    </p:spTree>
+    <p:extLst>
+      <p:ext uri="{BB962C8B-B14F-4D97-AF65-F5344CB8AC3E}">
+        <p14:creationId xmlns:p14="http://schemas.microsoft.com/office/powerpoint/2010/main" val="2980898789"/>
+      </p:ext>
+    </p:extLst>
+  </p:cSld>
+  <p:clrMapOvr>
+    <a:masterClrMapping/>
+  </p:clrMapOvr>
+  <mc:AlternateContent xmlns:mc="http://schemas.openxmlformats.org/markup-compatibility/2006" xmlns:p159="http://schemas.microsoft.com/office/powerpoint/2015/09/main">
+    <mc:Choice Requires="p159">
+      <p:transition spd="slow">
+        <p159:morph option="byObject"/>
+      </p:transition>
+    </mc:Choice>
+    <mc:Fallback xmlns="">
+      <p:transition spd="slow">
+        <p:fade/>
+      </p:transition>
+    </mc:Fallback>
+  </mc:AlternateContent>
+</p:sld>
+</file>
+
+<file path=ppt/slides/slide24.xml><?xml version="1.0" encoding="utf-8"?>
+<p:sld xmlns:a="http://schemas.openxmlformats.org/drawingml/2006/main" xmlns:r="http://schemas.openxmlformats.org/officeDocument/2006/relationships" xmlns:p="http://schemas.openxmlformats.org/presentationml/2006/main">
+  <p:cSld>
+    <p:spTree>
+      <p:nvGrpSpPr>
+        <p:cNvPr id="1" name=""/>
+        <p:cNvGrpSpPr/>
+        <p:nvPr/>
+      </p:nvGrpSpPr>
+      <p:grpSpPr>
+        <a:xfrm>
+          <a:off x="0" y="0"/>
+          <a:ext cx="0" cy="0"/>
+          <a:chOff x="0" y="0"/>
+          <a:chExt cx="0" cy="0"/>
+        </a:xfrm>
+      </p:grpSpPr>
+      <p:pic>
+        <p:nvPicPr>
+          <p:cNvPr id="3" name="Picture 2">
+            <a:extLst>
+              <a:ext uri="{FF2B5EF4-FFF2-40B4-BE49-F238E27FC236}">
+                <a16:creationId xmlns:a16="http://schemas.microsoft.com/office/drawing/2014/main" id="{B65D2315-51B1-4287-BCA6-D30549C2831D}"/>
+              </a:ext>
+            </a:extLst>
+          </p:cNvPr>
+          <p:cNvPicPr>
+            <a:picLocks noChangeAspect="1"/>
+          </p:cNvPicPr>
+          <p:nvPr/>
+        </p:nvPicPr>
+        <p:blipFill>
+          <a:blip r:embed="rId2">
+            <a:extLst>
+              <a:ext uri="{28A0092B-C50C-407E-A947-70E740481C1C}">
+                <a14:useLocalDpi xmlns:a14="http://schemas.microsoft.com/office/drawing/2010/main" val="0"/>
+              </a:ext>
+            </a:extLst>
+          </a:blip>
+          <a:stretch>
+            <a:fillRect/>
+          </a:stretch>
+        </p:blipFill>
+        <p:spPr>
+          <a:xfrm>
+            <a:off x="2491335" y="725501"/>
+            <a:ext cx="7209329" cy="5406997"/>
+          </a:xfrm>
+          <a:prstGeom prst="rect">
+            <a:avLst/>
+          </a:prstGeom>
+        </p:spPr>
+      </p:pic>
+      <p:sp>
+        <p:nvSpPr>
+          <p:cNvPr id="4" name="TextBox 3">
+            <a:extLst>
+              <a:ext uri="{FF2B5EF4-FFF2-40B4-BE49-F238E27FC236}">
+                <a16:creationId xmlns:a16="http://schemas.microsoft.com/office/drawing/2014/main" id="{0A5CCA7C-FF14-4AD7-8D60-609EC3986411}"/>
+              </a:ext>
+            </a:extLst>
+          </p:cNvPr>
+          <p:cNvSpPr txBox="1"/>
+          <p:nvPr/>
+        </p:nvSpPr>
+        <p:spPr>
+          <a:xfrm>
+            <a:off x="0" y="0"/>
+            <a:ext cx="3457074" cy="369332"/>
+          </a:xfrm>
+          <a:prstGeom prst="rect">
+            <a:avLst/>
+          </a:prstGeom>
+          <a:noFill/>
+        </p:spPr>
+        <p:txBody>
+          <a:bodyPr wrap="square" rtlCol="0">
+            <a:spAutoFit/>
+          </a:bodyPr>
+          <a:lstStyle/>
+          <a:p>
+            <a:r>
+              <a:rPr lang="it-IT" u="sng" dirty="0"/>
+              <a:t>MICE Forest Imputed Distributions</a:t>
+            </a:r>
+            <a:endParaRPr lang="nl-NL" u="sng" dirty="0"/>
+          </a:p>
+        </p:txBody>
+      </p:sp>
+    </p:spTree>
+    <p:extLst>
+      <p:ext uri="{BB962C8B-B14F-4D97-AF65-F5344CB8AC3E}">
+        <p14:creationId xmlns:p14="http://schemas.microsoft.com/office/powerpoint/2010/main" val="1751319707"/>
+      </p:ext>
+    </p:extLst>
+  </p:cSld>
+  <p:clrMapOvr>
+    <a:masterClrMapping/>
+  </p:clrMapOvr>
+  <mc:AlternateContent xmlns:mc="http://schemas.openxmlformats.org/markup-compatibility/2006" xmlns:p159="http://schemas.microsoft.com/office/powerpoint/2015/09/main">
+    <mc:Choice Requires="p159">
+      <p:transition spd="slow">
+        <p159:morph option="byObject"/>
+      </p:transition>
+    </mc:Choice>
+    <mc:Fallback xmlns="">
+      <p:transition spd="slow">
+        <p:fade/>
+      </p:transition>
+    </mc:Fallback>
+  </mc:AlternateContent>
+</p:sld>
+</file>
+
+<file path=ppt/slides/slide25.xml><?xml version="1.0" encoding="utf-8"?>
+<p:sld xmlns:a="http://schemas.openxmlformats.org/drawingml/2006/main" xmlns:r="http://schemas.openxmlformats.org/officeDocument/2006/relationships" xmlns:p="http://schemas.openxmlformats.org/presentationml/2006/main">
+  <p:cSld>
+    <p:spTree>
+      <p:nvGrpSpPr>
+        <p:cNvPr id="1" name=""/>
+        <p:cNvGrpSpPr/>
+        <p:nvPr/>
+      </p:nvGrpSpPr>
+      <p:grpSpPr>
+        <a:xfrm>
+          <a:off x="0" y="0"/>
+          <a:ext cx="0" cy="0"/>
+          <a:chOff x="0" y="0"/>
+          <a:chExt cx="0" cy="0"/>
+        </a:xfrm>
+      </p:grpSpPr>
+      <p:pic>
+        <p:nvPicPr>
+          <p:cNvPr id="3" name="Picture 2">
+            <a:extLst>
+              <a:ext uri="{FF2B5EF4-FFF2-40B4-BE49-F238E27FC236}">
+                <a16:creationId xmlns:a16="http://schemas.microsoft.com/office/drawing/2014/main" id="{B65D2315-51B1-4287-BCA6-D30549C2831D}"/>
+              </a:ext>
+            </a:extLst>
+          </p:cNvPr>
+          <p:cNvPicPr>
+            <a:picLocks noChangeAspect="1"/>
+          </p:cNvPicPr>
+          <p:nvPr/>
+        </p:nvPicPr>
+        <p:blipFill>
+          <a:blip r:embed="rId2">
+            <a:extLst>
+              <a:ext uri="{28A0092B-C50C-407E-A947-70E740481C1C}">
+                <a14:useLocalDpi xmlns:a14="http://schemas.microsoft.com/office/drawing/2010/main" val="0"/>
+              </a:ext>
+            </a:extLst>
+          </a:blip>
+          <a:stretch>
+            <a:fillRect/>
+          </a:stretch>
+        </p:blipFill>
+        <p:spPr>
+          <a:xfrm>
+            <a:off x="518158" y="725501"/>
+            <a:ext cx="7209329" cy="5406997"/>
+          </a:xfrm>
+          <a:prstGeom prst="rect">
+            <a:avLst/>
+          </a:prstGeom>
+        </p:spPr>
+      </p:pic>
+      <p:sp>
+        <p:nvSpPr>
+          <p:cNvPr id="4" name="TextBox 3">
+            <a:extLst>
+              <a:ext uri="{FF2B5EF4-FFF2-40B4-BE49-F238E27FC236}">
+                <a16:creationId xmlns:a16="http://schemas.microsoft.com/office/drawing/2014/main" id="{0A5CCA7C-FF14-4AD7-8D60-609EC3986411}"/>
+              </a:ext>
+            </a:extLst>
+          </p:cNvPr>
+          <p:cNvSpPr txBox="1"/>
+          <p:nvPr/>
+        </p:nvSpPr>
+        <p:spPr>
+          <a:xfrm>
+            <a:off x="0" y="0"/>
+            <a:ext cx="3457074" cy="369332"/>
+          </a:xfrm>
+          <a:prstGeom prst="rect">
+            <a:avLst/>
+          </a:prstGeom>
+          <a:noFill/>
+        </p:spPr>
+        <p:txBody>
+          <a:bodyPr wrap="square" rtlCol="0">
+            <a:spAutoFit/>
+          </a:bodyPr>
+          <a:lstStyle/>
+          <a:p>
+            <a:r>
+              <a:rPr lang="it-IT" u="sng" dirty="0"/>
+              <a:t>MICE Forest Imputed Distributions</a:t>
+            </a:r>
+            <a:endParaRPr lang="nl-NL" u="sng" dirty="0"/>
+          </a:p>
+        </p:txBody>
+      </p:sp>
+      <p:sp>
+        <p:nvSpPr>
+          <p:cNvPr id="2" name="TextBox 1">
+            <a:extLst>
+              <a:ext uri="{FF2B5EF4-FFF2-40B4-BE49-F238E27FC236}">
+                <a16:creationId xmlns:a16="http://schemas.microsoft.com/office/drawing/2014/main" id="{01856716-7E6F-49FD-A372-2EF5C92D3712}"/>
+              </a:ext>
+            </a:extLst>
+          </p:cNvPr>
+          <p:cNvSpPr txBox="1"/>
+          <p:nvPr/>
+        </p:nvSpPr>
+        <p:spPr>
+          <a:xfrm>
+            <a:off x="8598568" y="2895600"/>
+            <a:ext cx="2871537" cy="369332"/>
+          </a:xfrm>
+          <a:prstGeom prst="rect">
+            <a:avLst/>
+          </a:prstGeom>
+          <a:noFill/>
+        </p:spPr>
+        <p:txBody>
+          <a:bodyPr wrap="square" rtlCol="0">
+            <a:spAutoFit/>
+          </a:bodyPr>
+          <a:lstStyle/>
+          <a:p>
+            <a:r>
+              <a:rPr lang="it-IT" dirty="0"/>
+              <a:t>Is this acceptable?</a:t>
+            </a:r>
+            <a:endParaRPr lang="nl-NL" dirty="0"/>
+          </a:p>
+        </p:txBody>
+      </p:sp>
+    </p:spTree>
+    <p:extLst>
+      <p:ext uri="{BB962C8B-B14F-4D97-AF65-F5344CB8AC3E}">
+        <p14:creationId xmlns:p14="http://schemas.microsoft.com/office/powerpoint/2010/main" val="3402397846"/>
+      </p:ext>
+    </p:extLst>
+  </p:cSld>
+  <p:clrMapOvr>
+    <a:masterClrMapping/>
+  </p:clrMapOvr>
+  <mc:AlternateContent xmlns:mc="http://schemas.openxmlformats.org/markup-compatibility/2006" xmlns:p159="http://schemas.microsoft.com/office/powerpoint/2015/09/main">
+    <mc:Choice Requires="p159">
+      <p:transition spd="slow">
+        <p159:morph option="byObject"/>
+      </p:transition>
+    </mc:Choice>
+    <mc:Fallback xmlns="">
+      <p:transition spd="slow">
+        <p:fade/>
+      </p:transition>
+    </mc:Fallback>
+  </mc:AlternateContent>
+</p:sld>
+</file>
+
+<file path=ppt/slides/slide26.xml><?xml version="1.0" encoding="utf-8"?>
+<p:sld xmlns:a="http://schemas.openxmlformats.org/drawingml/2006/main" xmlns:r="http://schemas.openxmlformats.org/officeDocument/2006/relationships" xmlns:p="http://schemas.openxmlformats.org/presentationml/2006/main">
+  <p:cSld>
+    <p:spTree>
+      <p:nvGrpSpPr>
+        <p:cNvPr id="1" name=""/>
+        <p:cNvGrpSpPr/>
+        <p:nvPr/>
+      </p:nvGrpSpPr>
+      <p:grpSpPr>
+        <a:xfrm>
+          <a:off x="0" y="0"/>
+          <a:ext cx="0" cy="0"/>
+          <a:chOff x="0" y="0"/>
+          <a:chExt cx="0" cy="0"/>
+        </a:xfrm>
+      </p:grpSpPr>
+      <p:sp>
+        <p:nvSpPr>
           <p:cNvPr id="2" name="Title 1">
             <a:extLst>
               <a:ext uri="{FF2B5EF4-FFF2-40B4-BE49-F238E27FC236}">
@@ -9298,7 +10302,7 @@
 </p:sld>
 </file>
 
-<file path=ppt/slides/slide23.xml><?xml version="1.0" encoding="utf-8"?>
+<file path=ppt/slides/slide27.xml><?xml version="1.0" encoding="utf-8"?>
 <p:sld xmlns:a="http://schemas.openxmlformats.org/drawingml/2006/main" xmlns:r="http://schemas.openxmlformats.org/officeDocument/2006/relationships" xmlns:p="http://schemas.openxmlformats.org/presentationml/2006/main">
   <p:cSld>
     <p:spTree>
@@ -9340,7 +10344,7 @@
 </p:sld>
 </file>
 
-<file path=ppt/slides/slide24.xml><?xml version="1.0" encoding="utf-8"?>
+<file path=ppt/slides/slide28.xml><?xml version="1.0" encoding="utf-8"?>
 <p:sld xmlns:a="http://schemas.openxmlformats.org/drawingml/2006/main" xmlns:r="http://schemas.openxmlformats.org/officeDocument/2006/relationships" xmlns:p="http://schemas.openxmlformats.org/presentationml/2006/main">
   <p:cSld>
     <p:spTree>
@@ -9436,7 +10440,7 @@
 </p:sld>
 </file>
 
-<file path=ppt/slides/slide25.xml><?xml version="1.0" encoding="utf-8"?>
+<file path=ppt/slides/slide29.xml><?xml version="1.0" encoding="utf-8"?>
 <p:sld xmlns:a="http://schemas.openxmlformats.org/drawingml/2006/main" xmlns:r="http://schemas.openxmlformats.org/officeDocument/2006/relationships" xmlns:p="http://schemas.openxmlformats.org/presentationml/2006/main">
   <p:cSld>
     <p:spTree>
@@ -9478,1285 +10482,6 @@
 </p:sld>
 </file>
 
-<file path=ppt/slides/slide26.xml><?xml version="1.0" encoding="utf-8"?>
-<p:sld xmlns:a="http://schemas.openxmlformats.org/drawingml/2006/main" xmlns:r="http://schemas.openxmlformats.org/officeDocument/2006/relationships" xmlns:p="http://schemas.openxmlformats.org/presentationml/2006/main">
-  <p:cSld>
-    <p:spTree>
-      <p:nvGrpSpPr>
-        <p:cNvPr id="1" name=""/>
-        <p:cNvGrpSpPr/>
-        <p:nvPr/>
-      </p:nvGrpSpPr>
-      <p:grpSpPr>
-        <a:xfrm>
-          <a:off x="0" y="0"/>
-          <a:ext cx="0" cy="0"/>
-          <a:chOff x="0" y="0"/>
-          <a:chExt cx="0" cy="0"/>
-        </a:xfrm>
-      </p:grpSpPr>
-      <p:sp>
-        <p:nvSpPr>
-          <p:cNvPr id="2" name="Title 1">
-            <a:extLst>
-              <a:ext uri="{FF2B5EF4-FFF2-40B4-BE49-F238E27FC236}">
-                <a16:creationId xmlns:a16="http://schemas.microsoft.com/office/drawing/2014/main" id="{6D37F963-7349-4DE3-A960-EEBD333A4E61}"/>
-              </a:ext>
-            </a:extLst>
-          </p:cNvPr>
-          <p:cNvSpPr txBox="1">
-            <a:spLocks/>
-          </p:cNvSpPr>
-          <p:nvPr/>
-        </p:nvSpPr>
-        <p:spPr>
-          <a:xfrm>
-            <a:off x="1524000" y="2235200"/>
-            <a:ext cx="9144000" cy="2387600"/>
-          </a:xfrm>
-          <a:prstGeom prst="rect">
-            <a:avLst/>
-          </a:prstGeom>
-        </p:spPr>
-        <p:txBody>
-          <a:bodyPr anchor="ctr"/>
-          <a:lstStyle>
-            <a:lvl1pPr algn="l" defTabSz="914400" rtl="0" eaLnBrk="1" latinLnBrk="0" hangingPunct="1">
-              <a:lnSpc>
-                <a:spcPct val="90000"/>
-              </a:lnSpc>
-              <a:spcBef>
-                <a:spcPct val="0"/>
-              </a:spcBef>
-              <a:buNone/>
-              <a:defRPr sz="4400" kern="1200">
-                <a:solidFill>
-                  <a:schemeClr val="tx1"/>
-                </a:solidFill>
-                <a:latin typeface="+mj-lt"/>
-                <a:ea typeface="+mj-ea"/>
-                <a:cs typeface="+mj-cs"/>
-              </a:defRPr>
-            </a:lvl1pPr>
-          </a:lstStyle>
-          <a:p>
-            <a:pPr algn="ctr"/>
-            <a:r>
-              <a:rPr lang="it-IT" dirty="0"/>
-              <a:t>Blood Pressure Readings</a:t>
-            </a:r>
-            <a:endParaRPr lang="nl-NL" dirty="0"/>
-          </a:p>
-        </p:txBody>
-      </p:sp>
-    </p:spTree>
-    <p:extLst>
-      <p:ext uri="{BB962C8B-B14F-4D97-AF65-F5344CB8AC3E}">
-        <p14:creationId xmlns:p14="http://schemas.microsoft.com/office/powerpoint/2010/main" val="603692568"/>
-      </p:ext>
-    </p:extLst>
-  </p:cSld>
-  <p:clrMapOvr>
-    <a:masterClrMapping/>
-  </p:clrMapOvr>
-  <mc:AlternateContent xmlns:mc="http://schemas.openxmlformats.org/markup-compatibility/2006" xmlns:p159="http://schemas.microsoft.com/office/powerpoint/2015/09/main">
-    <mc:Choice Requires="p159">
-      <p:transition spd="slow">
-        <p159:morph option="byObject"/>
-      </p:transition>
-    </mc:Choice>
-    <mc:Fallback xmlns="">
-      <p:transition spd="slow">
-        <p:fade/>
-      </p:transition>
-    </mc:Fallback>
-  </mc:AlternateContent>
-</p:sld>
-</file>
-
-<file path=ppt/slides/slide27.xml><?xml version="1.0" encoding="utf-8"?>
-<p:sld xmlns:a="http://schemas.openxmlformats.org/drawingml/2006/main" xmlns:r="http://schemas.openxmlformats.org/officeDocument/2006/relationships" xmlns:p="http://schemas.openxmlformats.org/presentationml/2006/main">
-  <p:cSld>
-    <p:spTree>
-      <p:nvGrpSpPr>
-        <p:cNvPr id="1" name=""/>
-        <p:cNvGrpSpPr/>
-        <p:nvPr/>
-      </p:nvGrpSpPr>
-      <p:grpSpPr>
-        <a:xfrm>
-          <a:off x="0" y="0"/>
-          <a:ext cx="0" cy="0"/>
-          <a:chOff x="0" y="0"/>
-          <a:chExt cx="0" cy="0"/>
-        </a:xfrm>
-      </p:grpSpPr>
-      <p:sp>
-        <p:nvSpPr>
-          <p:cNvPr id="2" name="TextBox 1">
-            <a:extLst>
-              <a:ext uri="{FF2B5EF4-FFF2-40B4-BE49-F238E27FC236}">
-                <a16:creationId xmlns:a16="http://schemas.microsoft.com/office/drawing/2014/main" id="{CC0200F0-ABFF-45F8-A6F5-9F8372AE5C7D}"/>
-              </a:ext>
-            </a:extLst>
-          </p:cNvPr>
-          <p:cNvSpPr txBox="1"/>
-          <p:nvPr/>
-        </p:nvSpPr>
-        <p:spPr>
-          <a:xfrm>
-            <a:off x="0" y="0"/>
-            <a:ext cx="4395537" cy="369332"/>
-          </a:xfrm>
-          <a:prstGeom prst="rect">
-            <a:avLst/>
-          </a:prstGeom>
-          <a:noFill/>
-        </p:spPr>
-        <p:txBody>
-          <a:bodyPr wrap="square" rtlCol="0">
-            <a:spAutoFit/>
-          </a:bodyPr>
-          <a:lstStyle/>
-          <a:p>
-            <a:r>
-              <a:rPr lang="it-IT" u="sng" dirty="0"/>
-              <a:t>Blood Pressure Measurements - Outliers</a:t>
-            </a:r>
-            <a:endParaRPr lang="nl-NL" u="sng" dirty="0"/>
-          </a:p>
-        </p:txBody>
-      </p:sp>
-      <p:pic>
-        <p:nvPicPr>
-          <p:cNvPr id="4" name="Picture 3">
-            <a:extLst>
-              <a:ext uri="{FF2B5EF4-FFF2-40B4-BE49-F238E27FC236}">
-                <a16:creationId xmlns:a16="http://schemas.microsoft.com/office/drawing/2014/main" id="{B141D145-8AC1-45C7-8D61-50D4BD1CC9DF}"/>
-              </a:ext>
-            </a:extLst>
-          </p:cNvPr>
-          <p:cNvPicPr>
-            <a:picLocks noChangeAspect="1"/>
-          </p:cNvPicPr>
-          <p:nvPr/>
-        </p:nvPicPr>
-        <p:blipFill>
-          <a:blip r:embed="rId2">
-            <a:extLst>
-              <a:ext uri="{28A0092B-C50C-407E-A947-70E740481C1C}">
-                <a14:useLocalDpi xmlns:a14="http://schemas.microsoft.com/office/drawing/2010/main" val="0"/>
-              </a:ext>
-            </a:extLst>
-          </a:blip>
-          <a:stretch>
-            <a:fillRect/>
-          </a:stretch>
-        </p:blipFill>
-        <p:spPr>
-          <a:xfrm>
-            <a:off x="6186458" y="1957137"/>
-            <a:ext cx="6005542" cy="3649580"/>
-          </a:xfrm>
-          <a:prstGeom prst="rect">
-            <a:avLst/>
-          </a:prstGeom>
-        </p:spPr>
-      </p:pic>
-      <p:pic>
-        <p:nvPicPr>
-          <p:cNvPr id="8" name="Picture 7">
-            <a:extLst>
-              <a:ext uri="{FF2B5EF4-FFF2-40B4-BE49-F238E27FC236}">
-                <a16:creationId xmlns:a16="http://schemas.microsoft.com/office/drawing/2014/main" id="{B78D7C7E-C973-4558-835C-AE7A82ECC7EF}"/>
-              </a:ext>
-            </a:extLst>
-          </p:cNvPr>
-          <p:cNvPicPr>
-            <a:picLocks noChangeAspect="1"/>
-          </p:cNvPicPr>
-          <p:nvPr/>
-        </p:nvPicPr>
-        <p:blipFill>
-          <a:blip r:embed="rId3">
-            <a:extLst>
-              <a:ext uri="{28A0092B-C50C-407E-A947-70E740481C1C}">
-                <a14:useLocalDpi xmlns:a14="http://schemas.microsoft.com/office/drawing/2010/main" val="0"/>
-              </a:ext>
-            </a:extLst>
-          </a:blip>
-          <a:stretch>
-            <a:fillRect/>
-          </a:stretch>
-        </p:blipFill>
-        <p:spPr>
-          <a:xfrm>
-            <a:off x="14258" y="1957137"/>
-            <a:ext cx="6005542" cy="3649580"/>
-          </a:xfrm>
-          <a:prstGeom prst="rect">
-            <a:avLst/>
-          </a:prstGeom>
-        </p:spPr>
-      </p:pic>
-      <p:cxnSp>
-        <p:nvCxnSpPr>
-          <p:cNvPr id="10" name="Straight Arrow Connector 9">
-            <a:extLst>
-              <a:ext uri="{FF2B5EF4-FFF2-40B4-BE49-F238E27FC236}">
-                <a16:creationId xmlns:a16="http://schemas.microsoft.com/office/drawing/2014/main" id="{D2D21716-6BD7-4A50-9558-0D0C13985C2D}"/>
-              </a:ext>
-            </a:extLst>
-          </p:cNvPr>
-          <p:cNvCxnSpPr>
-            <a:cxnSpLocks/>
-            <a:stCxn id="13" idx="2"/>
-            <a:endCxn id="28" idx="7"/>
-          </p:cNvCxnSpPr>
-          <p:nvPr/>
-        </p:nvCxnSpPr>
-        <p:spPr>
-          <a:xfrm flipH="1">
-            <a:off x="1745476" y="1706964"/>
-            <a:ext cx="1271553" cy="618127"/>
-          </a:xfrm>
-          <a:prstGeom prst="straightConnector1">
-            <a:avLst/>
-          </a:prstGeom>
-          <a:ln>
-            <a:tailEnd type="triangle"/>
-          </a:ln>
-        </p:spPr>
-        <p:style>
-          <a:lnRef idx="3">
-            <a:schemeClr val="dk1"/>
-          </a:lnRef>
-          <a:fillRef idx="0">
-            <a:schemeClr val="dk1"/>
-          </a:fillRef>
-          <a:effectRef idx="2">
-            <a:schemeClr val="dk1"/>
-          </a:effectRef>
-          <a:fontRef idx="minor">
-            <a:schemeClr val="tx1"/>
-          </a:fontRef>
-        </p:style>
-      </p:cxnSp>
-      <p:cxnSp>
-        <p:nvCxnSpPr>
-          <p:cNvPr id="12" name="Straight Arrow Connector 11">
-            <a:extLst>
-              <a:ext uri="{FF2B5EF4-FFF2-40B4-BE49-F238E27FC236}">
-                <a16:creationId xmlns:a16="http://schemas.microsoft.com/office/drawing/2014/main" id="{8588E362-09B2-4B0B-BBDE-2EFEFF000F9B}"/>
-              </a:ext>
-            </a:extLst>
-          </p:cNvPr>
-          <p:cNvCxnSpPr>
-            <a:cxnSpLocks/>
-            <a:stCxn id="13" idx="2"/>
-            <a:endCxn id="30" idx="1"/>
-          </p:cNvCxnSpPr>
-          <p:nvPr/>
-        </p:nvCxnSpPr>
-        <p:spPr>
-          <a:xfrm>
-            <a:off x="3017029" y="1706964"/>
-            <a:ext cx="1532465" cy="797849"/>
-          </a:xfrm>
-          <a:prstGeom prst="straightConnector1">
-            <a:avLst/>
-          </a:prstGeom>
-          <a:ln>
-            <a:tailEnd type="triangle"/>
-          </a:ln>
-        </p:spPr>
-        <p:style>
-          <a:lnRef idx="3">
-            <a:schemeClr val="dk1"/>
-          </a:lnRef>
-          <a:fillRef idx="0">
-            <a:schemeClr val="dk1"/>
-          </a:fillRef>
-          <a:effectRef idx="2">
-            <a:schemeClr val="dk1"/>
-          </a:effectRef>
-          <a:fontRef idx="minor">
-            <a:schemeClr val="tx1"/>
-          </a:fontRef>
-        </p:style>
-      </p:cxnSp>
-      <p:sp>
-        <p:nvSpPr>
-          <p:cNvPr id="13" name="TextBox 12">
-            <a:extLst>
-              <a:ext uri="{FF2B5EF4-FFF2-40B4-BE49-F238E27FC236}">
-                <a16:creationId xmlns:a16="http://schemas.microsoft.com/office/drawing/2014/main" id="{6406D038-F66B-4859-9416-A23E4E34906D}"/>
-              </a:ext>
-            </a:extLst>
-          </p:cNvPr>
-          <p:cNvSpPr txBox="1"/>
-          <p:nvPr/>
-        </p:nvSpPr>
-        <p:spPr>
-          <a:xfrm>
-            <a:off x="1490242" y="1337632"/>
-            <a:ext cx="3053573" cy="369332"/>
-          </a:xfrm>
-          <a:prstGeom prst="rect">
-            <a:avLst/>
-          </a:prstGeom>
-          <a:noFill/>
-        </p:spPr>
-        <p:txBody>
-          <a:bodyPr wrap="square" rtlCol="0">
-            <a:spAutoFit/>
-          </a:bodyPr>
-          <a:lstStyle/>
-          <a:p>
-            <a:pPr algn="ctr"/>
-            <a:r>
-              <a:rPr lang="it-IT" dirty="0"/>
-              <a:t>Set to NaN... Imputation?</a:t>
-            </a:r>
-            <a:endParaRPr lang="nl-NL" dirty="0"/>
-          </a:p>
-        </p:txBody>
-      </p:sp>
-      <p:sp>
-        <p:nvSpPr>
-          <p:cNvPr id="14" name="TextBox 13">
-            <a:extLst>
-              <a:ext uri="{FF2B5EF4-FFF2-40B4-BE49-F238E27FC236}">
-                <a16:creationId xmlns:a16="http://schemas.microsoft.com/office/drawing/2014/main" id="{F98F7243-8499-4EB9-8006-57DE1509E5C3}"/>
-              </a:ext>
-            </a:extLst>
-          </p:cNvPr>
-          <p:cNvSpPr txBox="1"/>
-          <p:nvPr/>
-        </p:nvSpPr>
-        <p:spPr>
-          <a:xfrm>
-            <a:off x="8060265" y="1152966"/>
-            <a:ext cx="2229853" cy="369332"/>
-          </a:xfrm>
-          <a:prstGeom prst="rect">
-            <a:avLst/>
-          </a:prstGeom>
-          <a:noFill/>
-        </p:spPr>
-        <p:txBody>
-          <a:bodyPr wrap="square" rtlCol="0">
-            <a:spAutoFit/>
-          </a:bodyPr>
-          <a:lstStyle/>
-          <a:p>
-            <a:r>
-              <a:rPr lang="it-IT" dirty="0"/>
-              <a:t>Considered Outliers</a:t>
-            </a:r>
-            <a:endParaRPr lang="nl-NL" dirty="0"/>
-          </a:p>
-        </p:txBody>
-      </p:sp>
-      <p:cxnSp>
-        <p:nvCxnSpPr>
-          <p:cNvPr id="16" name="Straight Arrow Connector 15">
-            <a:extLst>
-              <a:ext uri="{FF2B5EF4-FFF2-40B4-BE49-F238E27FC236}">
-                <a16:creationId xmlns:a16="http://schemas.microsoft.com/office/drawing/2014/main" id="{EF44B29E-148B-46BB-A8FF-E530EC852232}"/>
-              </a:ext>
-            </a:extLst>
-          </p:cNvPr>
-          <p:cNvCxnSpPr>
-            <a:cxnSpLocks/>
-            <a:stCxn id="14" idx="2"/>
-          </p:cNvCxnSpPr>
-          <p:nvPr/>
-        </p:nvCxnSpPr>
-        <p:spPr>
-          <a:xfrm>
-            <a:off x="9175192" y="1522298"/>
-            <a:ext cx="1451811" cy="1108426"/>
-          </a:xfrm>
-          <a:prstGeom prst="straightConnector1">
-            <a:avLst/>
-          </a:prstGeom>
-          <a:ln>
-            <a:tailEnd type="triangle"/>
-          </a:ln>
-        </p:spPr>
-        <p:style>
-          <a:lnRef idx="3">
-            <a:schemeClr val="dk1"/>
-          </a:lnRef>
-          <a:fillRef idx="0">
-            <a:schemeClr val="dk1"/>
-          </a:fillRef>
-          <a:effectRef idx="2">
-            <a:schemeClr val="dk1"/>
-          </a:effectRef>
-          <a:fontRef idx="minor">
-            <a:schemeClr val="tx1"/>
-          </a:fontRef>
-        </p:style>
-      </p:cxnSp>
-      <p:cxnSp>
-        <p:nvCxnSpPr>
-          <p:cNvPr id="18" name="Straight Arrow Connector 17">
-            <a:extLst>
-              <a:ext uri="{FF2B5EF4-FFF2-40B4-BE49-F238E27FC236}">
-                <a16:creationId xmlns:a16="http://schemas.microsoft.com/office/drawing/2014/main" id="{496788B4-CBEF-49A2-B29F-3DAC5165F805}"/>
-              </a:ext>
-            </a:extLst>
-          </p:cNvPr>
-          <p:cNvCxnSpPr>
-            <a:cxnSpLocks/>
-            <a:stCxn id="14" idx="2"/>
-          </p:cNvCxnSpPr>
-          <p:nvPr/>
-        </p:nvCxnSpPr>
-        <p:spPr>
-          <a:xfrm flipH="1">
-            <a:off x="7955994" y="1522298"/>
-            <a:ext cx="1219198" cy="1212700"/>
-          </a:xfrm>
-          <a:prstGeom prst="straightConnector1">
-            <a:avLst/>
-          </a:prstGeom>
-          <a:ln>
-            <a:tailEnd type="triangle"/>
-          </a:ln>
-        </p:spPr>
-        <p:style>
-          <a:lnRef idx="3">
-            <a:schemeClr val="dk1"/>
-          </a:lnRef>
-          <a:fillRef idx="0">
-            <a:schemeClr val="dk1"/>
-          </a:fillRef>
-          <a:effectRef idx="2">
-            <a:schemeClr val="dk1"/>
-          </a:effectRef>
-          <a:fontRef idx="minor">
-            <a:schemeClr val="tx1"/>
-          </a:fontRef>
-        </p:style>
-      </p:cxnSp>
-      <p:sp>
-        <p:nvSpPr>
-          <p:cNvPr id="28" name="Oval 27">
-            <a:extLst>
-              <a:ext uri="{FF2B5EF4-FFF2-40B4-BE49-F238E27FC236}">
-                <a16:creationId xmlns:a16="http://schemas.microsoft.com/office/drawing/2014/main" id="{5D3BB183-A2CA-46A2-B9C3-ADAE972B9027}"/>
-              </a:ext>
-            </a:extLst>
-          </p:cNvPr>
-          <p:cNvSpPr/>
-          <p:nvPr/>
-        </p:nvSpPr>
-        <p:spPr>
-          <a:xfrm>
-            <a:off x="1444235" y="2056559"/>
-            <a:ext cx="352926" cy="1833652"/>
-          </a:xfrm>
-          <a:prstGeom prst="ellipse">
-            <a:avLst/>
-          </a:prstGeom>
-          <a:noFill/>
-          <a:ln w="9525" cap="flat" cmpd="sng" algn="ctr">
-            <a:solidFill>
-              <a:schemeClr val="accent1"/>
-            </a:solidFill>
-            <a:prstDash val="solid"/>
-            <a:round/>
-            <a:headEnd type="none" w="med" len="med"/>
-            <a:tailEnd type="none" w="med" len="med"/>
-          </a:ln>
-        </p:spPr>
-        <p:style>
-          <a:lnRef idx="0">
-            <a:scrgbClr r="0" g="0" b="0"/>
-          </a:lnRef>
-          <a:fillRef idx="0">
-            <a:scrgbClr r="0" g="0" b="0"/>
-          </a:fillRef>
-          <a:effectRef idx="0">
-            <a:scrgbClr r="0" g="0" b="0"/>
-          </a:effectRef>
-          <a:fontRef idx="minor">
-            <a:schemeClr val="accent1"/>
-          </a:fontRef>
-        </p:style>
-        <p:txBody>
-          <a:bodyPr rtlCol="0" anchor="ctr"/>
-          <a:lstStyle/>
-          <a:p>
-            <a:pPr algn="ctr"/>
-            <a:endParaRPr lang="nl-NL"/>
-          </a:p>
-        </p:txBody>
-      </p:sp>
-      <p:sp>
-        <p:nvSpPr>
-          <p:cNvPr id="30" name="Oval 29">
-            <a:extLst>
-              <a:ext uri="{FF2B5EF4-FFF2-40B4-BE49-F238E27FC236}">
-                <a16:creationId xmlns:a16="http://schemas.microsoft.com/office/drawing/2014/main" id="{DFC1405A-A1FB-4B7D-A729-6F366D78F1F5}"/>
-              </a:ext>
-            </a:extLst>
-          </p:cNvPr>
-          <p:cNvSpPr/>
-          <p:nvPr/>
-        </p:nvSpPr>
-        <p:spPr>
-          <a:xfrm>
-            <a:off x="4497809" y="2056558"/>
-            <a:ext cx="352926" cy="3060874"/>
-          </a:xfrm>
-          <a:prstGeom prst="ellipse">
-            <a:avLst/>
-          </a:prstGeom>
-          <a:noFill/>
-          <a:ln w="9525" cap="flat" cmpd="sng" algn="ctr">
-            <a:solidFill>
-              <a:schemeClr val="accent1"/>
-            </a:solidFill>
-            <a:prstDash val="solid"/>
-            <a:round/>
-            <a:headEnd type="none" w="med" len="med"/>
-            <a:tailEnd type="none" w="med" len="med"/>
-          </a:ln>
-        </p:spPr>
-        <p:style>
-          <a:lnRef idx="0">
-            <a:scrgbClr r="0" g="0" b="0"/>
-          </a:lnRef>
-          <a:fillRef idx="0">
-            <a:scrgbClr r="0" g="0" b="0"/>
-          </a:fillRef>
-          <a:effectRef idx="0">
-            <a:scrgbClr r="0" g="0" b="0"/>
-          </a:effectRef>
-          <a:fontRef idx="minor">
-            <a:schemeClr val="accent1"/>
-          </a:fontRef>
-        </p:style>
-        <p:txBody>
-          <a:bodyPr rtlCol="0" anchor="ctr"/>
-          <a:lstStyle/>
-          <a:p>
-            <a:pPr algn="ctr"/>
-            <a:endParaRPr lang="nl-NL"/>
-          </a:p>
-        </p:txBody>
-      </p:sp>
-      <p:cxnSp>
-        <p:nvCxnSpPr>
-          <p:cNvPr id="47" name="Straight Connector 46">
-            <a:extLst>
-              <a:ext uri="{FF2B5EF4-FFF2-40B4-BE49-F238E27FC236}">
-                <a16:creationId xmlns:a16="http://schemas.microsoft.com/office/drawing/2014/main" id="{BB77F60D-AA92-4E88-9238-C37C7FCED343}"/>
-              </a:ext>
-            </a:extLst>
-          </p:cNvPr>
-          <p:cNvCxnSpPr/>
-          <p:nvPr/>
-        </p:nvCxnSpPr>
-        <p:spPr>
-          <a:xfrm>
-            <a:off x="344905" y="4868779"/>
-            <a:ext cx="2334126" cy="0"/>
-          </a:xfrm>
-          <a:prstGeom prst="line">
-            <a:avLst/>
-          </a:prstGeom>
-        </p:spPr>
-        <p:style>
-          <a:lnRef idx="3">
-            <a:schemeClr val="accent2"/>
-          </a:lnRef>
-          <a:fillRef idx="0">
-            <a:schemeClr val="accent2"/>
-          </a:fillRef>
-          <a:effectRef idx="2">
-            <a:schemeClr val="accent2"/>
-          </a:effectRef>
-          <a:fontRef idx="minor">
-            <a:schemeClr val="tx1"/>
-          </a:fontRef>
-        </p:style>
-      </p:cxnSp>
-      <p:sp>
-        <p:nvSpPr>
-          <p:cNvPr id="48" name="TextBox 47">
-            <a:extLst>
-              <a:ext uri="{FF2B5EF4-FFF2-40B4-BE49-F238E27FC236}">
-                <a16:creationId xmlns:a16="http://schemas.microsoft.com/office/drawing/2014/main" id="{210063D6-AB12-4D1A-8DD9-1B596D004A2F}"/>
-              </a:ext>
-            </a:extLst>
-          </p:cNvPr>
-          <p:cNvSpPr txBox="1"/>
-          <p:nvPr/>
-        </p:nvSpPr>
-        <p:spPr>
-          <a:xfrm>
-            <a:off x="2310061" y="4588042"/>
-            <a:ext cx="471458" cy="369332"/>
-          </a:xfrm>
-          <a:prstGeom prst="rect">
-            <a:avLst/>
-          </a:prstGeom>
-          <a:noFill/>
-        </p:spPr>
-        <p:txBody>
-          <a:bodyPr wrap="square" rtlCol="0">
-            <a:spAutoFit/>
-          </a:bodyPr>
-          <a:lstStyle/>
-          <a:p>
-            <a:pPr algn="ctr"/>
-            <a:r>
-              <a:rPr lang="it-IT" dirty="0">
-                <a:solidFill>
-                  <a:schemeClr val="accent2"/>
-                </a:solidFill>
-              </a:rPr>
-              <a:t>20</a:t>
-            </a:r>
-            <a:endParaRPr lang="nl-NL" dirty="0">
-              <a:solidFill>
-                <a:schemeClr val="accent2"/>
-              </a:solidFill>
-            </a:endParaRPr>
-          </a:p>
-        </p:txBody>
-      </p:sp>
-      <p:cxnSp>
-        <p:nvCxnSpPr>
-          <p:cNvPr id="49" name="Straight Connector 48">
-            <a:extLst>
-              <a:ext uri="{FF2B5EF4-FFF2-40B4-BE49-F238E27FC236}">
-                <a16:creationId xmlns:a16="http://schemas.microsoft.com/office/drawing/2014/main" id="{0BD6F6C2-AA8F-4637-B394-6AEB8944AE70}"/>
-              </a:ext>
-            </a:extLst>
-          </p:cNvPr>
-          <p:cNvCxnSpPr/>
-          <p:nvPr/>
-        </p:nvCxnSpPr>
-        <p:spPr>
-          <a:xfrm>
-            <a:off x="351141" y="3890211"/>
-            <a:ext cx="2334126" cy="0"/>
-          </a:xfrm>
-          <a:prstGeom prst="line">
-            <a:avLst/>
-          </a:prstGeom>
-        </p:spPr>
-        <p:style>
-          <a:lnRef idx="3">
-            <a:schemeClr val="accent2"/>
-          </a:lnRef>
-          <a:fillRef idx="0">
-            <a:schemeClr val="accent2"/>
-          </a:fillRef>
-          <a:effectRef idx="2">
-            <a:schemeClr val="accent2"/>
-          </a:effectRef>
-          <a:fontRef idx="minor">
-            <a:schemeClr val="tx1"/>
-          </a:fontRef>
-        </p:style>
-      </p:cxnSp>
-      <p:sp>
-        <p:nvSpPr>
-          <p:cNvPr id="50" name="TextBox 49">
-            <a:extLst>
-              <a:ext uri="{FF2B5EF4-FFF2-40B4-BE49-F238E27FC236}">
-                <a16:creationId xmlns:a16="http://schemas.microsoft.com/office/drawing/2014/main" id="{DC3D5BFC-C2C7-4C0B-8CCD-B5F0EF51BD42}"/>
-              </a:ext>
-            </a:extLst>
-          </p:cNvPr>
-          <p:cNvSpPr txBox="1"/>
-          <p:nvPr/>
-        </p:nvSpPr>
-        <p:spPr>
-          <a:xfrm>
-            <a:off x="2181726" y="3609474"/>
-            <a:ext cx="606029" cy="369332"/>
-          </a:xfrm>
-          <a:prstGeom prst="rect">
-            <a:avLst/>
-          </a:prstGeom>
-          <a:noFill/>
-        </p:spPr>
-        <p:txBody>
-          <a:bodyPr wrap="square" rtlCol="0">
-            <a:spAutoFit/>
-          </a:bodyPr>
-          <a:lstStyle/>
-          <a:p>
-            <a:pPr algn="ctr"/>
-            <a:r>
-              <a:rPr lang="it-IT" dirty="0">
-                <a:solidFill>
-                  <a:schemeClr val="accent2"/>
-                </a:solidFill>
-              </a:rPr>
-              <a:t>300</a:t>
-            </a:r>
-            <a:endParaRPr lang="nl-NL" dirty="0">
-              <a:solidFill>
-                <a:schemeClr val="accent2"/>
-              </a:solidFill>
-            </a:endParaRPr>
-          </a:p>
-        </p:txBody>
-      </p:sp>
-      <p:cxnSp>
-        <p:nvCxnSpPr>
-          <p:cNvPr id="51" name="Straight Connector 50">
-            <a:extLst>
-              <a:ext uri="{FF2B5EF4-FFF2-40B4-BE49-F238E27FC236}">
-                <a16:creationId xmlns:a16="http://schemas.microsoft.com/office/drawing/2014/main" id="{44BEA9E8-8FA9-4EBF-ADB1-F15EF59D545A}"/>
-              </a:ext>
-            </a:extLst>
-          </p:cNvPr>
-          <p:cNvCxnSpPr/>
-          <p:nvPr/>
-        </p:nvCxnSpPr>
-        <p:spPr>
-          <a:xfrm>
-            <a:off x="3376752" y="5219798"/>
-            <a:ext cx="2334126" cy="0"/>
-          </a:xfrm>
-          <a:prstGeom prst="line">
-            <a:avLst/>
-          </a:prstGeom>
-        </p:spPr>
-        <p:style>
-          <a:lnRef idx="3">
-            <a:schemeClr val="accent2"/>
-          </a:lnRef>
-          <a:fillRef idx="0">
-            <a:schemeClr val="accent2"/>
-          </a:fillRef>
-          <a:effectRef idx="2">
-            <a:schemeClr val="accent2"/>
-          </a:effectRef>
-          <a:fontRef idx="minor">
-            <a:schemeClr val="tx1"/>
-          </a:fontRef>
-        </p:style>
-      </p:cxnSp>
-      <p:sp>
-        <p:nvSpPr>
-          <p:cNvPr id="52" name="TextBox 51">
-            <a:extLst>
-              <a:ext uri="{FF2B5EF4-FFF2-40B4-BE49-F238E27FC236}">
-                <a16:creationId xmlns:a16="http://schemas.microsoft.com/office/drawing/2014/main" id="{A166A446-0273-44CD-8582-FA57872289AC}"/>
-              </a:ext>
-            </a:extLst>
-          </p:cNvPr>
-          <p:cNvSpPr txBox="1"/>
-          <p:nvPr/>
-        </p:nvSpPr>
-        <p:spPr>
-          <a:xfrm>
-            <a:off x="5624542" y="5035132"/>
-            <a:ext cx="471458" cy="369332"/>
-          </a:xfrm>
-          <a:prstGeom prst="rect">
-            <a:avLst/>
-          </a:prstGeom>
-          <a:noFill/>
-        </p:spPr>
-        <p:txBody>
-          <a:bodyPr wrap="square" rtlCol="0">
-            <a:spAutoFit/>
-          </a:bodyPr>
-          <a:lstStyle/>
-          <a:p>
-            <a:pPr algn="ctr"/>
-            <a:r>
-              <a:rPr lang="it-IT" dirty="0">
-                <a:solidFill>
-                  <a:schemeClr val="accent2"/>
-                </a:solidFill>
-              </a:rPr>
-              <a:t>20</a:t>
-            </a:r>
-            <a:endParaRPr lang="nl-NL" dirty="0">
-              <a:solidFill>
-                <a:schemeClr val="accent2"/>
-              </a:solidFill>
-            </a:endParaRPr>
-          </a:p>
-        </p:txBody>
-      </p:sp>
-      <p:cxnSp>
-        <p:nvCxnSpPr>
-          <p:cNvPr id="53" name="Straight Connector 52">
-            <a:extLst>
-              <a:ext uri="{FF2B5EF4-FFF2-40B4-BE49-F238E27FC236}">
-                <a16:creationId xmlns:a16="http://schemas.microsoft.com/office/drawing/2014/main" id="{7EEC18CD-74D0-4FAF-8860-CE57F8D1CFA6}"/>
-              </a:ext>
-            </a:extLst>
-          </p:cNvPr>
-          <p:cNvCxnSpPr/>
-          <p:nvPr/>
-        </p:nvCxnSpPr>
-        <p:spPr>
-          <a:xfrm>
-            <a:off x="3382988" y="5112781"/>
-            <a:ext cx="2334126" cy="0"/>
-          </a:xfrm>
-          <a:prstGeom prst="line">
-            <a:avLst/>
-          </a:prstGeom>
-        </p:spPr>
-        <p:style>
-          <a:lnRef idx="3">
-            <a:schemeClr val="accent2"/>
-          </a:lnRef>
-          <a:fillRef idx="0">
-            <a:schemeClr val="accent2"/>
-          </a:fillRef>
-          <a:effectRef idx="2">
-            <a:schemeClr val="accent2"/>
-          </a:effectRef>
-          <a:fontRef idx="minor">
-            <a:schemeClr val="tx1"/>
-          </a:fontRef>
-        </p:style>
-      </p:cxnSp>
-      <p:sp>
-        <p:nvSpPr>
-          <p:cNvPr id="54" name="TextBox 53">
-            <a:extLst>
-              <a:ext uri="{FF2B5EF4-FFF2-40B4-BE49-F238E27FC236}">
-                <a16:creationId xmlns:a16="http://schemas.microsoft.com/office/drawing/2014/main" id="{79388AA8-1909-4DBD-B882-1AB427F2771E}"/>
-              </a:ext>
-            </a:extLst>
-          </p:cNvPr>
-          <p:cNvSpPr txBox="1"/>
-          <p:nvPr/>
-        </p:nvSpPr>
-        <p:spPr>
-          <a:xfrm>
-            <a:off x="5566173" y="4796958"/>
-            <a:ext cx="606029" cy="369332"/>
-          </a:xfrm>
-          <a:prstGeom prst="rect">
-            <a:avLst/>
-          </a:prstGeom>
-          <a:noFill/>
-        </p:spPr>
-        <p:txBody>
-          <a:bodyPr wrap="square" rtlCol="0">
-            <a:spAutoFit/>
-          </a:bodyPr>
-          <a:lstStyle/>
-          <a:p>
-            <a:pPr algn="ctr"/>
-            <a:r>
-              <a:rPr lang="it-IT" dirty="0">
-                <a:solidFill>
-                  <a:schemeClr val="accent2"/>
-                </a:solidFill>
-              </a:rPr>
-              <a:t>300</a:t>
-            </a:r>
-            <a:endParaRPr lang="nl-NL" dirty="0">
-              <a:solidFill>
-                <a:schemeClr val="accent2"/>
-              </a:solidFill>
-            </a:endParaRPr>
-          </a:p>
-        </p:txBody>
-      </p:sp>
-      <p:sp>
-        <p:nvSpPr>
-          <p:cNvPr id="55" name="Arrow: Right 54">
-            <a:extLst>
-              <a:ext uri="{FF2B5EF4-FFF2-40B4-BE49-F238E27FC236}">
-                <a16:creationId xmlns:a16="http://schemas.microsoft.com/office/drawing/2014/main" id="{CF186115-EF21-4E45-BA1A-F7A01B55B725}"/>
-              </a:ext>
-            </a:extLst>
-          </p:cNvPr>
-          <p:cNvSpPr/>
-          <p:nvPr/>
-        </p:nvSpPr>
-        <p:spPr>
-          <a:xfrm>
-            <a:off x="5654279" y="3364185"/>
-            <a:ext cx="1094205" cy="369332"/>
-          </a:xfrm>
-          <a:prstGeom prst="rightArrow">
-            <a:avLst/>
-          </a:prstGeom>
-        </p:spPr>
-        <p:style>
-          <a:lnRef idx="2">
-            <a:schemeClr val="accent2">
-              <a:shade val="50000"/>
-            </a:schemeClr>
-          </a:lnRef>
-          <a:fillRef idx="1">
-            <a:schemeClr val="accent2"/>
-          </a:fillRef>
-          <a:effectRef idx="0">
-            <a:schemeClr val="accent2"/>
-          </a:effectRef>
-          <a:fontRef idx="minor">
-            <a:schemeClr val="lt1"/>
-          </a:fontRef>
-        </p:style>
-        <p:txBody>
-          <a:bodyPr rtlCol="0" anchor="ctr"/>
-          <a:lstStyle/>
-          <a:p>
-            <a:pPr algn="ctr"/>
-            <a:endParaRPr lang="nl-NL"/>
-          </a:p>
-        </p:txBody>
-      </p:sp>
-      <p:sp>
-        <p:nvSpPr>
-          <p:cNvPr id="57" name="Oval 56">
-            <a:extLst>
-              <a:ext uri="{FF2B5EF4-FFF2-40B4-BE49-F238E27FC236}">
-                <a16:creationId xmlns:a16="http://schemas.microsoft.com/office/drawing/2014/main" id="{F946F1D0-67D6-45FC-AEDB-3F765ADB089F}"/>
-              </a:ext>
-            </a:extLst>
-          </p:cNvPr>
-          <p:cNvSpPr/>
-          <p:nvPr/>
-        </p:nvSpPr>
-        <p:spPr>
-          <a:xfrm>
-            <a:off x="1444235" y="4886330"/>
-            <a:ext cx="352926" cy="473862"/>
-          </a:xfrm>
-          <a:prstGeom prst="ellipse">
-            <a:avLst/>
-          </a:prstGeom>
-          <a:noFill/>
-          <a:ln w="9525" cap="flat" cmpd="sng" algn="ctr">
-            <a:solidFill>
-              <a:schemeClr val="accent1"/>
-            </a:solidFill>
-            <a:prstDash val="solid"/>
-            <a:round/>
-            <a:headEnd type="none" w="med" len="med"/>
-            <a:tailEnd type="none" w="med" len="med"/>
-          </a:ln>
-        </p:spPr>
-        <p:style>
-          <a:lnRef idx="0">
-            <a:scrgbClr r="0" g="0" b="0"/>
-          </a:lnRef>
-          <a:fillRef idx="0">
-            <a:scrgbClr r="0" g="0" b="0"/>
-          </a:fillRef>
-          <a:effectRef idx="0">
-            <a:scrgbClr r="0" g="0" b="0"/>
-          </a:effectRef>
-          <a:fontRef idx="minor">
-            <a:schemeClr val="accent1"/>
-          </a:fontRef>
-        </p:style>
-        <p:txBody>
-          <a:bodyPr rtlCol="0" anchor="ctr"/>
-          <a:lstStyle/>
-          <a:p>
-            <a:pPr algn="ctr"/>
-            <a:endParaRPr lang="nl-NL"/>
-          </a:p>
-        </p:txBody>
-      </p:sp>
-    </p:spTree>
-    <p:extLst>
-      <p:ext uri="{BB962C8B-B14F-4D97-AF65-F5344CB8AC3E}">
-        <p14:creationId xmlns:p14="http://schemas.microsoft.com/office/powerpoint/2010/main" val="2308014033"/>
-      </p:ext>
-    </p:extLst>
-  </p:cSld>
-  <p:clrMapOvr>
-    <a:masterClrMapping/>
-  </p:clrMapOvr>
-  <mc:AlternateContent xmlns:mc="http://schemas.openxmlformats.org/markup-compatibility/2006" xmlns:p159="http://schemas.microsoft.com/office/powerpoint/2015/09/main">
-    <mc:Choice Requires="p159">
-      <p:transition spd="slow">
-        <p159:morph option="byObject"/>
-      </p:transition>
-    </mc:Choice>
-    <mc:Fallback xmlns="">
-      <p:transition spd="slow">
-        <p:fade/>
-      </p:transition>
-    </mc:Fallback>
-  </mc:AlternateContent>
-</p:sld>
-</file>
-
-<file path=ppt/slides/slide28.xml><?xml version="1.0" encoding="utf-8"?>
-<p:sld xmlns:a="http://schemas.openxmlformats.org/drawingml/2006/main" xmlns:r="http://schemas.openxmlformats.org/officeDocument/2006/relationships" xmlns:p="http://schemas.openxmlformats.org/presentationml/2006/main">
-  <p:cSld>
-    <p:spTree>
-      <p:nvGrpSpPr>
-        <p:cNvPr id="1" name=""/>
-        <p:cNvGrpSpPr/>
-        <p:nvPr/>
-      </p:nvGrpSpPr>
-      <p:grpSpPr>
-        <a:xfrm>
-          <a:off x="0" y="0"/>
-          <a:ext cx="0" cy="0"/>
-          <a:chOff x="0" y="0"/>
-          <a:chExt cx="0" cy="0"/>
-        </a:xfrm>
-      </p:grpSpPr>
-      <p:pic>
-        <p:nvPicPr>
-          <p:cNvPr id="2" name="Picture 1">
-            <a:extLst>
-              <a:ext uri="{FF2B5EF4-FFF2-40B4-BE49-F238E27FC236}">
-                <a16:creationId xmlns:a16="http://schemas.microsoft.com/office/drawing/2014/main" id="{EFCA64AE-70C0-46DC-9DE0-3BD016877CF0}"/>
-              </a:ext>
-            </a:extLst>
-          </p:cNvPr>
-          <p:cNvPicPr>
-            <a:picLocks noChangeAspect="1"/>
-          </p:cNvPicPr>
-          <p:nvPr/>
-        </p:nvPicPr>
-        <p:blipFill>
-          <a:blip r:embed="rId2">
-            <a:extLst>
-              <a:ext uri="{28A0092B-C50C-407E-A947-70E740481C1C}">
-                <a14:useLocalDpi xmlns:a14="http://schemas.microsoft.com/office/drawing/2010/main" val="0"/>
-              </a:ext>
-            </a:extLst>
-          </a:blip>
-          <a:stretch>
-            <a:fillRect/>
-          </a:stretch>
-        </p:blipFill>
-        <p:spPr>
-          <a:xfrm>
-            <a:off x="2471014" y="2125452"/>
-            <a:ext cx="7249970" cy="4405816"/>
-          </a:xfrm>
-          <a:prstGeom prst="rect">
-            <a:avLst/>
-          </a:prstGeom>
-        </p:spPr>
-      </p:pic>
-      <p:sp>
-        <p:nvSpPr>
-          <p:cNvPr id="3" name="TextBox 2">
-            <a:extLst>
-              <a:ext uri="{FF2B5EF4-FFF2-40B4-BE49-F238E27FC236}">
-                <a16:creationId xmlns:a16="http://schemas.microsoft.com/office/drawing/2014/main" id="{669BC41E-7A1B-450B-AE56-57E23EBB368B}"/>
-              </a:ext>
-            </a:extLst>
-          </p:cNvPr>
-          <p:cNvSpPr txBox="1"/>
-          <p:nvPr/>
-        </p:nvSpPr>
-        <p:spPr>
-          <a:xfrm>
-            <a:off x="0" y="0"/>
-            <a:ext cx="4395537" cy="369332"/>
-          </a:xfrm>
-          <a:prstGeom prst="rect">
-            <a:avLst/>
-          </a:prstGeom>
-          <a:noFill/>
-        </p:spPr>
-        <p:txBody>
-          <a:bodyPr wrap="square" rtlCol="0">
-            <a:spAutoFit/>
-          </a:bodyPr>
-          <a:lstStyle/>
-          <a:p>
-            <a:r>
-              <a:rPr lang="it-IT" u="sng" dirty="0"/>
-              <a:t>Blood Pressure Measurements - Outliers</a:t>
-            </a:r>
-            <a:endParaRPr lang="nl-NL" u="sng" dirty="0"/>
-          </a:p>
-        </p:txBody>
-      </p:sp>
-      <p:sp>
-        <p:nvSpPr>
-          <p:cNvPr id="4" name="TextBox 3">
-            <a:extLst>
-              <a:ext uri="{FF2B5EF4-FFF2-40B4-BE49-F238E27FC236}">
-                <a16:creationId xmlns:a16="http://schemas.microsoft.com/office/drawing/2014/main" id="{9D83727A-AEE6-4E01-9A07-195FB57628BF}"/>
-              </a:ext>
-            </a:extLst>
-          </p:cNvPr>
-          <p:cNvSpPr txBox="1"/>
-          <p:nvPr/>
-        </p:nvSpPr>
-        <p:spPr>
-          <a:xfrm>
-            <a:off x="2709862" y="811929"/>
-            <a:ext cx="6772275" cy="1200329"/>
-          </a:xfrm>
-          <a:prstGeom prst="rect">
-            <a:avLst/>
-          </a:prstGeom>
-          <a:noFill/>
-        </p:spPr>
-        <p:txBody>
-          <a:bodyPr wrap="square" rtlCol="0">
-            <a:spAutoFit/>
-          </a:bodyPr>
-          <a:lstStyle/>
-          <a:p>
-            <a:pPr algn="ctr"/>
-            <a:r>
-              <a:rPr lang="it-IT" sz="2400" dirty="0"/>
-              <a:t>Replaced with Mean value </a:t>
-            </a:r>
-          </a:p>
-          <a:p>
-            <a:pPr algn="ctr"/>
-            <a:r>
-              <a:rPr lang="it-IT" sz="2400" dirty="0"/>
-              <a:t>if </a:t>
-            </a:r>
-          </a:p>
-          <a:p>
-            <a:pPr algn="ctr"/>
-            <a:r>
-              <a:rPr lang="it-IT" sz="2400" dirty="0"/>
-              <a:t>|BP</a:t>
-            </a:r>
-            <a:r>
-              <a:rPr lang="it-IT" sz="2400" baseline="-25000" dirty="0"/>
-              <a:t>Sys,Dia</a:t>
-            </a:r>
-            <a:r>
-              <a:rPr lang="it-IT" sz="2400" dirty="0"/>
-              <a:t>| </a:t>
-            </a:r>
-            <a:r>
-              <a:rPr lang="nl-NL" sz="2400" dirty="0"/>
-              <a:t>&lt; 3·</a:t>
-            </a:r>
-            <a:r>
-              <a:rPr lang="el-GR" sz="2400" dirty="0"/>
-              <a:t>σ</a:t>
-            </a:r>
-            <a:endParaRPr lang="nl-NL" sz="2400" dirty="0"/>
-          </a:p>
-        </p:txBody>
-      </p:sp>
-    </p:spTree>
-    <p:extLst>
-      <p:ext uri="{BB962C8B-B14F-4D97-AF65-F5344CB8AC3E}">
-        <p14:creationId xmlns:p14="http://schemas.microsoft.com/office/powerpoint/2010/main" val="483860090"/>
-      </p:ext>
-    </p:extLst>
-  </p:cSld>
-  <p:clrMapOvr>
-    <a:masterClrMapping/>
-  </p:clrMapOvr>
-  <mc:AlternateContent xmlns:mc="http://schemas.openxmlformats.org/markup-compatibility/2006" xmlns:p159="http://schemas.microsoft.com/office/powerpoint/2015/09/main">
-    <mc:Choice Requires="p159">
-      <p:transition spd="slow">
-        <p159:morph option="byObject"/>
-      </p:transition>
-    </mc:Choice>
-    <mc:Fallback xmlns="">
-      <p:transition spd="slow">
-        <p:fade/>
-      </p:transition>
-    </mc:Fallback>
-  </mc:AlternateContent>
-</p:sld>
-</file>
-
-<file path=ppt/slides/slide29.xml><?xml version="1.0" encoding="utf-8"?>
-<p:sld xmlns:a="http://schemas.openxmlformats.org/drawingml/2006/main" xmlns:r="http://schemas.openxmlformats.org/officeDocument/2006/relationships" xmlns:p="http://schemas.openxmlformats.org/presentationml/2006/main">
-  <p:cSld>
-    <p:spTree>
-      <p:nvGrpSpPr>
-        <p:cNvPr id="1" name=""/>
-        <p:cNvGrpSpPr/>
-        <p:nvPr/>
-      </p:nvGrpSpPr>
-      <p:grpSpPr>
-        <a:xfrm>
-          <a:off x="0" y="0"/>
-          <a:ext cx="0" cy="0"/>
-          <a:chOff x="0" y="0"/>
-          <a:chExt cx="0" cy="0"/>
-        </a:xfrm>
-      </p:grpSpPr>
-      <p:sp>
-        <p:nvSpPr>
-          <p:cNvPr id="2" name="Title 1">
-            <a:extLst>
-              <a:ext uri="{FF2B5EF4-FFF2-40B4-BE49-F238E27FC236}">
-                <a16:creationId xmlns:a16="http://schemas.microsoft.com/office/drawing/2014/main" id="{E2742523-2057-44B4-9FB1-A3B7126FBF7F}"/>
-              </a:ext>
-            </a:extLst>
-          </p:cNvPr>
-          <p:cNvSpPr>
-            <a:spLocks noGrp="1"/>
-          </p:cNvSpPr>
-          <p:nvPr>
-            <p:ph type="title"/>
-          </p:nvPr>
-        </p:nvSpPr>
-        <p:spPr>
-          <a:xfrm>
-            <a:off x="838200" y="2766218"/>
-            <a:ext cx="10515600" cy="1325563"/>
-          </a:xfrm>
-        </p:spPr>
-        <p:txBody>
-          <a:bodyPr/>
-          <a:lstStyle/>
-          <a:p>
-            <a:pPr algn="ctr"/>
-            <a:r>
-              <a:rPr lang="it-IT" dirty="0"/>
-              <a:t>Eligibility to LHS</a:t>
-            </a:r>
-            <a:endParaRPr lang="nl-NL" dirty="0"/>
-          </a:p>
-        </p:txBody>
-      </p:sp>
-    </p:spTree>
-    <p:extLst>
-      <p:ext uri="{BB962C8B-B14F-4D97-AF65-F5344CB8AC3E}">
-        <p14:creationId xmlns:p14="http://schemas.microsoft.com/office/powerpoint/2010/main" val="64685501"/>
-      </p:ext>
-    </p:extLst>
-  </p:cSld>
-  <p:clrMapOvr>
-    <a:masterClrMapping/>
-  </p:clrMapOvr>
-  <mc:AlternateContent xmlns:mc="http://schemas.openxmlformats.org/markup-compatibility/2006" xmlns:p159="http://schemas.microsoft.com/office/powerpoint/2015/09/main">
-    <mc:Choice Requires="p159">
-      <p:transition spd="slow">
-        <p159:morph option="byObject"/>
-      </p:transition>
-    </mc:Choice>
-    <mc:Fallback xmlns="">
-      <p:transition spd="slow">
-        <p:fade/>
-      </p:transition>
-    </mc:Fallback>
-  </mc:AlternateContent>
-</p:sld>
-</file>
-
 <file path=ppt/slides/slide3.xml><?xml version="1.0" encoding="utf-8"?>
 <p:sld xmlns:a="http://schemas.openxmlformats.org/drawingml/2006/main" xmlns:r="http://schemas.openxmlformats.org/officeDocument/2006/relationships" xmlns:p="http://schemas.openxmlformats.org/presentationml/2006/main">
   <p:cSld>
@@ -10829,6 +10554,1285 @@
 </file>
 
 <file path=ppt/slides/slide30.xml><?xml version="1.0" encoding="utf-8"?>
+<p:sld xmlns:a="http://schemas.openxmlformats.org/drawingml/2006/main" xmlns:r="http://schemas.openxmlformats.org/officeDocument/2006/relationships" xmlns:p="http://schemas.openxmlformats.org/presentationml/2006/main">
+  <p:cSld>
+    <p:spTree>
+      <p:nvGrpSpPr>
+        <p:cNvPr id="1" name=""/>
+        <p:cNvGrpSpPr/>
+        <p:nvPr/>
+      </p:nvGrpSpPr>
+      <p:grpSpPr>
+        <a:xfrm>
+          <a:off x="0" y="0"/>
+          <a:ext cx="0" cy="0"/>
+          <a:chOff x="0" y="0"/>
+          <a:chExt cx="0" cy="0"/>
+        </a:xfrm>
+      </p:grpSpPr>
+      <p:sp>
+        <p:nvSpPr>
+          <p:cNvPr id="2" name="Title 1">
+            <a:extLst>
+              <a:ext uri="{FF2B5EF4-FFF2-40B4-BE49-F238E27FC236}">
+                <a16:creationId xmlns:a16="http://schemas.microsoft.com/office/drawing/2014/main" id="{6D37F963-7349-4DE3-A960-EEBD333A4E61}"/>
+              </a:ext>
+            </a:extLst>
+          </p:cNvPr>
+          <p:cNvSpPr txBox="1">
+            <a:spLocks/>
+          </p:cNvSpPr>
+          <p:nvPr/>
+        </p:nvSpPr>
+        <p:spPr>
+          <a:xfrm>
+            <a:off x="1524000" y="2235200"/>
+            <a:ext cx="9144000" cy="2387600"/>
+          </a:xfrm>
+          <a:prstGeom prst="rect">
+            <a:avLst/>
+          </a:prstGeom>
+        </p:spPr>
+        <p:txBody>
+          <a:bodyPr anchor="ctr"/>
+          <a:lstStyle>
+            <a:lvl1pPr algn="l" defTabSz="914400" rtl="0" eaLnBrk="1" latinLnBrk="0" hangingPunct="1">
+              <a:lnSpc>
+                <a:spcPct val="90000"/>
+              </a:lnSpc>
+              <a:spcBef>
+                <a:spcPct val="0"/>
+              </a:spcBef>
+              <a:buNone/>
+              <a:defRPr sz="4400" kern="1200">
+                <a:solidFill>
+                  <a:schemeClr val="tx1"/>
+                </a:solidFill>
+                <a:latin typeface="+mj-lt"/>
+                <a:ea typeface="+mj-ea"/>
+                <a:cs typeface="+mj-cs"/>
+              </a:defRPr>
+            </a:lvl1pPr>
+          </a:lstStyle>
+          <a:p>
+            <a:pPr algn="ctr"/>
+            <a:r>
+              <a:rPr lang="it-IT" dirty="0"/>
+              <a:t>Blood Pressure Readings</a:t>
+            </a:r>
+            <a:endParaRPr lang="nl-NL" dirty="0"/>
+          </a:p>
+        </p:txBody>
+      </p:sp>
+    </p:spTree>
+    <p:extLst>
+      <p:ext uri="{BB962C8B-B14F-4D97-AF65-F5344CB8AC3E}">
+        <p14:creationId xmlns:p14="http://schemas.microsoft.com/office/powerpoint/2010/main" val="603692568"/>
+      </p:ext>
+    </p:extLst>
+  </p:cSld>
+  <p:clrMapOvr>
+    <a:masterClrMapping/>
+  </p:clrMapOvr>
+  <mc:AlternateContent xmlns:mc="http://schemas.openxmlformats.org/markup-compatibility/2006" xmlns:p159="http://schemas.microsoft.com/office/powerpoint/2015/09/main">
+    <mc:Choice Requires="p159">
+      <p:transition spd="slow">
+        <p159:morph option="byObject"/>
+      </p:transition>
+    </mc:Choice>
+    <mc:Fallback xmlns="">
+      <p:transition spd="slow">
+        <p:fade/>
+      </p:transition>
+    </mc:Fallback>
+  </mc:AlternateContent>
+</p:sld>
+</file>
+
+<file path=ppt/slides/slide31.xml><?xml version="1.0" encoding="utf-8"?>
+<p:sld xmlns:a="http://schemas.openxmlformats.org/drawingml/2006/main" xmlns:r="http://schemas.openxmlformats.org/officeDocument/2006/relationships" xmlns:p="http://schemas.openxmlformats.org/presentationml/2006/main">
+  <p:cSld>
+    <p:spTree>
+      <p:nvGrpSpPr>
+        <p:cNvPr id="1" name=""/>
+        <p:cNvGrpSpPr/>
+        <p:nvPr/>
+      </p:nvGrpSpPr>
+      <p:grpSpPr>
+        <a:xfrm>
+          <a:off x="0" y="0"/>
+          <a:ext cx="0" cy="0"/>
+          <a:chOff x="0" y="0"/>
+          <a:chExt cx="0" cy="0"/>
+        </a:xfrm>
+      </p:grpSpPr>
+      <p:sp>
+        <p:nvSpPr>
+          <p:cNvPr id="2" name="TextBox 1">
+            <a:extLst>
+              <a:ext uri="{FF2B5EF4-FFF2-40B4-BE49-F238E27FC236}">
+                <a16:creationId xmlns:a16="http://schemas.microsoft.com/office/drawing/2014/main" id="{CC0200F0-ABFF-45F8-A6F5-9F8372AE5C7D}"/>
+              </a:ext>
+            </a:extLst>
+          </p:cNvPr>
+          <p:cNvSpPr txBox="1"/>
+          <p:nvPr/>
+        </p:nvSpPr>
+        <p:spPr>
+          <a:xfrm>
+            <a:off x="0" y="0"/>
+            <a:ext cx="4395537" cy="369332"/>
+          </a:xfrm>
+          <a:prstGeom prst="rect">
+            <a:avLst/>
+          </a:prstGeom>
+          <a:noFill/>
+        </p:spPr>
+        <p:txBody>
+          <a:bodyPr wrap="square" rtlCol="0">
+            <a:spAutoFit/>
+          </a:bodyPr>
+          <a:lstStyle/>
+          <a:p>
+            <a:r>
+              <a:rPr lang="it-IT" u="sng" dirty="0"/>
+              <a:t>Blood Pressure Measurements - Outliers</a:t>
+            </a:r>
+            <a:endParaRPr lang="nl-NL" u="sng" dirty="0"/>
+          </a:p>
+        </p:txBody>
+      </p:sp>
+      <p:pic>
+        <p:nvPicPr>
+          <p:cNvPr id="4" name="Picture 3">
+            <a:extLst>
+              <a:ext uri="{FF2B5EF4-FFF2-40B4-BE49-F238E27FC236}">
+                <a16:creationId xmlns:a16="http://schemas.microsoft.com/office/drawing/2014/main" id="{B141D145-8AC1-45C7-8D61-50D4BD1CC9DF}"/>
+              </a:ext>
+            </a:extLst>
+          </p:cNvPr>
+          <p:cNvPicPr>
+            <a:picLocks noChangeAspect="1"/>
+          </p:cNvPicPr>
+          <p:nvPr/>
+        </p:nvPicPr>
+        <p:blipFill>
+          <a:blip r:embed="rId2">
+            <a:extLst>
+              <a:ext uri="{28A0092B-C50C-407E-A947-70E740481C1C}">
+                <a14:useLocalDpi xmlns:a14="http://schemas.microsoft.com/office/drawing/2010/main" val="0"/>
+              </a:ext>
+            </a:extLst>
+          </a:blip>
+          <a:stretch>
+            <a:fillRect/>
+          </a:stretch>
+        </p:blipFill>
+        <p:spPr>
+          <a:xfrm>
+            <a:off x="6186458" y="1957137"/>
+            <a:ext cx="6005542" cy="3649580"/>
+          </a:xfrm>
+          <a:prstGeom prst="rect">
+            <a:avLst/>
+          </a:prstGeom>
+        </p:spPr>
+      </p:pic>
+      <p:pic>
+        <p:nvPicPr>
+          <p:cNvPr id="8" name="Picture 7">
+            <a:extLst>
+              <a:ext uri="{FF2B5EF4-FFF2-40B4-BE49-F238E27FC236}">
+                <a16:creationId xmlns:a16="http://schemas.microsoft.com/office/drawing/2014/main" id="{B78D7C7E-C973-4558-835C-AE7A82ECC7EF}"/>
+              </a:ext>
+            </a:extLst>
+          </p:cNvPr>
+          <p:cNvPicPr>
+            <a:picLocks noChangeAspect="1"/>
+          </p:cNvPicPr>
+          <p:nvPr/>
+        </p:nvPicPr>
+        <p:blipFill>
+          <a:blip r:embed="rId3">
+            <a:extLst>
+              <a:ext uri="{28A0092B-C50C-407E-A947-70E740481C1C}">
+                <a14:useLocalDpi xmlns:a14="http://schemas.microsoft.com/office/drawing/2010/main" val="0"/>
+              </a:ext>
+            </a:extLst>
+          </a:blip>
+          <a:stretch>
+            <a:fillRect/>
+          </a:stretch>
+        </p:blipFill>
+        <p:spPr>
+          <a:xfrm>
+            <a:off x="14258" y="1957137"/>
+            <a:ext cx="6005542" cy="3649580"/>
+          </a:xfrm>
+          <a:prstGeom prst="rect">
+            <a:avLst/>
+          </a:prstGeom>
+        </p:spPr>
+      </p:pic>
+      <p:cxnSp>
+        <p:nvCxnSpPr>
+          <p:cNvPr id="10" name="Straight Arrow Connector 9">
+            <a:extLst>
+              <a:ext uri="{FF2B5EF4-FFF2-40B4-BE49-F238E27FC236}">
+                <a16:creationId xmlns:a16="http://schemas.microsoft.com/office/drawing/2014/main" id="{D2D21716-6BD7-4A50-9558-0D0C13985C2D}"/>
+              </a:ext>
+            </a:extLst>
+          </p:cNvPr>
+          <p:cNvCxnSpPr>
+            <a:cxnSpLocks/>
+            <a:stCxn id="13" idx="2"/>
+            <a:endCxn id="28" idx="7"/>
+          </p:cNvCxnSpPr>
+          <p:nvPr/>
+        </p:nvCxnSpPr>
+        <p:spPr>
+          <a:xfrm flipH="1">
+            <a:off x="1745476" y="1706964"/>
+            <a:ext cx="1271553" cy="618127"/>
+          </a:xfrm>
+          <a:prstGeom prst="straightConnector1">
+            <a:avLst/>
+          </a:prstGeom>
+          <a:ln>
+            <a:tailEnd type="triangle"/>
+          </a:ln>
+        </p:spPr>
+        <p:style>
+          <a:lnRef idx="3">
+            <a:schemeClr val="dk1"/>
+          </a:lnRef>
+          <a:fillRef idx="0">
+            <a:schemeClr val="dk1"/>
+          </a:fillRef>
+          <a:effectRef idx="2">
+            <a:schemeClr val="dk1"/>
+          </a:effectRef>
+          <a:fontRef idx="minor">
+            <a:schemeClr val="tx1"/>
+          </a:fontRef>
+        </p:style>
+      </p:cxnSp>
+      <p:cxnSp>
+        <p:nvCxnSpPr>
+          <p:cNvPr id="12" name="Straight Arrow Connector 11">
+            <a:extLst>
+              <a:ext uri="{FF2B5EF4-FFF2-40B4-BE49-F238E27FC236}">
+                <a16:creationId xmlns:a16="http://schemas.microsoft.com/office/drawing/2014/main" id="{8588E362-09B2-4B0B-BBDE-2EFEFF000F9B}"/>
+              </a:ext>
+            </a:extLst>
+          </p:cNvPr>
+          <p:cNvCxnSpPr>
+            <a:cxnSpLocks/>
+            <a:stCxn id="13" idx="2"/>
+            <a:endCxn id="30" idx="1"/>
+          </p:cNvCxnSpPr>
+          <p:nvPr/>
+        </p:nvCxnSpPr>
+        <p:spPr>
+          <a:xfrm>
+            <a:off x="3017029" y="1706964"/>
+            <a:ext cx="1532465" cy="797849"/>
+          </a:xfrm>
+          <a:prstGeom prst="straightConnector1">
+            <a:avLst/>
+          </a:prstGeom>
+          <a:ln>
+            <a:tailEnd type="triangle"/>
+          </a:ln>
+        </p:spPr>
+        <p:style>
+          <a:lnRef idx="3">
+            <a:schemeClr val="dk1"/>
+          </a:lnRef>
+          <a:fillRef idx="0">
+            <a:schemeClr val="dk1"/>
+          </a:fillRef>
+          <a:effectRef idx="2">
+            <a:schemeClr val="dk1"/>
+          </a:effectRef>
+          <a:fontRef idx="minor">
+            <a:schemeClr val="tx1"/>
+          </a:fontRef>
+        </p:style>
+      </p:cxnSp>
+      <p:sp>
+        <p:nvSpPr>
+          <p:cNvPr id="13" name="TextBox 12">
+            <a:extLst>
+              <a:ext uri="{FF2B5EF4-FFF2-40B4-BE49-F238E27FC236}">
+                <a16:creationId xmlns:a16="http://schemas.microsoft.com/office/drawing/2014/main" id="{6406D038-F66B-4859-9416-A23E4E34906D}"/>
+              </a:ext>
+            </a:extLst>
+          </p:cNvPr>
+          <p:cNvSpPr txBox="1"/>
+          <p:nvPr/>
+        </p:nvSpPr>
+        <p:spPr>
+          <a:xfrm>
+            <a:off x="1490242" y="1337632"/>
+            <a:ext cx="3053573" cy="369332"/>
+          </a:xfrm>
+          <a:prstGeom prst="rect">
+            <a:avLst/>
+          </a:prstGeom>
+          <a:noFill/>
+        </p:spPr>
+        <p:txBody>
+          <a:bodyPr wrap="square" rtlCol="0">
+            <a:spAutoFit/>
+          </a:bodyPr>
+          <a:lstStyle/>
+          <a:p>
+            <a:pPr algn="ctr"/>
+            <a:r>
+              <a:rPr lang="it-IT" dirty="0"/>
+              <a:t>Set to NaN... Imputation?</a:t>
+            </a:r>
+            <a:endParaRPr lang="nl-NL" dirty="0"/>
+          </a:p>
+        </p:txBody>
+      </p:sp>
+      <p:sp>
+        <p:nvSpPr>
+          <p:cNvPr id="14" name="TextBox 13">
+            <a:extLst>
+              <a:ext uri="{FF2B5EF4-FFF2-40B4-BE49-F238E27FC236}">
+                <a16:creationId xmlns:a16="http://schemas.microsoft.com/office/drawing/2014/main" id="{F98F7243-8499-4EB9-8006-57DE1509E5C3}"/>
+              </a:ext>
+            </a:extLst>
+          </p:cNvPr>
+          <p:cNvSpPr txBox="1"/>
+          <p:nvPr/>
+        </p:nvSpPr>
+        <p:spPr>
+          <a:xfrm>
+            <a:off x="8060265" y="1152966"/>
+            <a:ext cx="2229853" cy="369332"/>
+          </a:xfrm>
+          <a:prstGeom prst="rect">
+            <a:avLst/>
+          </a:prstGeom>
+          <a:noFill/>
+        </p:spPr>
+        <p:txBody>
+          <a:bodyPr wrap="square" rtlCol="0">
+            <a:spAutoFit/>
+          </a:bodyPr>
+          <a:lstStyle/>
+          <a:p>
+            <a:r>
+              <a:rPr lang="it-IT" dirty="0"/>
+              <a:t>Considered Outliers</a:t>
+            </a:r>
+            <a:endParaRPr lang="nl-NL" dirty="0"/>
+          </a:p>
+        </p:txBody>
+      </p:sp>
+      <p:cxnSp>
+        <p:nvCxnSpPr>
+          <p:cNvPr id="16" name="Straight Arrow Connector 15">
+            <a:extLst>
+              <a:ext uri="{FF2B5EF4-FFF2-40B4-BE49-F238E27FC236}">
+                <a16:creationId xmlns:a16="http://schemas.microsoft.com/office/drawing/2014/main" id="{EF44B29E-148B-46BB-A8FF-E530EC852232}"/>
+              </a:ext>
+            </a:extLst>
+          </p:cNvPr>
+          <p:cNvCxnSpPr>
+            <a:cxnSpLocks/>
+            <a:stCxn id="14" idx="2"/>
+          </p:cNvCxnSpPr>
+          <p:nvPr/>
+        </p:nvCxnSpPr>
+        <p:spPr>
+          <a:xfrm>
+            <a:off x="9175192" y="1522298"/>
+            <a:ext cx="1451811" cy="1108426"/>
+          </a:xfrm>
+          <a:prstGeom prst="straightConnector1">
+            <a:avLst/>
+          </a:prstGeom>
+          <a:ln>
+            <a:tailEnd type="triangle"/>
+          </a:ln>
+        </p:spPr>
+        <p:style>
+          <a:lnRef idx="3">
+            <a:schemeClr val="dk1"/>
+          </a:lnRef>
+          <a:fillRef idx="0">
+            <a:schemeClr val="dk1"/>
+          </a:fillRef>
+          <a:effectRef idx="2">
+            <a:schemeClr val="dk1"/>
+          </a:effectRef>
+          <a:fontRef idx="minor">
+            <a:schemeClr val="tx1"/>
+          </a:fontRef>
+        </p:style>
+      </p:cxnSp>
+      <p:cxnSp>
+        <p:nvCxnSpPr>
+          <p:cNvPr id="18" name="Straight Arrow Connector 17">
+            <a:extLst>
+              <a:ext uri="{FF2B5EF4-FFF2-40B4-BE49-F238E27FC236}">
+                <a16:creationId xmlns:a16="http://schemas.microsoft.com/office/drawing/2014/main" id="{496788B4-CBEF-49A2-B29F-3DAC5165F805}"/>
+              </a:ext>
+            </a:extLst>
+          </p:cNvPr>
+          <p:cNvCxnSpPr>
+            <a:cxnSpLocks/>
+            <a:stCxn id="14" idx="2"/>
+          </p:cNvCxnSpPr>
+          <p:nvPr/>
+        </p:nvCxnSpPr>
+        <p:spPr>
+          <a:xfrm flipH="1">
+            <a:off x="7955994" y="1522298"/>
+            <a:ext cx="1219198" cy="1212700"/>
+          </a:xfrm>
+          <a:prstGeom prst="straightConnector1">
+            <a:avLst/>
+          </a:prstGeom>
+          <a:ln>
+            <a:tailEnd type="triangle"/>
+          </a:ln>
+        </p:spPr>
+        <p:style>
+          <a:lnRef idx="3">
+            <a:schemeClr val="dk1"/>
+          </a:lnRef>
+          <a:fillRef idx="0">
+            <a:schemeClr val="dk1"/>
+          </a:fillRef>
+          <a:effectRef idx="2">
+            <a:schemeClr val="dk1"/>
+          </a:effectRef>
+          <a:fontRef idx="minor">
+            <a:schemeClr val="tx1"/>
+          </a:fontRef>
+        </p:style>
+      </p:cxnSp>
+      <p:sp>
+        <p:nvSpPr>
+          <p:cNvPr id="28" name="Oval 27">
+            <a:extLst>
+              <a:ext uri="{FF2B5EF4-FFF2-40B4-BE49-F238E27FC236}">
+                <a16:creationId xmlns:a16="http://schemas.microsoft.com/office/drawing/2014/main" id="{5D3BB183-A2CA-46A2-B9C3-ADAE972B9027}"/>
+              </a:ext>
+            </a:extLst>
+          </p:cNvPr>
+          <p:cNvSpPr/>
+          <p:nvPr/>
+        </p:nvSpPr>
+        <p:spPr>
+          <a:xfrm>
+            <a:off x="1444235" y="2056559"/>
+            <a:ext cx="352926" cy="1833652"/>
+          </a:xfrm>
+          <a:prstGeom prst="ellipse">
+            <a:avLst/>
+          </a:prstGeom>
+          <a:noFill/>
+          <a:ln w="9525" cap="flat" cmpd="sng" algn="ctr">
+            <a:solidFill>
+              <a:schemeClr val="accent1"/>
+            </a:solidFill>
+            <a:prstDash val="solid"/>
+            <a:round/>
+            <a:headEnd type="none" w="med" len="med"/>
+            <a:tailEnd type="none" w="med" len="med"/>
+          </a:ln>
+        </p:spPr>
+        <p:style>
+          <a:lnRef idx="0">
+            <a:scrgbClr r="0" g="0" b="0"/>
+          </a:lnRef>
+          <a:fillRef idx="0">
+            <a:scrgbClr r="0" g="0" b="0"/>
+          </a:fillRef>
+          <a:effectRef idx="0">
+            <a:scrgbClr r="0" g="0" b="0"/>
+          </a:effectRef>
+          <a:fontRef idx="minor">
+            <a:schemeClr val="accent1"/>
+          </a:fontRef>
+        </p:style>
+        <p:txBody>
+          <a:bodyPr rtlCol="0" anchor="ctr"/>
+          <a:lstStyle/>
+          <a:p>
+            <a:pPr algn="ctr"/>
+            <a:endParaRPr lang="nl-NL"/>
+          </a:p>
+        </p:txBody>
+      </p:sp>
+      <p:sp>
+        <p:nvSpPr>
+          <p:cNvPr id="30" name="Oval 29">
+            <a:extLst>
+              <a:ext uri="{FF2B5EF4-FFF2-40B4-BE49-F238E27FC236}">
+                <a16:creationId xmlns:a16="http://schemas.microsoft.com/office/drawing/2014/main" id="{DFC1405A-A1FB-4B7D-A729-6F366D78F1F5}"/>
+              </a:ext>
+            </a:extLst>
+          </p:cNvPr>
+          <p:cNvSpPr/>
+          <p:nvPr/>
+        </p:nvSpPr>
+        <p:spPr>
+          <a:xfrm>
+            <a:off x="4497809" y="2056558"/>
+            <a:ext cx="352926" cy="3060874"/>
+          </a:xfrm>
+          <a:prstGeom prst="ellipse">
+            <a:avLst/>
+          </a:prstGeom>
+          <a:noFill/>
+          <a:ln w="9525" cap="flat" cmpd="sng" algn="ctr">
+            <a:solidFill>
+              <a:schemeClr val="accent1"/>
+            </a:solidFill>
+            <a:prstDash val="solid"/>
+            <a:round/>
+            <a:headEnd type="none" w="med" len="med"/>
+            <a:tailEnd type="none" w="med" len="med"/>
+          </a:ln>
+        </p:spPr>
+        <p:style>
+          <a:lnRef idx="0">
+            <a:scrgbClr r="0" g="0" b="0"/>
+          </a:lnRef>
+          <a:fillRef idx="0">
+            <a:scrgbClr r="0" g="0" b="0"/>
+          </a:fillRef>
+          <a:effectRef idx="0">
+            <a:scrgbClr r="0" g="0" b="0"/>
+          </a:effectRef>
+          <a:fontRef idx="minor">
+            <a:schemeClr val="accent1"/>
+          </a:fontRef>
+        </p:style>
+        <p:txBody>
+          <a:bodyPr rtlCol="0" anchor="ctr"/>
+          <a:lstStyle/>
+          <a:p>
+            <a:pPr algn="ctr"/>
+            <a:endParaRPr lang="nl-NL"/>
+          </a:p>
+        </p:txBody>
+      </p:sp>
+      <p:cxnSp>
+        <p:nvCxnSpPr>
+          <p:cNvPr id="47" name="Straight Connector 46">
+            <a:extLst>
+              <a:ext uri="{FF2B5EF4-FFF2-40B4-BE49-F238E27FC236}">
+                <a16:creationId xmlns:a16="http://schemas.microsoft.com/office/drawing/2014/main" id="{BB77F60D-AA92-4E88-9238-C37C7FCED343}"/>
+              </a:ext>
+            </a:extLst>
+          </p:cNvPr>
+          <p:cNvCxnSpPr/>
+          <p:nvPr/>
+        </p:nvCxnSpPr>
+        <p:spPr>
+          <a:xfrm>
+            <a:off x="344905" y="4868779"/>
+            <a:ext cx="2334126" cy="0"/>
+          </a:xfrm>
+          <a:prstGeom prst="line">
+            <a:avLst/>
+          </a:prstGeom>
+        </p:spPr>
+        <p:style>
+          <a:lnRef idx="3">
+            <a:schemeClr val="accent2"/>
+          </a:lnRef>
+          <a:fillRef idx="0">
+            <a:schemeClr val="accent2"/>
+          </a:fillRef>
+          <a:effectRef idx="2">
+            <a:schemeClr val="accent2"/>
+          </a:effectRef>
+          <a:fontRef idx="minor">
+            <a:schemeClr val="tx1"/>
+          </a:fontRef>
+        </p:style>
+      </p:cxnSp>
+      <p:sp>
+        <p:nvSpPr>
+          <p:cNvPr id="48" name="TextBox 47">
+            <a:extLst>
+              <a:ext uri="{FF2B5EF4-FFF2-40B4-BE49-F238E27FC236}">
+                <a16:creationId xmlns:a16="http://schemas.microsoft.com/office/drawing/2014/main" id="{210063D6-AB12-4D1A-8DD9-1B596D004A2F}"/>
+              </a:ext>
+            </a:extLst>
+          </p:cNvPr>
+          <p:cNvSpPr txBox="1"/>
+          <p:nvPr/>
+        </p:nvSpPr>
+        <p:spPr>
+          <a:xfrm>
+            <a:off x="2310061" y="4588042"/>
+            <a:ext cx="471458" cy="369332"/>
+          </a:xfrm>
+          <a:prstGeom prst="rect">
+            <a:avLst/>
+          </a:prstGeom>
+          <a:noFill/>
+        </p:spPr>
+        <p:txBody>
+          <a:bodyPr wrap="square" rtlCol="0">
+            <a:spAutoFit/>
+          </a:bodyPr>
+          <a:lstStyle/>
+          <a:p>
+            <a:pPr algn="ctr"/>
+            <a:r>
+              <a:rPr lang="it-IT" dirty="0">
+                <a:solidFill>
+                  <a:schemeClr val="accent2"/>
+                </a:solidFill>
+              </a:rPr>
+              <a:t>20</a:t>
+            </a:r>
+            <a:endParaRPr lang="nl-NL" dirty="0">
+              <a:solidFill>
+                <a:schemeClr val="accent2"/>
+              </a:solidFill>
+            </a:endParaRPr>
+          </a:p>
+        </p:txBody>
+      </p:sp>
+      <p:cxnSp>
+        <p:nvCxnSpPr>
+          <p:cNvPr id="49" name="Straight Connector 48">
+            <a:extLst>
+              <a:ext uri="{FF2B5EF4-FFF2-40B4-BE49-F238E27FC236}">
+                <a16:creationId xmlns:a16="http://schemas.microsoft.com/office/drawing/2014/main" id="{0BD6F6C2-AA8F-4637-B394-6AEB8944AE70}"/>
+              </a:ext>
+            </a:extLst>
+          </p:cNvPr>
+          <p:cNvCxnSpPr/>
+          <p:nvPr/>
+        </p:nvCxnSpPr>
+        <p:spPr>
+          <a:xfrm>
+            <a:off x="351141" y="3890211"/>
+            <a:ext cx="2334126" cy="0"/>
+          </a:xfrm>
+          <a:prstGeom prst="line">
+            <a:avLst/>
+          </a:prstGeom>
+        </p:spPr>
+        <p:style>
+          <a:lnRef idx="3">
+            <a:schemeClr val="accent2"/>
+          </a:lnRef>
+          <a:fillRef idx="0">
+            <a:schemeClr val="accent2"/>
+          </a:fillRef>
+          <a:effectRef idx="2">
+            <a:schemeClr val="accent2"/>
+          </a:effectRef>
+          <a:fontRef idx="minor">
+            <a:schemeClr val="tx1"/>
+          </a:fontRef>
+        </p:style>
+      </p:cxnSp>
+      <p:sp>
+        <p:nvSpPr>
+          <p:cNvPr id="50" name="TextBox 49">
+            <a:extLst>
+              <a:ext uri="{FF2B5EF4-FFF2-40B4-BE49-F238E27FC236}">
+                <a16:creationId xmlns:a16="http://schemas.microsoft.com/office/drawing/2014/main" id="{DC3D5BFC-C2C7-4C0B-8CCD-B5F0EF51BD42}"/>
+              </a:ext>
+            </a:extLst>
+          </p:cNvPr>
+          <p:cNvSpPr txBox="1"/>
+          <p:nvPr/>
+        </p:nvSpPr>
+        <p:spPr>
+          <a:xfrm>
+            <a:off x="2181726" y="3609474"/>
+            <a:ext cx="606029" cy="369332"/>
+          </a:xfrm>
+          <a:prstGeom prst="rect">
+            <a:avLst/>
+          </a:prstGeom>
+          <a:noFill/>
+        </p:spPr>
+        <p:txBody>
+          <a:bodyPr wrap="square" rtlCol="0">
+            <a:spAutoFit/>
+          </a:bodyPr>
+          <a:lstStyle/>
+          <a:p>
+            <a:pPr algn="ctr"/>
+            <a:r>
+              <a:rPr lang="it-IT" dirty="0">
+                <a:solidFill>
+                  <a:schemeClr val="accent2"/>
+                </a:solidFill>
+              </a:rPr>
+              <a:t>300</a:t>
+            </a:r>
+            <a:endParaRPr lang="nl-NL" dirty="0">
+              <a:solidFill>
+                <a:schemeClr val="accent2"/>
+              </a:solidFill>
+            </a:endParaRPr>
+          </a:p>
+        </p:txBody>
+      </p:sp>
+      <p:cxnSp>
+        <p:nvCxnSpPr>
+          <p:cNvPr id="51" name="Straight Connector 50">
+            <a:extLst>
+              <a:ext uri="{FF2B5EF4-FFF2-40B4-BE49-F238E27FC236}">
+                <a16:creationId xmlns:a16="http://schemas.microsoft.com/office/drawing/2014/main" id="{44BEA9E8-8FA9-4EBF-ADB1-F15EF59D545A}"/>
+              </a:ext>
+            </a:extLst>
+          </p:cNvPr>
+          <p:cNvCxnSpPr/>
+          <p:nvPr/>
+        </p:nvCxnSpPr>
+        <p:spPr>
+          <a:xfrm>
+            <a:off x="3376752" y="5219798"/>
+            <a:ext cx="2334126" cy="0"/>
+          </a:xfrm>
+          <a:prstGeom prst="line">
+            <a:avLst/>
+          </a:prstGeom>
+        </p:spPr>
+        <p:style>
+          <a:lnRef idx="3">
+            <a:schemeClr val="accent2"/>
+          </a:lnRef>
+          <a:fillRef idx="0">
+            <a:schemeClr val="accent2"/>
+          </a:fillRef>
+          <a:effectRef idx="2">
+            <a:schemeClr val="accent2"/>
+          </a:effectRef>
+          <a:fontRef idx="minor">
+            <a:schemeClr val="tx1"/>
+          </a:fontRef>
+        </p:style>
+      </p:cxnSp>
+      <p:sp>
+        <p:nvSpPr>
+          <p:cNvPr id="52" name="TextBox 51">
+            <a:extLst>
+              <a:ext uri="{FF2B5EF4-FFF2-40B4-BE49-F238E27FC236}">
+                <a16:creationId xmlns:a16="http://schemas.microsoft.com/office/drawing/2014/main" id="{A166A446-0273-44CD-8582-FA57872289AC}"/>
+              </a:ext>
+            </a:extLst>
+          </p:cNvPr>
+          <p:cNvSpPr txBox="1"/>
+          <p:nvPr/>
+        </p:nvSpPr>
+        <p:spPr>
+          <a:xfrm>
+            <a:off x="5624542" y="5035132"/>
+            <a:ext cx="471458" cy="369332"/>
+          </a:xfrm>
+          <a:prstGeom prst="rect">
+            <a:avLst/>
+          </a:prstGeom>
+          <a:noFill/>
+        </p:spPr>
+        <p:txBody>
+          <a:bodyPr wrap="square" rtlCol="0">
+            <a:spAutoFit/>
+          </a:bodyPr>
+          <a:lstStyle/>
+          <a:p>
+            <a:pPr algn="ctr"/>
+            <a:r>
+              <a:rPr lang="it-IT" dirty="0">
+                <a:solidFill>
+                  <a:schemeClr val="accent2"/>
+                </a:solidFill>
+              </a:rPr>
+              <a:t>20</a:t>
+            </a:r>
+            <a:endParaRPr lang="nl-NL" dirty="0">
+              <a:solidFill>
+                <a:schemeClr val="accent2"/>
+              </a:solidFill>
+            </a:endParaRPr>
+          </a:p>
+        </p:txBody>
+      </p:sp>
+      <p:cxnSp>
+        <p:nvCxnSpPr>
+          <p:cNvPr id="53" name="Straight Connector 52">
+            <a:extLst>
+              <a:ext uri="{FF2B5EF4-FFF2-40B4-BE49-F238E27FC236}">
+                <a16:creationId xmlns:a16="http://schemas.microsoft.com/office/drawing/2014/main" id="{7EEC18CD-74D0-4FAF-8860-CE57F8D1CFA6}"/>
+              </a:ext>
+            </a:extLst>
+          </p:cNvPr>
+          <p:cNvCxnSpPr/>
+          <p:nvPr/>
+        </p:nvCxnSpPr>
+        <p:spPr>
+          <a:xfrm>
+            <a:off x="3382988" y="5112781"/>
+            <a:ext cx="2334126" cy="0"/>
+          </a:xfrm>
+          <a:prstGeom prst="line">
+            <a:avLst/>
+          </a:prstGeom>
+        </p:spPr>
+        <p:style>
+          <a:lnRef idx="3">
+            <a:schemeClr val="accent2"/>
+          </a:lnRef>
+          <a:fillRef idx="0">
+            <a:schemeClr val="accent2"/>
+          </a:fillRef>
+          <a:effectRef idx="2">
+            <a:schemeClr val="accent2"/>
+          </a:effectRef>
+          <a:fontRef idx="minor">
+            <a:schemeClr val="tx1"/>
+          </a:fontRef>
+        </p:style>
+      </p:cxnSp>
+      <p:sp>
+        <p:nvSpPr>
+          <p:cNvPr id="54" name="TextBox 53">
+            <a:extLst>
+              <a:ext uri="{FF2B5EF4-FFF2-40B4-BE49-F238E27FC236}">
+                <a16:creationId xmlns:a16="http://schemas.microsoft.com/office/drawing/2014/main" id="{79388AA8-1909-4DBD-B882-1AB427F2771E}"/>
+              </a:ext>
+            </a:extLst>
+          </p:cNvPr>
+          <p:cNvSpPr txBox="1"/>
+          <p:nvPr/>
+        </p:nvSpPr>
+        <p:spPr>
+          <a:xfrm>
+            <a:off x="5566173" y="4796958"/>
+            <a:ext cx="606029" cy="369332"/>
+          </a:xfrm>
+          <a:prstGeom prst="rect">
+            <a:avLst/>
+          </a:prstGeom>
+          <a:noFill/>
+        </p:spPr>
+        <p:txBody>
+          <a:bodyPr wrap="square" rtlCol="0">
+            <a:spAutoFit/>
+          </a:bodyPr>
+          <a:lstStyle/>
+          <a:p>
+            <a:pPr algn="ctr"/>
+            <a:r>
+              <a:rPr lang="it-IT" dirty="0">
+                <a:solidFill>
+                  <a:schemeClr val="accent2"/>
+                </a:solidFill>
+              </a:rPr>
+              <a:t>300</a:t>
+            </a:r>
+            <a:endParaRPr lang="nl-NL" dirty="0">
+              <a:solidFill>
+                <a:schemeClr val="accent2"/>
+              </a:solidFill>
+            </a:endParaRPr>
+          </a:p>
+        </p:txBody>
+      </p:sp>
+      <p:sp>
+        <p:nvSpPr>
+          <p:cNvPr id="55" name="Arrow: Right 54">
+            <a:extLst>
+              <a:ext uri="{FF2B5EF4-FFF2-40B4-BE49-F238E27FC236}">
+                <a16:creationId xmlns:a16="http://schemas.microsoft.com/office/drawing/2014/main" id="{CF186115-EF21-4E45-BA1A-F7A01B55B725}"/>
+              </a:ext>
+            </a:extLst>
+          </p:cNvPr>
+          <p:cNvSpPr/>
+          <p:nvPr/>
+        </p:nvSpPr>
+        <p:spPr>
+          <a:xfrm>
+            <a:off x="5654279" y="3364185"/>
+            <a:ext cx="1094205" cy="369332"/>
+          </a:xfrm>
+          <a:prstGeom prst="rightArrow">
+            <a:avLst/>
+          </a:prstGeom>
+        </p:spPr>
+        <p:style>
+          <a:lnRef idx="2">
+            <a:schemeClr val="accent2">
+              <a:shade val="50000"/>
+            </a:schemeClr>
+          </a:lnRef>
+          <a:fillRef idx="1">
+            <a:schemeClr val="accent2"/>
+          </a:fillRef>
+          <a:effectRef idx="0">
+            <a:schemeClr val="accent2"/>
+          </a:effectRef>
+          <a:fontRef idx="minor">
+            <a:schemeClr val="lt1"/>
+          </a:fontRef>
+        </p:style>
+        <p:txBody>
+          <a:bodyPr rtlCol="0" anchor="ctr"/>
+          <a:lstStyle/>
+          <a:p>
+            <a:pPr algn="ctr"/>
+            <a:endParaRPr lang="nl-NL"/>
+          </a:p>
+        </p:txBody>
+      </p:sp>
+      <p:sp>
+        <p:nvSpPr>
+          <p:cNvPr id="57" name="Oval 56">
+            <a:extLst>
+              <a:ext uri="{FF2B5EF4-FFF2-40B4-BE49-F238E27FC236}">
+                <a16:creationId xmlns:a16="http://schemas.microsoft.com/office/drawing/2014/main" id="{F946F1D0-67D6-45FC-AEDB-3F765ADB089F}"/>
+              </a:ext>
+            </a:extLst>
+          </p:cNvPr>
+          <p:cNvSpPr/>
+          <p:nvPr/>
+        </p:nvSpPr>
+        <p:spPr>
+          <a:xfrm>
+            <a:off x="1444235" y="4886330"/>
+            <a:ext cx="352926" cy="473862"/>
+          </a:xfrm>
+          <a:prstGeom prst="ellipse">
+            <a:avLst/>
+          </a:prstGeom>
+          <a:noFill/>
+          <a:ln w="9525" cap="flat" cmpd="sng" algn="ctr">
+            <a:solidFill>
+              <a:schemeClr val="accent1"/>
+            </a:solidFill>
+            <a:prstDash val="solid"/>
+            <a:round/>
+            <a:headEnd type="none" w="med" len="med"/>
+            <a:tailEnd type="none" w="med" len="med"/>
+          </a:ln>
+        </p:spPr>
+        <p:style>
+          <a:lnRef idx="0">
+            <a:scrgbClr r="0" g="0" b="0"/>
+          </a:lnRef>
+          <a:fillRef idx="0">
+            <a:scrgbClr r="0" g="0" b="0"/>
+          </a:fillRef>
+          <a:effectRef idx="0">
+            <a:scrgbClr r="0" g="0" b="0"/>
+          </a:effectRef>
+          <a:fontRef idx="minor">
+            <a:schemeClr val="accent1"/>
+          </a:fontRef>
+        </p:style>
+        <p:txBody>
+          <a:bodyPr rtlCol="0" anchor="ctr"/>
+          <a:lstStyle/>
+          <a:p>
+            <a:pPr algn="ctr"/>
+            <a:endParaRPr lang="nl-NL"/>
+          </a:p>
+        </p:txBody>
+      </p:sp>
+    </p:spTree>
+    <p:extLst>
+      <p:ext uri="{BB962C8B-B14F-4D97-AF65-F5344CB8AC3E}">
+        <p14:creationId xmlns:p14="http://schemas.microsoft.com/office/powerpoint/2010/main" val="2308014033"/>
+      </p:ext>
+    </p:extLst>
+  </p:cSld>
+  <p:clrMapOvr>
+    <a:masterClrMapping/>
+  </p:clrMapOvr>
+  <mc:AlternateContent xmlns:mc="http://schemas.openxmlformats.org/markup-compatibility/2006" xmlns:p159="http://schemas.microsoft.com/office/powerpoint/2015/09/main">
+    <mc:Choice Requires="p159">
+      <p:transition spd="slow">
+        <p159:morph option="byObject"/>
+      </p:transition>
+    </mc:Choice>
+    <mc:Fallback xmlns="">
+      <p:transition spd="slow">
+        <p:fade/>
+      </p:transition>
+    </mc:Fallback>
+  </mc:AlternateContent>
+</p:sld>
+</file>
+
+<file path=ppt/slides/slide32.xml><?xml version="1.0" encoding="utf-8"?>
+<p:sld xmlns:a="http://schemas.openxmlformats.org/drawingml/2006/main" xmlns:r="http://schemas.openxmlformats.org/officeDocument/2006/relationships" xmlns:p="http://schemas.openxmlformats.org/presentationml/2006/main">
+  <p:cSld>
+    <p:spTree>
+      <p:nvGrpSpPr>
+        <p:cNvPr id="1" name=""/>
+        <p:cNvGrpSpPr/>
+        <p:nvPr/>
+      </p:nvGrpSpPr>
+      <p:grpSpPr>
+        <a:xfrm>
+          <a:off x="0" y="0"/>
+          <a:ext cx="0" cy="0"/>
+          <a:chOff x="0" y="0"/>
+          <a:chExt cx="0" cy="0"/>
+        </a:xfrm>
+      </p:grpSpPr>
+      <p:pic>
+        <p:nvPicPr>
+          <p:cNvPr id="2" name="Picture 1">
+            <a:extLst>
+              <a:ext uri="{FF2B5EF4-FFF2-40B4-BE49-F238E27FC236}">
+                <a16:creationId xmlns:a16="http://schemas.microsoft.com/office/drawing/2014/main" id="{EFCA64AE-70C0-46DC-9DE0-3BD016877CF0}"/>
+              </a:ext>
+            </a:extLst>
+          </p:cNvPr>
+          <p:cNvPicPr>
+            <a:picLocks noChangeAspect="1"/>
+          </p:cNvPicPr>
+          <p:nvPr/>
+        </p:nvPicPr>
+        <p:blipFill>
+          <a:blip r:embed="rId2">
+            <a:extLst>
+              <a:ext uri="{28A0092B-C50C-407E-A947-70E740481C1C}">
+                <a14:useLocalDpi xmlns:a14="http://schemas.microsoft.com/office/drawing/2010/main" val="0"/>
+              </a:ext>
+            </a:extLst>
+          </a:blip>
+          <a:stretch>
+            <a:fillRect/>
+          </a:stretch>
+        </p:blipFill>
+        <p:spPr>
+          <a:xfrm>
+            <a:off x="2471014" y="2125452"/>
+            <a:ext cx="7249970" cy="4405816"/>
+          </a:xfrm>
+          <a:prstGeom prst="rect">
+            <a:avLst/>
+          </a:prstGeom>
+        </p:spPr>
+      </p:pic>
+      <p:sp>
+        <p:nvSpPr>
+          <p:cNvPr id="3" name="TextBox 2">
+            <a:extLst>
+              <a:ext uri="{FF2B5EF4-FFF2-40B4-BE49-F238E27FC236}">
+                <a16:creationId xmlns:a16="http://schemas.microsoft.com/office/drawing/2014/main" id="{669BC41E-7A1B-450B-AE56-57E23EBB368B}"/>
+              </a:ext>
+            </a:extLst>
+          </p:cNvPr>
+          <p:cNvSpPr txBox="1"/>
+          <p:nvPr/>
+        </p:nvSpPr>
+        <p:spPr>
+          <a:xfrm>
+            <a:off x="0" y="0"/>
+            <a:ext cx="4395537" cy="369332"/>
+          </a:xfrm>
+          <a:prstGeom prst="rect">
+            <a:avLst/>
+          </a:prstGeom>
+          <a:noFill/>
+        </p:spPr>
+        <p:txBody>
+          <a:bodyPr wrap="square" rtlCol="0">
+            <a:spAutoFit/>
+          </a:bodyPr>
+          <a:lstStyle/>
+          <a:p>
+            <a:r>
+              <a:rPr lang="it-IT" u="sng" dirty="0"/>
+              <a:t>Blood Pressure Measurements - Outliers</a:t>
+            </a:r>
+            <a:endParaRPr lang="nl-NL" u="sng" dirty="0"/>
+          </a:p>
+        </p:txBody>
+      </p:sp>
+      <p:sp>
+        <p:nvSpPr>
+          <p:cNvPr id="4" name="TextBox 3">
+            <a:extLst>
+              <a:ext uri="{FF2B5EF4-FFF2-40B4-BE49-F238E27FC236}">
+                <a16:creationId xmlns:a16="http://schemas.microsoft.com/office/drawing/2014/main" id="{9D83727A-AEE6-4E01-9A07-195FB57628BF}"/>
+              </a:ext>
+            </a:extLst>
+          </p:cNvPr>
+          <p:cNvSpPr txBox="1"/>
+          <p:nvPr/>
+        </p:nvSpPr>
+        <p:spPr>
+          <a:xfrm>
+            <a:off x="2709862" y="811929"/>
+            <a:ext cx="6772275" cy="1200329"/>
+          </a:xfrm>
+          <a:prstGeom prst="rect">
+            <a:avLst/>
+          </a:prstGeom>
+          <a:noFill/>
+        </p:spPr>
+        <p:txBody>
+          <a:bodyPr wrap="square" rtlCol="0">
+            <a:spAutoFit/>
+          </a:bodyPr>
+          <a:lstStyle/>
+          <a:p>
+            <a:pPr algn="ctr"/>
+            <a:r>
+              <a:rPr lang="it-IT" sz="2400" dirty="0"/>
+              <a:t>Replaced with Mean value </a:t>
+            </a:r>
+          </a:p>
+          <a:p>
+            <a:pPr algn="ctr"/>
+            <a:r>
+              <a:rPr lang="it-IT" sz="2400" dirty="0"/>
+              <a:t>if </a:t>
+            </a:r>
+          </a:p>
+          <a:p>
+            <a:pPr algn="ctr"/>
+            <a:r>
+              <a:rPr lang="it-IT" sz="2400" dirty="0"/>
+              <a:t>|BP</a:t>
+            </a:r>
+            <a:r>
+              <a:rPr lang="it-IT" sz="2400" baseline="-25000" dirty="0"/>
+              <a:t>Sys,Dia</a:t>
+            </a:r>
+            <a:r>
+              <a:rPr lang="it-IT" sz="2400" dirty="0"/>
+              <a:t>| </a:t>
+            </a:r>
+            <a:r>
+              <a:rPr lang="nl-NL" sz="2400" dirty="0"/>
+              <a:t>&lt; 3·</a:t>
+            </a:r>
+            <a:r>
+              <a:rPr lang="el-GR" sz="2400" dirty="0"/>
+              <a:t>σ</a:t>
+            </a:r>
+            <a:endParaRPr lang="nl-NL" sz="2400" dirty="0"/>
+          </a:p>
+        </p:txBody>
+      </p:sp>
+    </p:spTree>
+    <p:extLst>
+      <p:ext uri="{BB962C8B-B14F-4D97-AF65-F5344CB8AC3E}">
+        <p14:creationId xmlns:p14="http://schemas.microsoft.com/office/powerpoint/2010/main" val="483860090"/>
+      </p:ext>
+    </p:extLst>
+  </p:cSld>
+  <p:clrMapOvr>
+    <a:masterClrMapping/>
+  </p:clrMapOvr>
+  <mc:AlternateContent xmlns:mc="http://schemas.openxmlformats.org/markup-compatibility/2006" xmlns:p159="http://schemas.microsoft.com/office/powerpoint/2015/09/main">
+    <mc:Choice Requires="p159">
+      <p:transition spd="slow">
+        <p159:morph option="byObject"/>
+      </p:transition>
+    </mc:Choice>
+    <mc:Fallback xmlns="">
+      <p:transition spd="slow">
+        <p:fade/>
+      </p:transition>
+    </mc:Fallback>
+  </mc:AlternateContent>
+</p:sld>
+</file>
+
+<file path=ppt/slides/slide33.xml><?xml version="1.0" encoding="utf-8"?>
+<p:sld xmlns:a="http://schemas.openxmlformats.org/drawingml/2006/main" xmlns:r="http://schemas.openxmlformats.org/officeDocument/2006/relationships" xmlns:p="http://schemas.openxmlformats.org/presentationml/2006/main">
+  <p:cSld>
+    <p:spTree>
+      <p:nvGrpSpPr>
+        <p:cNvPr id="1" name=""/>
+        <p:cNvGrpSpPr/>
+        <p:nvPr/>
+      </p:nvGrpSpPr>
+      <p:grpSpPr>
+        <a:xfrm>
+          <a:off x="0" y="0"/>
+          <a:ext cx="0" cy="0"/>
+          <a:chOff x="0" y="0"/>
+          <a:chExt cx="0" cy="0"/>
+        </a:xfrm>
+      </p:grpSpPr>
+      <p:sp>
+        <p:nvSpPr>
+          <p:cNvPr id="2" name="Title 1">
+            <a:extLst>
+              <a:ext uri="{FF2B5EF4-FFF2-40B4-BE49-F238E27FC236}">
+                <a16:creationId xmlns:a16="http://schemas.microsoft.com/office/drawing/2014/main" id="{E2742523-2057-44B4-9FB1-A3B7126FBF7F}"/>
+              </a:ext>
+            </a:extLst>
+          </p:cNvPr>
+          <p:cNvSpPr>
+            <a:spLocks noGrp="1"/>
+          </p:cNvSpPr>
+          <p:nvPr>
+            <p:ph type="title"/>
+          </p:nvPr>
+        </p:nvSpPr>
+        <p:spPr>
+          <a:xfrm>
+            <a:off x="838200" y="2766218"/>
+            <a:ext cx="10515600" cy="1325563"/>
+          </a:xfrm>
+        </p:spPr>
+        <p:txBody>
+          <a:bodyPr/>
+          <a:lstStyle/>
+          <a:p>
+            <a:pPr algn="ctr"/>
+            <a:r>
+              <a:rPr lang="it-IT" dirty="0"/>
+              <a:t>Eligibility to LHS</a:t>
+            </a:r>
+            <a:endParaRPr lang="nl-NL" dirty="0"/>
+          </a:p>
+        </p:txBody>
+      </p:sp>
+    </p:spTree>
+    <p:extLst>
+      <p:ext uri="{BB962C8B-B14F-4D97-AF65-F5344CB8AC3E}">
+        <p14:creationId xmlns:p14="http://schemas.microsoft.com/office/powerpoint/2010/main" val="64685501"/>
+      </p:ext>
+    </p:extLst>
+  </p:cSld>
+  <p:clrMapOvr>
+    <a:masterClrMapping/>
+  </p:clrMapOvr>
+  <mc:AlternateContent xmlns:mc="http://schemas.openxmlformats.org/markup-compatibility/2006" xmlns:p159="http://schemas.microsoft.com/office/powerpoint/2015/09/main">
+    <mc:Choice Requires="p159">
+      <p:transition spd="slow">
+        <p159:morph option="byObject"/>
+      </p:transition>
+    </mc:Choice>
+    <mc:Fallback xmlns="">
+      <p:transition spd="slow">
+        <p:fade/>
+      </p:transition>
+    </mc:Fallback>
+  </mc:AlternateContent>
+</p:sld>
+</file>
+
+<file path=ppt/slides/slide34.xml><?xml version="1.0" encoding="utf-8"?>
 <p:sld xmlns:a="http://schemas.openxmlformats.org/drawingml/2006/main" xmlns:r="http://schemas.openxmlformats.org/officeDocument/2006/relationships" xmlns:p="http://schemas.openxmlformats.org/presentationml/2006/main">
   <p:cSld>
     <p:spTree>
@@ -11179,7 +12183,7 @@
 </p:sld>
 </file>
 
-<file path=ppt/slides/slide31.xml><?xml version="1.0" encoding="utf-8"?>
+<file path=ppt/slides/slide35.xml><?xml version="1.0" encoding="utf-8"?>
 <p:sld xmlns:a="http://schemas.openxmlformats.org/drawingml/2006/main" xmlns:r="http://schemas.openxmlformats.org/officeDocument/2006/relationships" xmlns:p="http://schemas.openxmlformats.org/presentationml/2006/main">
   <p:cSld>
     <p:spTree>
@@ -11548,7 +12552,7 @@
 </p:sld>
 </file>
 
-<file path=ppt/slides/slide32.xml><?xml version="1.0" encoding="utf-8"?>
+<file path=ppt/slides/slide36.xml><?xml version="1.0" encoding="utf-8"?>
 <p:sld xmlns:a="http://schemas.openxmlformats.org/drawingml/2006/main" xmlns:r="http://schemas.openxmlformats.org/officeDocument/2006/relationships" xmlns:p="http://schemas.openxmlformats.org/presentationml/2006/main">
   <p:cSld>
     <p:spTree>
@@ -12040,7 +13044,7 @@
 </p:sld>
 </file>
 
-<file path=ppt/slides/slide33.xml><?xml version="1.0" encoding="utf-8"?>
+<file path=ppt/slides/slide37.xml><?xml version="1.0" encoding="utf-8"?>
 <p:sld xmlns:a="http://schemas.openxmlformats.org/drawingml/2006/main" xmlns:r="http://schemas.openxmlformats.org/officeDocument/2006/relationships" xmlns:p="http://schemas.openxmlformats.org/presentationml/2006/main">
   <p:cSld>
     <p:spTree>
@@ -14544,7 +15548,7 @@
 </file>
 
 <file path=ppt/slides/slide7.xml><?xml version="1.0" encoding="utf-8"?>
-<p:sld xmlns:a="http://schemas.openxmlformats.org/drawingml/2006/main" xmlns:r="http://schemas.openxmlformats.org/officeDocument/2006/relationships" xmlns:p="http://schemas.openxmlformats.org/presentationml/2006/main" show="0">
+<p:sld xmlns:a="http://schemas.openxmlformats.org/drawingml/2006/main" xmlns:r="http://schemas.openxmlformats.org/officeDocument/2006/relationships" xmlns:p="http://schemas.openxmlformats.org/presentationml/2006/main">
   <p:cSld>
     <p:spTree>
       <p:nvGrpSpPr>
@@ -14820,7 +15824,7 @@
 </file>
 
 <file path=ppt/slides/slide8.xml><?xml version="1.0" encoding="utf-8"?>
-<p:sld xmlns:a="http://schemas.openxmlformats.org/drawingml/2006/main" xmlns:r="http://schemas.openxmlformats.org/officeDocument/2006/relationships" xmlns:p="http://schemas.openxmlformats.org/presentationml/2006/main" show="0">
+<p:sld xmlns:a="http://schemas.openxmlformats.org/drawingml/2006/main" xmlns:r="http://schemas.openxmlformats.org/officeDocument/2006/relationships" xmlns:p="http://schemas.openxmlformats.org/presentationml/2006/main">
   <p:cSld>
     <p:spTree>
       <p:nvGrpSpPr>
@@ -15256,7 +16260,7 @@
           <a:p>
             <a:r>
               <a:rPr lang="it-IT" dirty="0"/>
-              <a:t>This is the Pivoted data, that can increase the scarcity of the data</a:t>
+              <a:t>This is the Pivoted table, that can increase the scarcity of the data</a:t>
             </a:r>
             <a:endParaRPr lang="nl-NL" dirty="0"/>
           </a:p>

</xml_diff>

<commit_message>
mice forest added on metingen
</commit_message>
<xml_diff>
--- a/assets/ppt/data_exploration.pptx
+++ b/assets/ppt/data_exploration.pptx
@@ -4762,7 +4762,7 @@
 </file>
 
 <file path=ppt/slides/slide10.xml><?xml version="1.0" encoding="utf-8"?>
-<p:sld xmlns:a="http://schemas.openxmlformats.org/drawingml/2006/main" xmlns:r="http://schemas.openxmlformats.org/officeDocument/2006/relationships" xmlns:p="http://schemas.openxmlformats.org/presentationml/2006/main">
+<p:sld xmlns:a="http://schemas.openxmlformats.org/drawingml/2006/main" xmlns:r="http://schemas.openxmlformats.org/officeDocument/2006/relationships" xmlns:p="http://schemas.openxmlformats.org/presentationml/2006/main" show="0">
   <p:cSld>
     <p:spTree>
       <p:nvGrpSpPr>
@@ -4940,13 +4940,13 @@
   <p:clrMapOvr>
     <a:masterClrMapping/>
   </p:clrMapOvr>
-  <mc:AlternateContent xmlns:mc="http://schemas.openxmlformats.org/markup-compatibility/2006" xmlns:p159="http://schemas.microsoft.com/office/powerpoint/2015/09/main">
-    <mc:Choice Requires="p159">
+  <mc:AlternateContent xmlns:mc="http://schemas.openxmlformats.org/markup-compatibility/2006">
+    <mc:Choice xmlns:p159="http://schemas.microsoft.com/office/powerpoint/2015/09/main" Requires="p159">
       <p:transition spd="slow">
         <p159:morph option="byObject"/>
       </p:transition>
     </mc:Choice>
-    <mc:Fallback xmlns="">
+    <mc:Fallback>
       <p:transition spd="slow">
         <p:fade/>
       </p:transition>
@@ -4956,7 +4956,7 @@
 </file>
 
 <file path=ppt/slides/slide11.xml><?xml version="1.0" encoding="utf-8"?>
-<p:sld xmlns:a="http://schemas.openxmlformats.org/drawingml/2006/main" xmlns:r="http://schemas.openxmlformats.org/officeDocument/2006/relationships" xmlns:p="http://schemas.openxmlformats.org/presentationml/2006/main">
+<p:sld xmlns:a="http://schemas.openxmlformats.org/drawingml/2006/main" xmlns:r="http://schemas.openxmlformats.org/officeDocument/2006/relationships" xmlns:p="http://schemas.openxmlformats.org/presentationml/2006/main" show="0">
   <p:cSld>
     <p:spTree>
       <p:nvGrpSpPr>
@@ -5054,13 +5054,13 @@
   <p:clrMapOvr>
     <a:masterClrMapping/>
   </p:clrMapOvr>
-  <mc:AlternateContent xmlns:mc="http://schemas.openxmlformats.org/markup-compatibility/2006" xmlns:p159="http://schemas.microsoft.com/office/powerpoint/2015/09/main">
-    <mc:Choice Requires="p159">
+  <mc:AlternateContent xmlns:mc="http://schemas.openxmlformats.org/markup-compatibility/2006">
+    <mc:Choice xmlns:p159="http://schemas.microsoft.com/office/powerpoint/2015/09/main" Requires="p159">
       <p:transition spd="slow">
         <p159:morph option="byObject"/>
       </p:transition>
     </mc:Choice>
-    <mc:Fallback xmlns="">
+    <mc:Fallback>
       <p:transition spd="slow">
         <p:fade/>
       </p:transition>
@@ -5070,7 +5070,7 @@
 </file>
 
 <file path=ppt/slides/slide12.xml><?xml version="1.0" encoding="utf-8"?>
-<p:sld xmlns:a="http://schemas.openxmlformats.org/drawingml/2006/main" xmlns:r="http://schemas.openxmlformats.org/officeDocument/2006/relationships" xmlns:p="http://schemas.openxmlformats.org/presentationml/2006/main">
+<p:sld xmlns:a="http://schemas.openxmlformats.org/drawingml/2006/main" xmlns:r="http://schemas.openxmlformats.org/officeDocument/2006/relationships" xmlns:p="http://schemas.openxmlformats.org/presentationml/2006/main" show="0">
   <p:cSld>
     <p:spTree>
       <p:nvGrpSpPr>
@@ -5168,13 +5168,13 @@
   <p:clrMapOvr>
     <a:masterClrMapping/>
   </p:clrMapOvr>
-  <mc:AlternateContent xmlns:mc="http://schemas.openxmlformats.org/markup-compatibility/2006" xmlns:p159="http://schemas.microsoft.com/office/powerpoint/2015/09/main">
-    <mc:Choice Requires="p159">
+  <mc:AlternateContent xmlns:mc="http://schemas.openxmlformats.org/markup-compatibility/2006">
+    <mc:Choice xmlns:p159="http://schemas.microsoft.com/office/powerpoint/2015/09/main" Requires="p159">
       <p:transition spd="slow">
         <p159:morph option="byObject"/>
       </p:transition>
     </mc:Choice>
-    <mc:Fallback xmlns="">
+    <mc:Fallback>
       <p:transition spd="slow">
         <p:fade/>
       </p:transition>
@@ -5184,7 +5184,7 @@
 </file>
 
 <file path=ppt/slides/slide13.xml><?xml version="1.0" encoding="utf-8"?>
-<p:sld xmlns:a="http://schemas.openxmlformats.org/drawingml/2006/main" xmlns:r="http://schemas.openxmlformats.org/officeDocument/2006/relationships" xmlns:p="http://schemas.openxmlformats.org/presentationml/2006/main">
+<p:sld xmlns:a="http://schemas.openxmlformats.org/drawingml/2006/main" xmlns:r="http://schemas.openxmlformats.org/officeDocument/2006/relationships" xmlns:p="http://schemas.openxmlformats.org/presentationml/2006/main" show="0">
   <p:cSld>
     <p:spTree>
       <p:nvGrpSpPr>
@@ -5318,13 +5318,13 @@
   <p:clrMapOvr>
     <a:masterClrMapping/>
   </p:clrMapOvr>
-  <mc:AlternateContent xmlns:mc="http://schemas.openxmlformats.org/markup-compatibility/2006" xmlns:p159="http://schemas.microsoft.com/office/powerpoint/2015/09/main">
-    <mc:Choice Requires="p159">
+  <mc:AlternateContent xmlns:mc="http://schemas.openxmlformats.org/markup-compatibility/2006">
+    <mc:Choice xmlns:p159="http://schemas.microsoft.com/office/powerpoint/2015/09/main" Requires="p159">
       <p:transition spd="slow">
         <p159:morph option="byObject"/>
       </p:transition>
     </mc:Choice>
-    <mc:Fallback xmlns="">
+    <mc:Fallback>
       <p:transition spd="slow">
         <p:fade/>
       </p:transition>
@@ -5334,7 +5334,7 @@
 </file>
 
 <file path=ppt/slides/slide14.xml><?xml version="1.0" encoding="utf-8"?>
-<p:sld xmlns:a="http://schemas.openxmlformats.org/drawingml/2006/main" xmlns:r="http://schemas.openxmlformats.org/officeDocument/2006/relationships" xmlns:p="http://schemas.openxmlformats.org/presentationml/2006/main">
+<p:sld xmlns:a="http://schemas.openxmlformats.org/drawingml/2006/main" xmlns:r="http://schemas.openxmlformats.org/officeDocument/2006/relationships" xmlns:p="http://schemas.openxmlformats.org/presentationml/2006/main" show="0">
   <p:cSld>
     <p:spTree>
       <p:nvGrpSpPr>
@@ -5432,13 +5432,13 @@
   <p:clrMapOvr>
     <a:masterClrMapping/>
   </p:clrMapOvr>
-  <mc:AlternateContent xmlns:mc="http://schemas.openxmlformats.org/markup-compatibility/2006" xmlns:p159="http://schemas.microsoft.com/office/powerpoint/2015/09/main">
-    <mc:Choice Requires="p159">
+  <mc:AlternateContent xmlns:mc="http://schemas.openxmlformats.org/markup-compatibility/2006">
+    <mc:Choice xmlns:p159="http://schemas.microsoft.com/office/powerpoint/2015/09/main" Requires="p159">
       <p:transition spd="slow">
         <p159:morph option="byObject"/>
       </p:transition>
     </mc:Choice>
-    <mc:Fallback xmlns="">
+    <mc:Fallback>
       <p:transition spd="slow">
         <p:fade/>
       </p:transition>
@@ -5448,7 +5448,7 @@
 </file>
 
 <file path=ppt/slides/slide15.xml><?xml version="1.0" encoding="utf-8"?>
-<p:sld xmlns:a="http://schemas.openxmlformats.org/drawingml/2006/main" xmlns:r="http://schemas.openxmlformats.org/officeDocument/2006/relationships" xmlns:p="http://schemas.openxmlformats.org/presentationml/2006/main">
+<p:sld xmlns:a="http://schemas.openxmlformats.org/drawingml/2006/main" xmlns:r="http://schemas.openxmlformats.org/officeDocument/2006/relationships" xmlns:p="http://schemas.openxmlformats.org/presentationml/2006/main" show="0">
   <p:cSld>
     <p:spTree>
       <p:nvGrpSpPr>
@@ -5546,13 +5546,13 @@
   <p:clrMapOvr>
     <a:masterClrMapping/>
   </p:clrMapOvr>
-  <mc:AlternateContent xmlns:mc="http://schemas.openxmlformats.org/markup-compatibility/2006" xmlns:p159="http://schemas.microsoft.com/office/powerpoint/2015/09/main">
-    <mc:Choice Requires="p159">
+  <mc:AlternateContent xmlns:mc="http://schemas.openxmlformats.org/markup-compatibility/2006">
+    <mc:Choice xmlns:p159="http://schemas.microsoft.com/office/powerpoint/2015/09/main" Requires="p159">
       <p:transition spd="slow">
         <p159:morph option="byObject"/>
       </p:transition>
     </mc:Choice>
-    <mc:Fallback xmlns="">
+    <mc:Fallback>
       <p:transition spd="slow">
         <p:fade/>
       </p:transition>
@@ -5562,7 +5562,7 @@
 </file>
 
 <file path=ppt/slides/slide16.xml><?xml version="1.0" encoding="utf-8"?>
-<p:sld xmlns:a="http://schemas.openxmlformats.org/drawingml/2006/main" xmlns:r="http://schemas.openxmlformats.org/officeDocument/2006/relationships" xmlns:p="http://schemas.openxmlformats.org/presentationml/2006/main">
+<p:sld xmlns:a="http://schemas.openxmlformats.org/drawingml/2006/main" xmlns:r="http://schemas.openxmlformats.org/officeDocument/2006/relationships" xmlns:p="http://schemas.openxmlformats.org/presentationml/2006/main" show="0">
   <p:cSld>
     <p:spTree>
       <p:nvGrpSpPr>
@@ -5770,13 +5770,13 @@
   <p:clrMapOvr>
     <a:masterClrMapping/>
   </p:clrMapOvr>
-  <mc:AlternateContent xmlns:mc="http://schemas.openxmlformats.org/markup-compatibility/2006" xmlns:p159="http://schemas.microsoft.com/office/powerpoint/2015/09/main">
-    <mc:Choice Requires="p159">
+  <mc:AlternateContent xmlns:mc="http://schemas.openxmlformats.org/markup-compatibility/2006">
+    <mc:Choice xmlns:p159="http://schemas.microsoft.com/office/powerpoint/2015/09/main" Requires="p159">
       <p:transition spd="slow">
         <p159:morph option="byObject"/>
       </p:transition>
     </mc:Choice>
-    <mc:Fallback xmlns="">
+    <mc:Fallback>
       <p:transition spd="slow">
         <p:fade/>
       </p:transition>
@@ -5786,7 +5786,7 @@
 </file>
 
 <file path=ppt/slides/slide17.xml><?xml version="1.0" encoding="utf-8"?>
-<p:sld xmlns:a="http://schemas.openxmlformats.org/drawingml/2006/main" xmlns:r="http://schemas.openxmlformats.org/officeDocument/2006/relationships" xmlns:p="http://schemas.openxmlformats.org/presentationml/2006/main">
+<p:sld xmlns:a="http://schemas.openxmlformats.org/drawingml/2006/main" xmlns:r="http://schemas.openxmlformats.org/officeDocument/2006/relationships" xmlns:p="http://schemas.openxmlformats.org/presentationml/2006/main" show="0">
   <p:cSld>
     <p:spTree>
       <p:nvGrpSpPr>
@@ -6114,13 +6114,13 @@
   <p:clrMapOvr>
     <a:masterClrMapping/>
   </p:clrMapOvr>
-  <mc:AlternateContent xmlns:mc="http://schemas.openxmlformats.org/markup-compatibility/2006" xmlns:p159="http://schemas.microsoft.com/office/powerpoint/2015/09/main">
-    <mc:Choice Requires="p159">
+  <mc:AlternateContent xmlns:mc="http://schemas.openxmlformats.org/markup-compatibility/2006">
+    <mc:Choice xmlns:p159="http://schemas.microsoft.com/office/powerpoint/2015/09/main" Requires="p159">
       <p:transition spd="slow">
         <p159:morph option="byObject"/>
       </p:transition>
     </mc:Choice>
-    <mc:Fallback xmlns="">
+    <mc:Fallback>
       <p:transition spd="slow">
         <p:fade/>
       </p:transition>
@@ -6130,7 +6130,7 @@
 </file>
 
 <file path=ppt/slides/slide18.xml><?xml version="1.0" encoding="utf-8"?>
-<p:sld xmlns:a="http://schemas.openxmlformats.org/drawingml/2006/main" xmlns:r="http://schemas.openxmlformats.org/officeDocument/2006/relationships" xmlns:p="http://schemas.openxmlformats.org/presentationml/2006/main">
+<p:sld xmlns:a="http://schemas.openxmlformats.org/drawingml/2006/main" xmlns:r="http://schemas.openxmlformats.org/officeDocument/2006/relationships" xmlns:p="http://schemas.openxmlformats.org/presentationml/2006/main" show="0">
   <p:cSld>
     <p:spTree>
       <p:nvGrpSpPr>
@@ -6193,13 +6193,13 @@
   <p:clrMapOvr>
     <a:masterClrMapping/>
   </p:clrMapOvr>
-  <mc:AlternateContent xmlns:mc="http://schemas.openxmlformats.org/markup-compatibility/2006" xmlns:p159="http://schemas.microsoft.com/office/powerpoint/2015/09/main">
-    <mc:Choice Requires="p159">
+  <mc:AlternateContent xmlns:mc="http://schemas.openxmlformats.org/markup-compatibility/2006">
+    <mc:Choice xmlns:p159="http://schemas.microsoft.com/office/powerpoint/2015/09/main" Requires="p159">
       <p:transition spd="slow">
         <p159:morph option="byObject"/>
       </p:transition>
     </mc:Choice>
-    <mc:Fallback xmlns="">
+    <mc:Fallback>
       <p:transition spd="slow">
         <p:fade/>
       </p:transition>
@@ -6209,7 +6209,7 @@
 </file>
 
 <file path=ppt/slides/slide19.xml><?xml version="1.0" encoding="utf-8"?>
-<p:sld xmlns:a="http://schemas.openxmlformats.org/drawingml/2006/main" xmlns:r="http://schemas.openxmlformats.org/officeDocument/2006/relationships" xmlns:p="http://schemas.openxmlformats.org/presentationml/2006/main">
+<p:sld xmlns:a="http://schemas.openxmlformats.org/drawingml/2006/main" xmlns:r="http://schemas.openxmlformats.org/officeDocument/2006/relationships" xmlns:p="http://schemas.openxmlformats.org/presentationml/2006/main" show="0">
   <p:cSld>
     <p:spTree>
       <p:nvGrpSpPr>
@@ -7215,13 +7215,13 @@
   <p:clrMapOvr>
     <a:masterClrMapping/>
   </p:clrMapOvr>
-  <mc:AlternateContent xmlns:mc="http://schemas.openxmlformats.org/markup-compatibility/2006" xmlns:p159="http://schemas.microsoft.com/office/powerpoint/2015/09/main">
-    <mc:Choice Requires="p159">
+  <mc:AlternateContent xmlns:mc="http://schemas.openxmlformats.org/markup-compatibility/2006">
+    <mc:Choice xmlns:p159="http://schemas.microsoft.com/office/powerpoint/2015/09/main" Requires="p159">
       <p:transition spd="slow">
         <p159:morph option="byObject"/>
       </p:transition>
     </mc:Choice>
-    <mc:Fallback xmlns="">
+    <mc:Fallback>
       <p:transition spd="slow">
         <p:fade/>
       </p:transition>
@@ -7385,7 +7385,7 @@
 </file>
 
 <file path=ppt/slides/slide20.xml><?xml version="1.0" encoding="utf-8"?>
-<p:sld xmlns:a="http://schemas.openxmlformats.org/drawingml/2006/main" xmlns:r="http://schemas.openxmlformats.org/officeDocument/2006/relationships" xmlns:p="http://schemas.openxmlformats.org/presentationml/2006/main">
+<p:sld xmlns:a="http://schemas.openxmlformats.org/drawingml/2006/main" xmlns:r="http://schemas.openxmlformats.org/officeDocument/2006/relationships" xmlns:p="http://schemas.openxmlformats.org/presentationml/2006/main" show="0">
   <p:cSld>
     <p:spTree>
       <p:nvGrpSpPr>
@@ -9177,13 +9177,13 @@
   <p:clrMapOvr>
     <a:masterClrMapping/>
   </p:clrMapOvr>
-  <mc:AlternateContent xmlns:mc="http://schemas.openxmlformats.org/markup-compatibility/2006" xmlns:p159="http://schemas.microsoft.com/office/powerpoint/2015/09/main">
-    <mc:Choice Requires="p159">
+  <mc:AlternateContent xmlns:mc="http://schemas.openxmlformats.org/markup-compatibility/2006">
+    <mc:Choice xmlns:p159="http://schemas.microsoft.com/office/powerpoint/2015/09/main" Requires="p159">
       <p:transition spd="slow">
         <p159:morph option="byObject"/>
       </p:transition>
     </mc:Choice>
-    <mc:Fallback xmlns="">
+    <mc:Fallback>
       <p:transition spd="slow">
         <p:fade/>
       </p:transition>
@@ -9193,7 +9193,7 @@
 </file>
 
 <file path=ppt/slides/slide21.xml><?xml version="1.0" encoding="utf-8"?>
-<p:sld xmlns:a="http://schemas.openxmlformats.org/drawingml/2006/main" xmlns:r="http://schemas.openxmlformats.org/officeDocument/2006/relationships" xmlns:p="http://schemas.openxmlformats.org/presentationml/2006/main">
+<p:sld xmlns:a="http://schemas.openxmlformats.org/drawingml/2006/main" xmlns:r="http://schemas.openxmlformats.org/officeDocument/2006/relationships" xmlns:p="http://schemas.openxmlformats.org/presentationml/2006/main" show="0">
   <p:cSld>
     <p:spTree>
       <p:nvGrpSpPr>
@@ -9256,13 +9256,13 @@
   <p:clrMapOvr>
     <a:masterClrMapping/>
   </p:clrMapOvr>
-  <mc:AlternateContent xmlns:mc="http://schemas.openxmlformats.org/markup-compatibility/2006" xmlns:p159="http://schemas.microsoft.com/office/powerpoint/2015/09/main">
-    <mc:Choice Requires="p159">
+  <mc:AlternateContent xmlns:mc="http://schemas.openxmlformats.org/markup-compatibility/2006">
+    <mc:Choice xmlns:p159="http://schemas.microsoft.com/office/powerpoint/2015/09/main" Requires="p159">
       <p:transition spd="slow">
         <p159:morph option="byObject"/>
       </p:transition>
     </mc:Choice>
-    <mc:Fallback xmlns="">
+    <mc:Fallback>
       <p:transition spd="slow">
         <p:fade/>
       </p:transition>
@@ -10460,6 +10460,1333 @@
           <a:chExt cx="0" cy="0"/>
         </a:xfrm>
       </p:grpSpPr>
+      <p:pic>
+        <p:nvPicPr>
+          <p:cNvPr id="2" name="Graphic 1" descr="Database">
+            <a:extLst>
+              <a:ext uri="{FF2B5EF4-FFF2-40B4-BE49-F238E27FC236}">
+                <a16:creationId xmlns:a16="http://schemas.microsoft.com/office/drawing/2014/main" id="{7405DEB1-F797-41FD-AC52-AE5153BED84B}"/>
+              </a:ext>
+            </a:extLst>
+          </p:cNvPr>
+          <p:cNvPicPr>
+            <a:picLocks noChangeAspect="1"/>
+          </p:cNvPicPr>
+          <p:nvPr/>
+        </p:nvPicPr>
+        <p:blipFill>
+          <a:blip r:embed="rId2">
+            <a:extLst>
+              <a:ext uri="{28A0092B-C50C-407E-A947-70E740481C1C}">
+                <a14:useLocalDpi xmlns:a14="http://schemas.microsoft.com/office/drawing/2010/main" val="0"/>
+              </a:ext>
+              <a:ext uri="{96DAC541-7B7A-43D3-8B79-37D633B846F1}">
+                <asvg:svgBlip xmlns:asvg="http://schemas.microsoft.com/office/drawing/2016/SVG/main" r:embed="rId3"/>
+              </a:ext>
+            </a:extLst>
+          </a:blip>
+          <a:stretch>
+            <a:fillRect/>
+          </a:stretch>
+        </p:blipFill>
+        <p:spPr>
+          <a:xfrm>
+            <a:off x="1915583" y="2999691"/>
+            <a:ext cx="914400" cy="914400"/>
+          </a:xfrm>
+          <a:prstGeom prst="rect">
+            <a:avLst/>
+          </a:prstGeom>
+        </p:spPr>
+      </p:pic>
+      <p:pic>
+        <p:nvPicPr>
+          <p:cNvPr id="5" name="Graphic 4" descr="Database">
+            <a:extLst>
+              <a:ext uri="{FF2B5EF4-FFF2-40B4-BE49-F238E27FC236}">
+                <a16:creationId xmlns:a16="http://schemas.microsoft.com/office/drawing/2014/main" id="{2FC5F5C2-6DCF-4E5C-AC31-5042C508BCB0}"/>
+              </a:ext>
+            </a:extLst>
+          </p:cNvPr>
+          <p:cNvPicPr>
+            <a:picLocks noChangeAspect="1"/>
+          </p:cNvPicPr>
+          <p:nvPr/>
+        </p:nvPicPr>
+        <p:blipFill>
+          <a:blip r:embed="rId2">
+            <a:extLst>
+              <a:ext uri="{28A0092B-C50C-407E-A947-70E740481C1C}">
+                <a14:useLocalDpi xmlns:a14="http://schemas.microsoft.com/office/drawing/2010/main" val="0"/>
+              </a:ext>
+              <a:ext uri="{96DAC541-7B7A-43D3-8B79-37D633B846F1}">
+                <asvg:svgBlip xmlns:asvg="http://schemas.microsoft.com/office/drawing/2016/SVG/main" r:embed="rId3"/>
+              </a:ext>
+            </a:extLst>
+          </a:blip>
+          <a:stretch>
+            <a:fillRect/>
+          </a:stretch>
+        </p:blipFill>
+        <p:spPr>
+          <a:xfrm>
+            <a:off x="4774534" y="4106965"/>
+            <a:ext cx="577514" cy="577514"/>
+          </a:xfrm>
+          <a:prstGeom prst="rect">
+            <a:avLst/>
+          </a:prstGeom>
+        </p:spPr>
+      </p:pic>
+      <p:pic>
+        <p:nvPicPr>
+          <p:cNvPr id="6" name="Graphic 5" descr="Database">
+            <a:extLst>
+              <a:ext uri="{FF2B5EF4-FFF2-40B4-BE49-F238E27FC236}">
+                <a16:creationId xmlns:a16="http://schemas.microsoft.com/office/drawing/2014/main" id="{4247EEB0-3DA4-4027-A3AF-B37C18EE0AAC}"/>
+              </a:ext>
+            </a:extLst>
+          </p:cNvPr>
+          <p:cNvPicPr>
+            <a:picLocks noChangeAspect="1"/>
+          </p:cNvPicPr>
+          <p:nvPr/>
+        </p:nvPicPr>
+        <p:blipFill>
+          <a:blip r:embed="rId2">
+            <a:extLst>
+              <a:ext uri="{28A0092B-C50C-407E-A947-70E740481C1C}">
+                <a14:useLocalDpi xmlns:a14="http://schemas.microsoft.com/office/drawing/2010/main" val="0"/>
+              </a:ext>
+              <a:ext uri="{96DAC541-7B7A-43D3-8B79-37D633B846F1}">
+                <asvg:svgBlip xmlns:asvg="http://schemas.microsoft.com/office/drawing/2016/SVG/main" r:embed="rId3"/>
+              </a:ext>
+            </a:extLst>
+          </a:blip>
+          <a:stretch>
+            <a:fillRect/>
+          </a:stretch>
+        </p:blipFill>
+        <p:spPr>
+          <a:xfrm>
+            <a:off x="4774534" y="2422177"/>
+            <a:ext cx="577514" cy="577514"/>
+          </a:xfrm>
+          <a:prstGeom prst="rect">
+            <a:avLst/>
+          </a:prstGeom>
+        </p:spPr>
+      </p:pic>
+      <p:cxnSp>
+        <p:nvCxnSpPr>
+          <p:cNvPr id="8" name="Straight Arrow Connector 7">
+            <a:extLst>
+              <a:ext uri="{FF2B5EF4-FFF2-40B4-BE49-F238E27FC236}">
+                <a16:creationId xmlns:a16="http://schemas.microsoft.com/office/drawing/2014/main" id="{9E3FCF76-11AD-41A8-997C-012106AAC6EF}"/>
+              </a:ext>
+            </a:extLst>
+          </p:cNvPr>
+          <p:cNvCxnSpPr>
+            <a:stCxn id="2" idx="3"/>
+            <a:endCxn id="6" idx="1"/>
+          </p:cNvCxnSpPr>
+          <p:nvPr/>
+        </p:nvCxnSpPr>
+        <p:spPr>
+          <a:xfrm flipV="1">
+            <a:off x="2829983" y="2710934"/>
+            <a:ext cx="1944551" cy="745957"/>
+          </a:xfrm>
+          <a:prstGeom prst="straightConnector1">
+            <a:avLst/>
+          </a:prstGeom>
+          <a:ln w="9525" cap="flat" cmpd="sng" algn="ctr">
+            <a:solidFill>
+              <a:schemeClr val="dk1"/>
+            </a:solidFill>
+            <a:prstDash val="solid"/>
+            <a:round/>
+            <a:headEnd type="none" w="med" len="med"/>
+            <a:tailEnd type="arrow" w="med" len="med"/>
+          </a:ln>
+        </p:spPr>
+        <p:style>
+          <a:lnRef idx="0">
+            <a:scrgbClr r="0" g="0" b="0"/>
+          </a:lnRef>
+          <a:fillRef idx="0">
+            <a:scrgbClr r="0" g="0" b="0"/>
+          </a:fillRef>
+          <a:effectRef idx="0">
+            <a:scrgbClr r="0" g="0" b="0"/>
+          </a:effectRef>
+          <a:fontRef idx="minor">
+            <a:schemeClr val="tx1"/>
+          </a:fontRef>
+        </p:style>
+      </p:cxnSp>
+      <p:cxnSp>
+        <p:nvCxnSpPr>
+          <p:cNvPr id="10" name="Straight Arrow Connector 9">
+            <a:extLst>
+              <a:ext uri="{FF2B5EF4-FFF2-40B4-BE49-F238E27FC236}">
+                <a16:creationId xmlns:a16="http://schemas.microsoft.com/office/drawing/2014/main" id="{B5B291E3-ACA9-4C6C-9C01-90F93198D824}"/>
+              </a:ext>
+            </a:extLst>
+          </p:cNvPr>
+          <p:cNvCxnSpPr>
+            <a:stCxn id="2" idx="3"/>
+            <a:endCxn id="5" idx="1"/>
+          </p:cNvCxnSpPr>
+          <p:nvPr/>
+        </p:nvCxnSpPr>
+        <p:spPr>
+          <a:xfrm>
+            <a:off x="2829983" y="3456891"/>
+            <a:ext cx="1944551" cy="938831"/>
+          </a:xfrm>
+          <a:prstGeom prst="straightConnector1">
+            <a:avLst/>
+          </a:prstGeom>
+          <a:ln w="9525" cap="flat" cmpd="sng" algn="ctr">
+            <a:solidFill>
+              <a:schemeClr val="dk1"/>
+            </a:solidFill>
+            <a:prstDash val="solid"/>
+            <a:round/>
+            <a:headEnd type="none" w="med" len="med"/>
+            <a:tailEnd type="arrow" w="med" len="med"/>
+          </a:ln>
+        </p:spPr>
+        <p:style>
+          <a:lnRef idx="0">
+            <a:scrgbClr r="0" g="0" b="0"/>
+          </a:lnRef>
+          <a:fillRef idx="0">
+            <a:scrgbClr r="0" g="0" b="0"/>
+          </a:fillRef>
+          <a:effectRef idx="0">
+            <a:scrgbClr r="0" g="0" b="0"/>
+          </a:effectRef>
+          <a:fontRef idx="minor">
+            <a:schemeClr val="tx1"/>
+          </a:fontRef>
+        </p:style>
+      </p:cxnSp>
+      <p:sp>
+        <p:nvSpPr>
+          <p:cNvPr id="12" name="TextBox 11">
+            <a:extLst>
+              <a:ext uri="{FF2B5EF4-FFF2-40B4-BE49-F238E27FC236}">
+                <a16:creationId xmlns:a16="http://schemas.microsoft.com/office/drawing/2014/main" id="{074E7333-1183-4CE6-9A27-22DFDEC462A6}"/>
+              </a:ext>
+            </a:extLst>
+          </p:cNvPr>
+          <p:cNvSpPr txBox="1"/>
+          <p:nvPr/>
+        </p:nvSpPr>
+        <p:spPr>
+          <a:xfrm>
+            <a:off x="3992481" y="2028962"/>
+            <a:ext cx="2141620" cy="369332"/>
+          </a:xfrm>
+          <a:prstGeom prst="rect">
+            <a:avLst/>
+          </a:prstGeom>
+          <a:noFill/>
+        </p:spPr>
+        <p:txBody>
+          <a:bodyPr wrap="square" rtlCol="0">
+            <a:spAutoFit/>
+          </a:bodyPr>
+          <a:lstStyle/>
+          <a:p>
+            <a:pPr algn="ctr"/>
+            <a:r>
+              <a:rPr lang="it-IT" dirty="0"/>
+              <a:t>Base Measurements</a:t>
+            </a:r>
+            <a:endParaRPr lang="en-US" dirty="0"/>
+          </a:p>
+        </p:txBody>
+      </p:sp>
+      <p:sp>
+        <p:nvSpPr>
+          <p:cNvPr id="13" name="TextBox 12">
+            <a:extLst>
+              <a:ext uri="{FF2B5EF4-FFF2-40B4-BE49-F238E27FC236}">
+                <a16:creationId xmlns:a16="http://schemas.microsoft.com/office/drawing/2014/main" id="{75BD85AE-4829-44BB-AF28-37B3DCA7EAAB}"/>
+              </a:ext>
+            </a:extLst>
+          </p:cNvPr>
+          <p:cNvSpPr txBox="1"/>
+          <p:nvPr/>
+        </p:nvSpPr>
+        <p:spPr>
+          <a:xfrm>
+            <a:off x="3942349" y="4684478"/>
+            <a:ext cx="2241883" cy="369332"/>
+          </a:xfrm>
+          <a:prstGeom prst="rect">
+            <a:avLst/>
+          </a:prstGeom>
+          <a:noFill/>
+        </p:spPr>
+        <p:txBody>
+          <a:bodyPr wrap="square" rtlCol="0">
+            <a:spAutoFit/>
+          </a:bodyPr>
+          <a:lstStyle/>
+          <a:p>
+            <a:pPr algn="ctr"/>
+            <a:r>
+              <a:rPr lang="it-IT" dirty="0"/>
+              <a:t>Score Measurements</a:t>
+            </a:r>
+            <a:endParaRPr lang="en-US" dirty="0"/>
+          </a:p>
+        </p:txBody>
+      </p:sp>
+      <p:sp>
+        <p:nvSpPr>
+          <p:cNvPr id="14" name="TextBox 13">
+            <a:extLst>
+              <a:ext uri="{FF2B5EF4-FFF2-40B4-BE49-F238E27FC236}">
+                <a16:creationId xmlns:a16="http://schemas.microsoft.com/office/drawing/2014/main" id="{E7F1FC96-EBE4-4DD6-AE78-89CA7084A6F0}"/>
+              </a:ext>
+            </a:extLst>
+          </p:cNvPr>
+          <p:cNvSpPr txBox="1"/>
+          <p:nvPr/>
+        </p:nvSpPr>
+        <p:spPr>
+          <a:xfrm>
+            <a:off x="0" y="0"/>
+            <a:ext cx="3729790" cy="369332"/>
+          </a:xfrm>
+          <a:prstGeom prst="rect">
+            <a:avLst/>
+          </a:prstGeom>
+          <a:noFill/>
+        </p:spPr>
+        <p:txBody>
+          <a:bodyPr wrap="square" rtlCol="0">
+            <a:spAutoFit/>
+          </a:bodyPr>
+          <a:lstStyle/>
+          <a:p>
+            <a:r>
+              <a:rPr lang="it-IT" u="sng" dirty="0"/>
+              <a:t>Dataset Overall Pipeline</a:t>
+            </a:r>
+            <a:endParaRPr lang="en-US" u="sng" dirty="0"/>
+          </a:p>
+        </p:txBody>
+      </p:sp>
+      <p:pic>
+        <p:nvPicPr>
+          <p:cNvPr id="15" name="Graphic 14" descr="Filter">
+            <a:extLst>
+              <a:ext uri="{FF2B5EF4-FFF2-40B4-BE49-F238E27FC236}">
+                <a16:creationId xmlns:a16="http://schemas.microsoft.com/office/drawing/2014/main" id="{77EFA052-BE58-4D1D-B8A8-F655071A6ABC}"/>
+              </a:ext>
+            </a:extLst>
+          </p:cNvPr>
+          <p:cNvPicPr>
+            <a:picLocks noChangeAspect="1"/>
+          </p:cNvPicPr>
+          <p:nvPr/>
+        </p:nvPicPr>
+        <p:blipFill>
+          <a:blip r:embed="rId4">
+            <a:extLst>
+              <a:ext uri="{28A0092B-C50C-407E-A947-70E740481C1C}">
+                <a14:useLocalDpi xmlns:a14="http://schemas.microsoft.com/office/drawing/2010/main" val="0"/>
+              </a:ext>
+              <a:ext uri="{96DAC541-7B7A-43D3-8B79-37D633B846F1}">
+                <asvg:svgBlip xmlns:asvg="http://schemas.microsoft.com/office/drawing/2016/SVG/main" r:embed="rId5"/>
+              </a:ext>
+            </a:extLst>
+          </a:blip>
+          <a:stretch>
+            <a:fillRect/>
+          </a:stretch>
+        </p:blipFill>
+        <p:spPr>
+          <a:xfrm>
+            <a:off x="7216942" y="2430855"/>
+            <a:ext cx="560158" cy="560158"/>
+          </a:xfrm>
+          <a:prstGeom prst="rect">
+            <a:avLst/>
+          </a:prstGeom>
+        </p:spPr>
+      </p:pic>
+      <p:pic>
+        <p:nvPicPr>
+          <p:cNvPr id="16" name="Graphic 15" descr="Filter">
+            <a:extLst>
+              <a:ext uri="{FF2B5EF4-FFF2-40B4-BE49-F238E27FC236}">
+                <a16:creationId xmlns:a16="http://schemas.microsoft.com/office/drawing/2014/main" id="{8CE6F089-4292-41E2-A4CB-9CE900294558}"/>
+              </a:ext>
+            </a:extLst>
+          </p:cNvPr>
+          <p:cNvPicPr>
+            <a:picLocks noChangeAspect="1"/>
+          </p:cNvPicPr>
+          <p:nvPr/>
+        </p:nvPicPr>
+        <p:blipFill>
+          <a:blip r:embed="rId4">
+            <a:extLst>
+              <a:ext uri="{28A0092B-C50C-407E-A947-70E740481C1C}">
+                <a14:useLocalDpi xmlns:a14="http://schemas.microsoft.com/office/drawing/2010/main" val="0"/>
+              </a:ext>
+              <a:ext uri="{96DAC541-7B7A-43D3-8B79-37D633B846F1}">
+                <asvg:svgBlip xmlns:asvg="http://schemas.microsoft.com/office/drawing/2016/SVG/main" r:embed="rId5"/>
+              </a:ext>
+            </a:extLst>
+          </a:blip>
+          <a:stretch>
+            <a:fillRect/>
+          </a:stretch>
+        </p:blipFill>
+        <p:spPr>
+          <a:xfrm>
+            <a:off x="7216942" y="4106965"/>
+            <a:ext cx="560158" cy="560158"/>
+          </a:xfrm>
+          <a:prstGeom prst="rect">
+            <a:avLst/>
+          </a:prstGeom>
+        </p:spPr>
+      </p:pic>
+      <p:cxnSp>
+        <p:nvCxnSpPr>
+          <p:cNvPr id="18" name="Straight Arrow Connector 17">
+            <a:extLst>
+              <a:ext uri="{FF2B5EF4-FFF2-40B4-BE49-F238E27FC236}">
+                <a16:creationId xmlns:a16="http://schemas.microsoft.com/office/drawing/2014/main" id="{555783A9-DA1F-458D-8AC7-9F29C7BF3301}"/>
+              </a:ext>
+            </a:extLst>
+          </p:cNvPr>
+          <p:cNvCxnSpPr>
+            <a:stCxn id="6" idx="3"/>
+            <a:endCxn id="15" idx="1"/>
+          </p:cNvCxnSpPr>
+          <p:nvPr/>
+        </p:nvCxnSpPr>
+        <p:spPr>
+          <a:xfrm>
+            <a:off x="5352048" y="2710934"/>
+            <a:ext cx="1864894" cy="0"/>
+          </a:xfrm>
+          <a:prstGeom prst="straightConnector1">
+            <a:avLst/>
+          </a:prstGeom>
+          <a:ln w="9525" cap="flat" cmpd="sng" algn="ctr">
+            <a:solidFill>
+              <a:schemeClr val="dk1"/>
+            </a:solidFill>
+            <a:prstDash val="solid"/>
+            <a:round/>
+            <a:headEnd type="none" w="med" len="med"/>
+            <a:tailEnd type="arrow" w="med" len="med"/>
+          </a:ln>
+        </p:spPr>
+        <p:style>
+          <a:lnRef idx="0">
+            <a:scrgbClr r="0" g="0" b="0"/>
+          </a:lnRef>
+          <a:fillRef idx="0">
+            <a:scrgbClr r="0" g="0" b="0"/>
+          </a:fillRef>
+          <a:effectRef idx="0">
+            <a:scrgbClr r="0" g="0" b="0"/>
+          </a:effectRef>
+          <a:fontRef idx="minor">
+            <a:schemeClr val="tx1"/>
+          </a:fontRef>
+        </p:style>
+      </p:cxnSp>
+      <p:cxnSp>
+        <p:nvCxnSpPr>
+          <p:cNvPr id="21" name="Straight Arrow Connector 20">
+            <a:extLst>
+              <a:ext uri="{FF2B5EF4-FFF2-40B4-BE49-F238E27FC236}">
+                <a16:creationId xmlns:a16="http://schemas.microsoft.com/office/drawing/2014/main" id="{8A796B5C-4D51-4010-A70E-8C95CEFCB608}"/>
+              </a:ext>
+            </a:extLst>
+          </p:cNvPr>
+          <p:cNvCxnSpPr>
+            <a:stCxn id="5" idx="3"/>
+            <a:endCxn id="16" idx="1"/>
+          </p:cNvCxnSpPr>
+          <p:nvPr/>
+        </p:nvCxnSpPr>
+        <p:spPr>
+          <a:xfrm flipV="1">
+            <a:off x="5352048" y="4387044"/>
+            <a:ext cx="1864894" cy="8678"/>
+          </a:xfrm>
+          <a:prstGeom prst="straightConnector1">
+            <a:avLst/>
+          </a:prstGeom>
+          <a:ln w="9525" cap="flat" cmpd="sng" algn="ctr">
+            <a:solidFill>
+              <a:schemeClr val="dk1"/>
+            </a:solidFill>
+            <a:prstDash val="solid"/>
+            <a:round/>
+            <a:headEnd type="none" w="med" len="med"/>
+            <a:tailEnd type="arrow" w="med" len="med"/>
+          </a:ln>
+        </p:spPr>
+        <p:style>
+          <a:lnRef idx="0">
+            <a:scrgbClr r="0" g="0" b="0"/>
+          </a:lnRef>
+          <a:fillRef idx="0">
+            <a:scrgbClr r="0" g="0" b="0"/>
+          </a:fillRef>
+          <a:effectRef idx="0">
+            <a:scrgbClr r="0" g="0" b="0"/>
+          </a:effectRef>
+          <a:fontRef idx="minor">
+            <a:schemeClr val="tx1"/>
+          </a:fontRef>
+        </p:style>
+      </p:cxnSp>
+      <p:sp>
+        <p:nvSpPr>
+          <p:cNvPr id="22" name="TextBox 21">
+            <a:extLst>
+              <a:ext uri="{FF2B5EF4-FFF2-40B4-BE49-F238E27FC236}">
+                <a16:creationId xmlns:a16="http://schemas.microsoft.com/office/drawing/2014/main" id="{65879BE2-3BDB-435A-A601-3F95ED3E8624}"/>
+              </a:ext>
+            </a:extLst>
+          </p:cNvPr>
+          <p:cNvSpPr txBox="1"/>
+          <p:nvPr/>
+        </p:nvSpPr>
+        <p:spPr>
+          <a:xfrm>
+            <a:off x="6603332" y="2024867"/>
+            <a:ext cx="1787378" cy="369332"/>
+          </a:xfrm>
+          <a:prstGeom prst="rect">
+            <a:avLst/>
+          </a:prstGeom>
+          <a:noFill/>
+        </p:spPr>
+        <p:txBody>
+          <a:bodyPr wrap="square" rtlCol="0">
+            <a:spAutoFit/>
+          </a:bodyPr>
+          <a:lstStyle/>
+          <a:p>
+            <a:pPr algn="ctr"/>
+            <a:r>
+              <a:rPr lang="it-IT" dirty="0"/>
+              <a:t>25% presence</a:t>
+            </a:r>
+            <a:endParaRPr lang="en-US" dirty="0"/>
+          </a:p>
+        </p:txBody>
+      </p:sp>
+      <p:sp>
+        <p:nvSpPr>
+          <p:cNvPr id="25" name="TextBox 24">
+            <a:extLst>
+              <a:ext uri="{FF2B5EF4-FFF2-40B4-BE49-F238E27FC236}">
+                <a16:creationId xmlns:a16="http://schemas.microsoft.com/office/drawing/2014/main" id="{010D410E-647F-4FE6-995F-3F96C38EA75C}"/>
+              </a:ext>
+            </a:extLst>
+          </p:cNvPr>
+          <p:cNvSpPr txBox="1"/>
+          <p:nvPr/>
+        </p:nvSpPr>
+        <p:spPr>
+          <a:xfrm>
+            <a:off x="6603332" y="3736620"/>
+            <a:ext cx="1787378" cy="369332"/>
+          </a:xfrm>
+          <a:prstGeom prst="rect">
+            <a:avLst/>
+          </a:prstGeom>
+          <a:noFill/>
+        </p:spPr>
+        <p:txBody>
+          <a:bodyPr wrap="square" rtlCol="0">
+            <a:spAutoFit/>
+          </a:bodyPr>
+          <a:lstStyle/>
+          <a:p>
+            <a:pPr algn="ctr"/>
+            <a:r>
+              <a:rPr lang="it-IT" dirty="0"/>
+              <a:t>25% presence</a:t>
+            </a:r>
+            <a:endParaRPr lang="en-US" dirty="0"/>
+          </a:p>
+        </p:txBody>
+      </p:sp>
+      <p:grpSp>
+        <p:nvGrpSpPr>
+          <p:cNvPr id="45" name="Group 44">
+            <a:extLst>
+              <a:ext uri="{FF2B5EF4-FFF2-40B4-BE49-F238E27FC236}">
+                <a16:creationId xmlns:a16="http://schemas.microsoft.com/office/drawing/2014/main" id="{EFCDFCF5-3CB5-44E5-9669-2EA232528336}"/>
+              </a:ext>
+            </a:extLst>
+          </p:cNvPr>
+          <p:cNvGrpSpPr/>
+          <p:nvPr/>
+        </p:nvGrpSpPr>
+        <p:grpSpPr>
+          <a:xfrm>
+            <a:off x="8866787" y="2341955"/>
+            <a:ext cx="660962" cy="656371"/>
+            <a:chOff x="8659054" y="1554760"/>
+            <a:chExt cx="660962" cy="656371"/>
+          </a:xfrm>
+        </p:grpSpPr>
+        <p:pic>
+          <p:nvPicPr>
+            <p:cNvPr id="31" name="Graphic 30" descr="Fir tree">
+              <a:extLst>
+                <a:ext uri="{FF2B5EF4-FFF2-40B4-BE49-F238E27FC236}">
+                  <a16:creationId xmlns:a16="http://schemas.microsoft.com/office/drawing/2014/main" id="{A28448D4-A5BA-4AA1-914C-F81207800F37}"/>
+                </a:ext>
+              </a:extLst>
+            </p:cNvPr>
+            <p:cNvPicPr>
+              <a:picLocks noChangeAspect="1"/>
+            </p:cNvPicPr>
+            <p:nvPr/>
+          </p:nvPicPr>
+          <p:blipFill>
+            <a:blip r:embed="rId6">
+              <a:extLst>
+                <a:ext uri="{28A0092B-C50C-407E-A947-70E740481C1C}">
+                  <a14:useLocalDpi xmlns:a14="http://schemas.microsoft.com/office/drawing/2010/main" val="0"/>
+                </a:ext>
+                <a:ext uri="{96DAC541-7B7A-43D3-8B79-37D633B846F1}">
+                  <asvg:svgBlip xmlns:asvg="http://schemas.microsoft.com/office/drawing/2016/SVG/main" r:embed="rId7"/>
+                </a:ext>
+              </a:extLst>
+            </a:blip>
+            <a:stretch>
+              <a:fillRect/>
+            </a:stretch>
+          </p:blipFill>
+          <p:spPr>
+            <a:xfrm>
+              <a:off x="8804250" y="1554760"/>
+              <a:ext cx="369331" cy="369331"/>
+            </a:xfrm>
+            <a:prstGeom prst="rect">
+              <a:avLst/>
+            </a:prstGeom>
+          </p:spPr>
+        </p:pic>
+        <p:pic>
+          <p:nvPicPr>
+            <p:cNvPr id="33" name="Graphic 32" descr="Fir tree">
+              <a:extLst>
+                <a:ext uri="{FF2B5EF4-FFF2-40B4-BE49-F238E27FC236}">
+                  <a16:creationId xmlns:a16="http://schemas.microsoft.com/office/drawing/2014/main" id="{FA5DFC68-AF0D-4662-B2B3-AB729F785AD7}"/>
+                </a:ext>
+              </a:extLst>
+            </p:cNvPr>
+            <p:cNvPicPr>
+              <a:picLocks noChangeAspect="1"/>
+            </p:cNvPicPr>
+            <p:nvPr/>
+          </p:nvPicPr>
+          <p:blipFill>
+            <a:blip r:embed="rId6">
+              <a:extLst>
+                <a:ext uri="{28A0092B-C50C-407E-A947-70E740481C1C}">
+                  <a14:useLocalDpi xmlns:a14="http://schemas.microsoft.com/office/drawing/2010/main" val="0"/>
+                </a:ext>
+                <a:ext uri="{96DAC541-7B7A-43D3-8B79-37D633B846F1}">
+                  <asvg:svgBlip xmlns:asvg="http://schemas.microsoft.com/office/drawing/2016/SVG/main" r:embed="rId7"/>
+                </a:ext>
+              </a:extLst>
+            </a:blip>
+            <a:stretch>
+              <a:fillRect/>
+            </a:stretch>
+          </p:blipFill>
+          <p:spPr>
+            <a:xfrm>
+              <a:off x="8659054" y="1631712"/>
+              <a:ext cx="369331" cy="369331"/>
+            </a:xfrm>
+            <a:prstGeom prst="rect">
+              <a:avLst/>
+            </a:prstGeom>
+          </p:spPr>
+        </p:pic>
+        <p:pic>
+          <p:nvPicPr>
+            <p:cNvPr id="34" name="Graphic 33" descr="Fir tree">
+              <a:extLst>
+                <a:ext uri="{FF2B5EF4-FFF2-40B4-BE49-F238E27FC236}">
+                  <a16:creationId xmlns:a16="http://schemas.microsoft.com/office/drawing/2014/main" id="{A87B39C9-9355-4F04-85A8-68975E2D1931}"/>
+                </a:ext>
+              </a:extLst>
+            </p:cNvPr>
+            <p:cNvPicPr>
+              <a:picLocks noChangeAspect="1"/>
+            </p:cNvPicPr>
+            <p:nvPr/>
+          </p:nvPicPr>
+          <p:blipFill>
+            <a:blip r:embed="rId6">
+              <a:extLst>
+                <a:ext uri="{28A0092B-C50C-407E-A947-70E740481C1C}">
+                  <a14:useLocalDpi xmlns:a14="http://schemas.microsoft.com/office/drawing/2010/main" val="0"/>
+                </a:ext>
+                <a:ext uri="{96DAC541-7B7A-43D3-8B79-37D633B846F1}">
+                  <asvg:svgBlip xmlns:asvg="http://schemas.microsoft.com/office/drawing/2016/SVG/main" r:embed="rId7"/>
+                </a:ext>
+              </a:extLst>
+            </a:blip>
+            <a:stretch>
+              <a:fillRect/>
+            </a:stretch>
+          </p:blipFill>
+          <p:spPr>
+            <a:xfrm>
+              <a:off x="8950685" y="1652154"/>
+              <a:ext cx="369331" cy="369331"/>
+            </a:xfrm>
+            <a:prstGeom prst="rect">
+              <a:avLst/>
+            </a:prstGeom>
+          </p:spPr>
+        </p:pic>
+        <p:pic>
+          <p:nvPicPr>
+            <p:cNvPr id="27" name="Graphic 26" descr="Rat">
+              <a:extLst>
+                <a:ext uri="{FF2B5EF4-FFF2-40B4-BE49-F238E27FC236}">
+                  <a16:creationId xmlns:a16="http://schemas.microsoft.com/office/drawing/2014/main" id="{E0A02F5C-79F0-4D89-8F50-304FD4BD9848}"/>
+                </a:ext>
+              </a:extLst>
+            </p:cNvPr>
+            <p:cNvPicPr>
+              <a:picLocks noChangeAspect="1"/>
+            </p:cNvPicPr>
+            <p:nvPr/>
+          </p:nvPicPr>
+          <p:blipFill>
+            <a:blip r:embed="rId8">
+              <a:extLst>
+                <a:ext uri="{28A0092B-C50C-407E-A947-70E740481C1C}">
+                  <a14:useLocalDpi xmlns:a14="http://schemas.microsoft.com/office/drawing/2010/main" val="0"/>
+                </a:ext>
+                <a:ext uri="{96DAC541-7B7A-43D3-8B79-37D633B846F1}">
+                  <asvg:svgBlip xmlns:asvg="http://schemas.microsoft.com/office/drawing/2016/SVG/main" r:embed="rId9"/>
+                </a:ext>
+              </a:extLst>
+            </a:blip>
+            <a:stretch>
+              <a:fillRect/>
+            </a:stretch>
+          </p:blipFill>
+          <p:spPr>
+            <a:xfrm>
+              <a:off x="8753807" y="1914827"/>
+              <a:ext cx="268922" cy="268922"/>
+            </a:xfrm>
+            <a:prstGeom prst="rect">
+              <a:avLst/>
+            </a:prstGeom>
+          </p:spPr>
+        </p:pic>
+        <p:pic>
+          <p:nvPicPr>
+            <p:cNvPr id="28" name="Graphic 27" descr="Rat">
+              <a:extLst>
+                <a:ext uri="{FF2B5EF4-FFF2-40B4-BE49-F238E27FC236}">
+                  <a16:creationId xmlns:a16="http://schemas.microsoft.com/office/drawing/2014/main" id="{E52DBD8A-0DAA-4002-B99A-3279FA56CC7D}"/>
+                </a:ext>
+              </a:extLst>
+            </p:cNvPr>
+            <p:cNvPicPr>
+              <a:picLocks noChangeAspect="1"/>
+            </p:cNvPicPr>
+            <p:nvPr/>
+          </p:nvPicPr>
+          <p:blipFill>
+            <a:blip r:embed="rId8">
+              <a:extLst>
+                <a:ext uri="{28A0092B-C50C-407E-A947-70E740481C1C}">
+                  <a14:useLocalDpi xmlns:a14="http://schemas.microsoft.com/office/drawing/2010/main" val="0"/>
+                </a:ext>
+                <a:ext uri="{96DAC541-7B7A-43D3-8B79-37D633B846F1}">
+                  <asvg:svgBlip xmlns:asvg="http://schemas.microsoft.com/office/drawing/2016/SVG/main" r:embed="rId9"/>
+                </a:ext>
+              </a:extLst>
+            </a:blip>
+            <a:stretch>
+              <a:fillRect/>
+            </a:stretch>
+          </p:blipFill>
+          <p:spPr>
+            <a:xfrm flipH="1">
+              <a:off x="8939164" y="2068427"/>
+              <a:ext cx="142704" cy="142704"/>
+            </a:xfrm>
+            <a:prstGeom prst="rect">
+              <a:avLst/>
+            </a:prstGeom>
+          </p:spPr>
+        </p:pic>
+        <p:pic>
+          <p:nvPicPr>
+            <p:cNvPr id="35" name="Graphic 34" descr="Rat">
+              <a:extLst>
+                <a:ext uri="{FF2B5EF4-FFF2-40B4-BE49-F238E27FC236}">
+                  <a16:creationId xmlns:a16="http://schemas.microsoft.com/office/drawing/2014/main" id="{6D33A84E-4C0D-4033-8FCF-EC2E10BDF52D}"/>
+                </a:ext>
+              </a:extLst>
+            </p:cNvPr>
+            <p:cNvPicPr>
+              <a:picLocks noChangeAspect="1"/>
+            </p:cNvPicPr>
+            <p:nvPr/>
+          </p:nvPicPr>
+          <p:blipFill>
+            <a:blip r:embed="rId8">
+              <a:extLst>
+                <a:ext uri="{28A0092B-C50C-407E-A947-70E740481C1C}">
+                  <a14:useLocalDpi xmlns:a14="http://schemas.microsoft.com/office/drawing/2010/main" val="0"/>
+                </a:ext>
+                <a:ext uri="{96DAC541-7B7A-43D3-8B79-37D633B846F1}">
+                  <asvg:svgBlip xmlns:asvg="http://schemas.microsoft.com/office/drawing/2016/SVG/main" r:embed="rId9"/>
+                </a:ext>
+              </a:extLst>
+            </a:blip>
+            <a:stretch>
+              <a:fillRect/>
+            </a:stretch>
+          </p:blipFill>
+          <p:spPr>
+            <a:xfrm flipH="1">
+              <a:off x="8969417" y="1908414"/>
+              <a:ext cx="224902" cy="221156"/>
+            </a:xfrm>
+            <a:prstGeom prst="rect">
+              <a:avLst/>
+            </a:prstGeom>
+          </p:spPr>
+        </p:pic>
+        <p:pic>
+          <p:nvPicPr>
+            <p:cNvPr id="36" name="Graphic 35" descr="Rat">
+              <a:extLst>
+                <a:ext uri="{FF2B5EF4-FFF2-40B4-BE49-F238E27FC236}">
+                  <a16:creationId xmlns:a16="http://schemas.microsoft.com/office/drawing/2014/main" id="{9C8F06A7-7870-4608-AA82-B4F3C3504D7E}"/>
+                </a:ext>
+              </a:extLst>
+            </p:cNvPr>
+            <p:cNvPicPr>
+              <a:picLocks noChangeAspect="1"/>
+            </p:cNvPicPr>
+            <p:nvPr/>
+          </p:nvPicPr>
+          <p:blipFill>
+            <a:blip r:embed="rId8">
+              <a:extLst>
+                <a:ext uri="{28A0092B-C50C-407E-A947-70E740481C1C}">
+                  <a14:useLocalDpi xmlns:a14="http://schemas.microsoft.com/office/drawing/2010/main" val="0"/>
+                </a:ext>
+                <a:ext uri="{96DAC541-7B7A-43D3-8B79-37D633B846F1}">
+                  <asvg:svgBlip xmlns:asvg="http://schemas.microsoft.com/office/drawing/2016/SVG/main" r:embed="rId9"/>
+                </a:ext>
+              </a:extLst>
+            </a:blip>
+            <a:stretch>
+              <a:fillRect/>
+            </a:stretch>
+          </p:blipFill>
+          <p:spPr>
+            <a:xfrm>
+              <a:off x="9058905" y="2035427"/>
+              <a:ext cx="142704" cy="142704"/>
+            </a:xfrm>
+            <a:prstGeom prst="rect">
+              <a:avLst/>
+            </a:prstGeom>
+          </p:spPr>
+        </p:pic>
+      </p:grpSp>
+      <p:grpSp>
+        <p:nvGrpSpPr>
+          <p:cNvPr id="44" name="Group 43">
+            <a:extLst>
+              <a:ext uri="{FF2B5EF4-FFF2-40B4-BE49-F238E27FC236}">
+                <a16:creationId xmlns:a16="http://schemas.microsoft.com/office/drawing/2014/main" id="{04F9F91F-2781-44FE-98AE-7E4D07F97208}"/>
+              </a:ext>
+            </a:extLst>
+          </p:cNvPr>
+          <p:cNvGrpSpPr/>
+          <p:nvPr/>
+        </p:nvGrpSpPr>
+        <p:grpSpPr>
+          <a:xfrm>
+            <a:off x="8936157" y="4010752"/>
+            <a:ext cx="660962" cy="656371"/>
+            <a:chOff x="8659054" y="4532119"/>
+            <a:chExt cx="660962" cy="656371"/>
+          </a:xfrm>
+        </p:grpSpPr>
+        <p:pic>
+          <p:nvPicPr>
+            <p:cNvPr id="37" name="Graphic 36" descr="Fir tree">
+              <a:extLst>
+                <a:ext uri="{FF2B5EF4-FFF2-40B4-BE49-F238E27FC236}">
+                  <a16:creationId xmlns:a16="http://schemas.microsoft.com/office/drawing/2014/main" id="{0E363A89-E105-4E57-91E1-3E875915792D}"/>
+                </a:ext>
+              </a:extLst>
+            </p:cNvPr>
+            <p:cNvPicPr>
+              <a:picLocks noChangeAspect="1"/>
+            </p:cNvPicPr>
+            <p:nvPr/>
+          </p:nvPicPr>
+          <p:blipFill>
+            <a:blip r:embed="rId6">
+              <a:extLst>
+                <a:ext uri="{28A0092B-C50C-407E-A947-70E740481C1C}">
+                  <a14:useLocalDpi xmlns:a14="http://schemas.microsoft.com/office/drawing/2010/main" val="0"/>
+                </a:ext>
+                <a:ext uri="{96DAC541-7B7A-43D3-8B79-37D633B846F1}">
+                  <asvg:svgBlip xmlns:asvg="http://schemas.microsoft.com/office/drawing/2016/SVG/main" r:embed="rId7"/>
+                </a:ext>
+              </a:extLst>
+            </a:blip>
+            <a:stretch>
+              <a:fillRect/>
+            </a:stretch>
+          </p:blipFill>
+          <p:spPr>
+            <a:xfrm>
+              <a:off x="8804250" y="4532119"/>
+              <a:ext cx="369331" cy="369331"/>
+            </a:xfrm>
+            <a:prstGeom prst="rect">
+              <a:avLst/>
+            </a:prstGeom>
+          </p:spPr>
+        </p:pic>
+        <p:pic>
+          <p:nvPicPr>
+            <p:cNvPr id="38" name="Graphic 37" descr="Fir tree">
+              <a:extLst>
+                <a:ext uri="{FF2B5EF4-FFF2-40B4-BE49-F238E27FC236}">
+                  <a16:creationId xmlns:a16="http://schemas.microsoft.com/office/drawing/2014/main" id="{770005CA-79DF-4370-88CD-7C3EB7DAF6FD}"/>
+                </a:ext>
+              </a:extLst>
+            </p:cNvPr>
+            <p:cNvPicPr>
+              <a:picLocks noChangeAspect="1"/>
+            </p:cNvPicPr>
+            <p:nvPr/>
+          </p:nvPicPr>
+          <p:blipFill>
+            <a:blip r:embed="rId6">
+              <a:extLst>
+                <a:ext uri="{28A0092B-C50C-407E-A947-70E740481C1C}">
+                  <a14:useLocalDpi xmlns:a14="http://schemas.microsoft.com/office/drawing/2010/main" val="0"/>
+                </a:ext>
+                <a:ext uri="{96DAC541-7B7A-43D3-8B79-37D633B846F1}">
+                  <asvg:svgBlip xmlns:asvg="http://schemas.microsoft.com/office/drawing/2016/SVG/main" r:embed="rId7"/>
+                </a:ext>
+              </a:extLst>
+            </a:blip>
+            <a:stretch>
+              <a:fillRect/>
+            </a:stretch>
+          </p:blipFill>
+          <p:spPr>
+            <a:xfrm>
+              <a:off x="8659054" y="4609071"/>
+              <a:ext cx="369331" cy="369331"/>
+            </a:xfrm>
+            <a:prstGeom prst="rect">
+              <a:avLst/>
+            </a:prstGeom>
+          </p:spPr>
+        </p:pic>
+        <p:pic>
+          <p:nvPicPr>
+            <p:cNvPr id="39" name="Graphic 38" descr="Fir tree">
+              <a:extLst>
+                <a:ext uri="{FF2B5EF4-FFF2-40B4-BE49-F238E27FC236}">
+                  <a16:creationId xmlns:a16="http://schemas.microsoft.com/office/drawing/2014/main" id="{289005B1-E3F6-4D74-8657-EBA911FA0743}"/>
+                </a:ext>
+              </a:extLst>
+            </p:cNvPr>
+            <p:cNvPicPr>
+              <a:picLocks noChangeAspect="1"/>
+            </p:cNvPicPr>
+            <p:nvPr/>
+          </p:nvPicPr>
+          <p:blipFill>
+            <a:blip r:embed="rId6">
+              <a:extLst>
+                <a:ext uri="{28A0092B-C50C-407E-A947-70E740481C1C}">
+                  <a14:useLocalDpi xmlns:a14="http://schemas.microsoft.com/office/drawing/2010/main" val="0"/>
+                </a:ext>
+                <a:ext uri="{96DAC541-7B7A-43D3-8B79-37D633B846F1}">
+                  <asvg:svgBlip xmlns:asvg="http://schemas.microsoft.com/office/drawing/2016/SVG/main" r:embed="rId7"/>
+                </a:ext>
+              </a:extLst>
+            </a:blip>
+            <a:stretch>
+              <a:fillRect/>
+            </a:stretch>
+          </p:blipFill>
+          <p:spPr>
+            <a:xfrm>
+              <a:off x="8950685" y="4629513"/>
+              <a:ext cx="369331" cy="369331"/>
+            </a:xfrm>
+            <a:prstGeom prst="rect">
+              <a:avLst/>
+            </a:prstGeom>
+          </p:spPr>
+        </p:pic>
+        <p:pic>
+          <p:nvPicPr>
+            <p:cNvPr id="40" name="Graphic 39" descr="Rat">
+              <a:extLst>
+                <a:ext uri="{FF2B5EF4-FFF2-40B4-BE49-F238E27FC236}">
+                  <a16:creationId xmlns:a16="http://schemas.microsoft.com/office/drawing/2014/main" id="{3790F890-04F6-4F83-9FB3-08B39B7B162B}"/>
+                </a:ext>
+              </a:extLst>
+            </p:cNvPr>
+            <p:cNvPicPr>
+              <a:picLocks noChangeAspect="1"/>
+            </p:cNvPicPr>
+            <p:nvPr/>
+          </p:nvPicPr>
+          <p:blipFill>
+            <a:blip r:embed="rId8">
+              <a:extLst>
+                <a:ext uri="{28A0092B-C50C-407E-A947-70E740481C1C}">
+                  <a14:useLocalDpi xmlns:a14="http://schemas.microsoft.com/office/drawing/2010/main" val="0"/>
+                </a:ext>
+                <a:ext uri="{96DAC541-7B7A-43D3-8B79-37D633B846F1}">
+                  <asvg:svgBlip xmlns:asvg="http://schemas.microsoft.com/office/drawing/2016/SVG/main" r:embed="rId9"/>
+                </a:ext>
+              </a:extLst>
+            </a:blip>
+            <a:stretch>
+              <a:fillRect/>
+            </a:stretch>
+          </p:blipFill>
+          <p:spPr>
+            <a:xfrm>
+              <a:off x="8753807" y="4892186"/>
+              <a:ext cx="268922" cy="268922"/>
+            </a:xfrm>
+            <a:prstGeom prst="rect">
+              <a:avLst/>
+            </a:prstGeom>
+          </p:spPr>
+        </p:pic>
+        <p:pic>
+          <p:nvPicPr>
+            <p:cNvPr id="41" name="Graphic 40" descr="Rat">
+              <a:extLst>
+                <a:ext uri="{FF2B5EF4-FFF2-40B4-BE49-F238E27FC236}">
+                  <a16:creationId xmlns:a16="http://schemas.microsoft.com/office/drawing/2014/main" id="{7A52470C-137D-4771-8BEE-0C2423A4F498}"/>
+                </a:ext>
+              </a:extLst>
+            </p:cNvPr>
+            <p:cNvPicPr>
+              <a:picLocks noChangeAspect="1"/>
+            </p:cNvPicPr>
+            <p:nvPr/>
+          </p:nvPicPr>
+          <p:blipFill>
+            <a:blip r:embed="rId8">
+              <a:extLst>
+                <a:ext uri="{28A0092B-C50C-407E-A947-70E740481C1C}">
+                  <a14:useLocalDpi xmlns:a14="http://schemas.microsoft.com/office/drawing/2010/main" val="0"/>
+                </a:ext>
+                <a:ext uri="{96DAC541-7B7A-43D3-8B79-37D633B846F1}">
+                  <asvg:svgBlip xmlns:asvg="http://schemas.microsoft.com/office/drawing/2016/SVG/main" r:embed="rId9"/>
+                </a:ext>
+              </a:extLst>
+            </a:blip>
+            <a:stretch>
+              <a:fillRect/>
+            </a:stretch>
+          </p:blipFill>
+          <p:spPr>
+            <a:xfrm flipH="1">
+              <a:off x="8939164" y="5045786"/>
+              <a:ext cx="142704" cy="142704"/>
+            </a:xfrm>
+            <a:prstGeom prst="rect">
+              <a:avLst/>
+            </a:prstGeom>
+          </p:spPr>
+        </p:pic>
+        <p:pic>
+          <p:nvPicPr>
+            <p:cNvPr id="42" name="Graphic 41" descr="Rat">
+              <a:extLst>
+                <a:ext uri="{FF2B5EF4-FFF2-40B4-BE49-F238E27FC236}">
+                  <a16:creationId xmlns:a16="http://schemas.microsoft.com/office/drawing/2014/main" id="{FD3ADE60-EA42-4A59-8BC6-FB7B717A80CE}"/>
+                </a:ext>
+              </a:extLst>
+            </p:cNvPr>
+            <p:cNvPicPr>
+              <a:picLocks noChangeAspect="1"/>
+            </p:cNvPicPr>
+            <p:nvPr/>
+          </p:nvPicPr>
+          <p:blipFill>
+            <a:blip r:embed="rId8">
+              <a:extLst>
+                <a:ext uri="{28A0092B-C50C-407E-A947-70E740481C1C}">
+                  <a14:useLocalDpi xmlns:a14="http://schemas.microsoft.com/office/drawing/2010/main" val="0"/>
+                </a:ext>
+                <a:ext uri="{96DAC541-7B7A-43D3-8B79-37D633B846F1}">
+                  <asvg:svgBlip xmlns:asvg="http://schemas.microsoft.com/office/drawing/2016/SVG/main" r:embed="rId9"/>
+                </a:ext>
+              </a:extLst>
+            </a:blip>
+            <a:stretch>
+              <a:fillRect/>
+            </a:stretch>
+          </p:blipFill>
+          <p:spPr>
+            <a:xfrm flipH="1">
+              <a:off x="8969417" y="4885773"/>
+              <a:ext cx="224902" cy="221156"/>
+            </a:xfrm>
+            <a:prstGeom prst="rect">
+              <a:avLst/>
+            </a:prstGeom>
+          </p:spPr>
+        </p:pic>
+        <p:pic>
+          <p:nvPicPr>
+            <p:cNvPr id="43" name="Graphic 42" descr="Rat">
+              <a:extLst>
+                <a:ext uri="{FF2B5EF4-FFF2-40B4-BE49-F238E27FC236}">
+                  <a16:creationId xmlns:a16="http://schemas.microsoft.com/office/drawing/2014/main" id="{F353A656-F1AF-4FC7-ADD9-491A9B3BF874}"/>
+                </a:ext>
+              </a:extLst>
+            </p:cNvPr>
+            <p:cNvPicPr>
+              <a:picLocks noChangeAspect="1"/>
+            </p:cNvPicPr>
+            <p:nvPr/>
+          </p:nvPicPr>
+          <p:blipFill>
+            <a:blip r:embed="rId8">
+              <a:extLst>
+                <a:ext uri="{28A0092B-C50C-407E-A947-70E740481C1C}">
+                  <a14:useLocalDpi xmlns:a14="http://schemas.microsoft.com/office/drawing/2010/main" val="0"/>
+                </a:ext>
+                <a:ext uri="{96DAC541-7B7A-43D3-8B79-37D633B846F1}">
+                  <asvg:svgBlip xmlns:asvg="http://schemas.microsoft.com/office/drawing/2016/SVG/main" r:embed="rId9"/>
+                </a:ext>
+              </a:extLst>
+            </a:blip>
+            <a:stretch>
+              <a:fillRect/>
+            </a:stretch>
+          </p:blipFill>
+          <p:spPr>
+            <a:xfrm>
+              <a:off x="9058905" y="5012786"/>
+              <a:ext cx="142704" cy="142704"/>
+            </a:xfrm>
+            <a:prstGeom prst="rect">
+              <a:avLst/>
+            </a:prstGeom>
+          </p:spPr>
+        </p:pic>
+      </p:grpSp>
+      <p:cxnSp>
+        <p:nvCxnSpPr>
+          <p:cNvPr id="47" name="Straight Arrow Connector 46">
+            <a:extLst>
+              <a:ext uri="{FF2B5EF4-FFF2-40B4-BE49-F238E27FC236}">
+                <a16:creationId xmlns:a16="http://schemas.microsoft.com/office/drawing/2014/main" id="{21D791B7-BCEC-4B7D-8AF4-F64002B1ECC4}"/>
+              </a:ext>
+            </a:extLst>
+          </p:cNvPr>
+          <p:cNvCxnSpPr>
+            <a:stCxn id="15" idx="3"/>
+          </p:cNvCxnSpPr>
+          <p:nvPr/>
+        </p:nvCxnSpPr>
+        <p:spPr>
+          <a:xfrm>
+            <a:off x="7777100" y="2710934"/>
+            <a:ext cx="1089067" cy="0"/>
+          </a:xfrm>
+          <a:prstGeom prst="straightConnector1">
+            <a:avLst/>
+          </a:prstGeom>
+          <a:ln w="9525" cap="flat" cmpd="sng" algn="ctr">
+            <a:solidFill>
+              <a:schemeClr val="dk1"/>
+            </a:solidFill>
+            <a:prstDash val="solid"/>
+            <a:round/>
+            <a:headEnd type="none" w="med" len="med"/>
+            <a:tailEnd type="arrow" w="med" len="med"/>
+          </a:ln>
+        </p:spPr>
+        <p:style>
+          <a:lnRef idx="0">
+            <a:scrgbClr r="0" g="0" b="0"/>
+          </a:lnRef>
+          <a:fillRef idx="0">
+            <a:scrgbClr r="0" g="0" b="0"/>
+          </a:fillRef>
+          <a:effectRef idx="0">
+            <a:scrgbClr r="0" g="0" b="0"/>
+          </a:effectRef>
+          <a:fontRef idx="minor">
+            <a:schemeClr val="tx1"/>
+          </a:fontRef>
+        </p:style>
+      </p:cxnSp>
+      <p:cxnSp>
+        <p:nvCxnSpPr>
+          <p:cNvPr id="49" name="Straight Arrow Connector 48">
+            <a:extLst>
+              <a:ext uri="{FF2B5EF4-FFF2-40B4-BE49-F238E27FC236}">
+                <a16:creationId xmlns:a16="http://schemas.microsoft.com/office/drawing/2014/main" id="{60EF8F11-6F77-4F18-8FE0-357F66B187C9}"/>
+              </a:ext>
+            </a:extLst>
+          </p:cNvPr>
+          <p:cNvCxnSpPr>
+            <a:stCxn id="16" idx="3"/>
+          </p:cNvCxnSpPr>
+          <p:nvPr/>
+        </p:nvCxnSpPr>
+        <p:spPr>
+          <a:xfrm>
+            <a:off x="7777100" y="4387044"/>
+            <a:ext cx="1089067" cy="8678"/>
+          </a:xfrm>
+          <a:prstGeom prst="straightConnector1">
+            <a:avLst/>
+          </a:prstGeom>
+          <a:ln w="9525" cap="flat" cmpd="sng" algn="ctr">
+            <a:solidFill>
+              <a:schemeClr val="dk1"/>
+            </a:solidFill>
+            <a:prstDash val="solid"/>
+            <a:round/>
+            <a:headEnd type="none" w="med" len="med"/>
+            <a:tailEnd type="arrow" w="med" len="med"/>
+          </a:ln>
+        </p:spPr>
+        <p:style>
+          <a:lnRef idx="0">
+            <a:scrgbClr r="0" g="0" b="0"/>
+          </a:lnRef>
+          <a:fillRef idx="0">
+            <a:scrgbClr r="0" g="0" b="0"/>
+          </a:fillRef>
+          <a:effectRef idx="0">
+            <a:scrgbClr r="0" g="0" b="0"/>
+          </a:effectRef>
+          <a:fontRef idx="minor">
+            <a:schemeClr val="tx1"/>
+          </a:fontRef>
+        </p:style>
+      </p:cxnSp>
+      <p:sp>
+        <p:nvSpPr>
+          <p:cNvPr id="50" name="TextBox 49">
+            <a:extLst>
+              <a:ext uri="{FF2B5EF4-FFF2-40B4-BE49-F238E27FC236}">
+                <a16:creationId xmlns:a16="http://schemas.microsoft.com/office/drawing/2014/main" id="{245E91A3-D02A-4899-B0C7-967A56251B12}"/>
+              </a:ext>
+            </a:extLst>
+          </p:cNvPr>
+          <p:cNvSpPr txBox="1"/>
+          <p:nvPr/>
+        </p:nvSpPr>
+        <p:spPr>
+          <a:xfrm>
+            <a:off x="8302339" y="2024867"/>
+            <a:ext cx="1787378" cy="369332"/>
+          </a:xfrm>
+          <a:prstGeom prst="rect">
+            <a:avLst/>
+          </a:prstGeom>
+          <a:noFill/>
+        </p:spPr>
+        <p:txBody>
+          <a:bodyPr wrap="square" rtlCol="0">
+            <a:spAutoFit/>
+          </a:bodyPr>
+          <a:lstStyle/>
+          <a:p>
+            <a:pPr algn="ctr"/>
+            <a:r>
+              <a:rPr lang="it-IT" dirty="0"/>
+              <a:t>MICE Forest</a:t>
+            </a:r>
+            <a:endParaRPr lang="en-US" dirty="0"/>
+          </a:p>
+        </p:txBody>
+      </p:sp>
+      <p:sp>
+        <p:nvSpPr>
+          <p:cNvPr id="51" name="TextBox 50">
+            <a:extLst>
+              <a:ext uri="{FF2B5EF4-FFF2-40B4-BE49-F238E27FC236}">
+                <a16:creationId xmlns:a16="http://schemas.microsoft.com/office/drawing/2014/main" id="{92B6B99E-4147-4597-8C5E-0518FED712B3}"/>
+              </a:ext>
+            </a:extLst>
+          </p:cNvPr>
+          <p:cNvSpPr txBox="1"/>
+          <p:nvPr/>
+        </p:nvSpPr>
+        <p:spPr>
+          <a:xfrm>
+            <a:off x="8352831" y="3736620"/>
+            <a:ext cx="1787378" cy="369332"/>
+          </a:xfrm>
+          <a:prstGeom prst="rect">
+            <a:avLst/>
+          </a:prstGeom>
+          <a:noFill/>
+        </p:spPr>
+        <p:txBody>
+          <a:bodyPr wrap="square" rtlCol="0">
+            <a:spAutoFit/>
+          </a:bodyPr>
+          <a:lstStyle/>
+          <a:p>
+            <a:pPr algn="ctr"/>
+            <a:r>
+              <a:rPr lang="it-IT" dirty="0"/>
+              <a:t>MICE Forest</a:t>
+            </a:r>
+            <a:endParaRPr lang="en-US" dirty="0"/>
+          </a:p>
+        </p:txBody>
+      </p:sp>
     </p:spTree>
     <p:extLst>
       <p:ext uri="{BB962C8B-B14F-4D97-AF65-F5344CB8AC3E}">
@@ -17618,7 +18945,7 @@
 </file>
 
 <file path=ppt/slides/slide7.xml><?xml version="1.0" encoding="utf-8"?>
-<p:sld xmlns:a="http://schemas.openxmlformats.org/drawingml/2006/main" xmlns:r="http://schemas.openxmlformats.org/officeDocument/2006/relationships" xmlns:p="http://schemas.openxmlformats.org/presentationml/2006/main">
+<p:sld xmlns:a="http://schemas.openxmlformats.org/drawingml/2006/main" xmlns:r="http://schemas.openxmlformats.org/officeDocument/2006/relationships" xmlns:p="http://schemas.openxmlformats.org/presentationml/2006/main" show="0">
   <p:cSld>
     <p:spTree>
       <p:nvGrpSpPr>
@@ -17878,13 +19205,13 @@
   <p:clrMapOvr>
     <a:masterClrMapping/>
   </p:clrMapOvr>
-  <mc:AlternateContent xmlns:mc="http://schemas.openxmlformats.org/markup-compatibility/2006" xmlns:p159="http://schemas.microsoft.com/office/powerpoint/2015/09/main">
-    <mc:Choice Requires="p159">
+  <mc:AlternateContent xmlns:mc="http://schemas.openxmlformats.org/markup-compatibility/2006">
+    <mc:Choice xmlns:p159="http://schemas.microsoft.com/office/powerpoint/2015/09/main" Requires="p159">
       <p:transition spd="slow">
         <p159:morph option="byObject"/>
       </p:transition>
     </mc:Choice>
-    <mc:Fallback xmlns="">
+    <mc:Fallback>
       <p:transition spd="slow">
         <p:fade/>
       </p:transition>
@@ -17894,7 +19221,7 @@
 </file>
 
 <file path=ppt/slides/slide8.xml><?xml version="1.0" encoding="utf-8"?>
-<p:sld xmlns:a="http://schemas.openxmlformats.org/drawingml/2006/main" xmlns:r="http://schemas.openxmlformats.org/officeDocument/2006/relationships" xmlns:p="http://schemas.openxmlformats.org/presentationml/2006/main">
+<p:sld xmlns:a="http://schemas.openxmlformats.org/drawingml/2006/main" xmlns:r="http://schemas.openxmlformats.org/officeDocument/2006/relationships" xmlns:p="http://schemas.openxmlformats.org/presentationml/2006/main" show="0">
   <p:cSld>
     <p:spTree>
       <p:nvGrpSpPr>
@@ -18154,13 +19481,13 @@
   <p:clrMapOvr>
     <a:masterClrMapping/>
   </p:clrMapOvr>
-  <mc:AlternateContent xmlns:mc="http://schemas.openxmlformats.org/markup-compatibility/2006" xmlns:p159="http://schemas.microsoft.com/office/powerpoint/2015/09/main">
-    <mc:Choice Requires="p159">
+  <mc:AlternateContent xmlns:mc="http://schemas.openxmlformats.org/markup-compatibility/2006">
+    <mc:Choice xmlns:p159="http://schemas.microsoft.com/office/powerpoint/2015/09/main" Requires="p159">
       <p:transition spd="slow">
         <p159:morph option="byObject"/>
       </p:transition>
     </mc:Choice>
-    <mc:Fallback xmlns="">
+    <mc:Fallback>
       <p:transition spd="slow">
         <p:fade/>
       </p:transition>
@@ -18170,7 +19497,7 @@
 </file>
 
 <file path=ppt/slides/slide9.xml><?xml version="1.0" encoding="utf-8"?>
-<p:sld xmlns:a="http://schemas.openxmlformats.org/drawingml/2006/main" xmlns:r="http://schemas.openxmlformats.org/officeDocument/2006/relationships" xmlns:p="http://schemas.openxmlformats.org/presentationml/2006/main">
+<p:sld xmlns:a="http://schemas.openxmlformats.org/drawingml/2006/main" xmlns:r="http://schemas.openxmlformats.org/officeDocument/2006/relationships" xmlns:p="http://schemas.openxmlformats.org/presentationml/2006/main" show="0">
   <p:cSld>
     <p:spTree>
       <p:nvGrpSpPr>
@@ -18346,13 +19673,13 @@
   <p:clrMapOvr>
     <a:masterClrMapping/>
   </p:clrMapOvr>
-  <mc:AlternateContent xmlns:mc="http://schemas.openxmlformats.org/markup-compatibility/2006" xmlns:p159="http://schemas.microsoft.com/office/powerpoint/2015/09/main">
-    <mc:Choice Requires="p159">
+  <mc:AlternateContent xmlns:mc="http://schemas.openxmlformats.org/markup-compatibility/2006">
+    <mc:Choice xmlns:p159="http://schemas.microsoft.com/office/powerpoint/2015/09/main" Requires="p159">
       <p:transition spd="slow">
         <p159:morph option="byObject"/>
       </p:transition>
     </mc:Choice>
-    <mc:Fallback xmlns="">
+    <mc:Fallback>
       <p:transition spd="slow">
         <p:fade/>
       </p:transition>

</xml_diff>

<commit_message>
medicatie david file created
</commit_message>
<xml_diff>
--- a/assets/ppt/data_exploration.pptx
+++ b/assets/ppt/data_exploration.pptx
@@ -1059,7 +1059,7 @@
           <a:p>
             <a:fld id="{511A67EE-E303-4967-962F-9A28980F7F51}" type="datetimeFigureOut">
               <a:rPr lang="nl-NL" smtClean="0"/>
-              <a:t>11-9-2024</a:t>
+              <a:t>18-9-2024</a:t>
             </a:fld>
             <a:endParaRPr lang="nl-NL"/>
           </a:p>
@@ -1476,7 +1476,7 @@
           <a:p>
             <a:fld id="{FED566F3-1D76-4AEC-ABE9-AFABCF495913}" type="datetime1">
               <a:rPr lang="nl-NL" smtClean="0"/>
-              <a:t>11-9-2024</a:t>
+              <a:t>18-9-2024</a:t>
             </a:fld>
             <a:endParaRPr lang="nl-NL"/>
           </a:p>
@@ -1688,7 +1688,7 @@
           <a:p>
             <a:fld id="{BC7E55A1-B228-4CF1-BFC3-6AC3B8574AC2}" type="datetime1">
               <a:rPr lang="nl-NL" smtClean="0"/>
-              <a:t>11-9-2024</a:t>
+              <a:t>18-9-2024</a:t>
             </a:fld>
             <a:endParaRPr lang="nl-NL"/>
           </a:p>
@@ -1910,7 +1910,7 @@
           <a:p>
             <a:fld id="{31AEBC58-6519-439D-8982-F0178170B57B}" type="datetime1">
               <a:rPr lang="nl-NL" smtClean="0"/>
-              <a:t>11-9-2024</a:t>
+              <a:t>18-9-2024</a:t>
             </a:fld>
             <a:endParaRPr lang="nl-NL"/>
           </a:p>
@@ -2122,7 +2122,7 @@
           <a:p>
             <a:fld id="{86DED964-D172-498F-BB83-2F7DE2692B37}" type="datetime1">
               <a:rPr lang="nl-NL" smtClean="0"/>
-              <a:t>11-9-2024</a:t>
+              <a:t>18-9-2024</a:t>
             </a:fld>
             <a:endParaRPr lang="nl-NL"/>
           </a:p>
@@ -2410,7 +2410,7 @@
           <a:p>
             <a:fld id="{230F72AC-D91D-48F5-81B4-4889AEA39D06}" type="datetime1">
               <a:rPr lang="nl-NL" smtClean="0"/>
-              <a:t>11-9-2024</a:t>
+              <a:t>18-9-2024</a:t>
             </a:fld>
             <a:endParaRPr lang="nl-NL"/>
           </a:p>
@@ -2690,7 +2690,7 @@
           <a:p>
             <a:fld id="{A0669485-26A9-497C-AD22-BCEA88DF9055}" type="datetime1">
               <a:rPr lang="nl-NL" smtClean="0"/>
-              <a:t>11-9-2024</a:t>
+              <a:t>18-9-2024</a:t>
             </a:fld>
             <a:endParaRPr lang="nl-NL"/>
           </a:p>
@@ -3117,7 +3117,7 @@
           <a:p>
             <a:fld id="{6216D00C-0C62-40DF-B6FF-B9A70701552F}" type="datetime1">
               <a:rPr lang="nl-NL" smtClean="0"/>
-              <a:t>11-9-2024</a:t>
+              <a:t>18-9-2024</a:t>
             </a:fld>
             <a:endParaRPr lang="nl-NL"/>
           </a:p>
@@ -3271,7 +3271,7 @@
           <a:p>
             <a:fld id="{88FE9515-DD39-459B-B4EF-789D74C861A5}" type="datetime1">
               <a:rPr lang="nl-NL" smtClean="0"/>
-              <a:t>11-9-2024</a:t>
+              <a:t>18-9-2024</a:t>
             </a:fld>
             <a:endParaRPr lang="nl-NL"/>
           </a:p>
@@ -3396,7 +3396,7 @@
           <a:p>
             <a:fld id="{DFA27954-A76F-4E23-8576-A7D9667CDBCC}" type="datetime1">
               <a:rPr lang="nl-NL" smtClean="0"/>
-              <a:t>11-9-2024</a:t>
+              <a:t>18-9-2024</a:t>
             </a:fld>
             <a:endParaRPr lang="nl-NL"/>
           </a:p>
@@ -3721,7 +3721,7 @@
           <a:p>
             <a:fld id="{53C17D54-D850-41AA-94F6-0F7316E4F326}" type="datetime1">
               <a:rPr lang="nl-NL" smtClean="0"/>
-              <a:t>11-9-2024</a:t>
+              <a:t>18-9-2024</a:t>
             </a:fld>
             <a:endParaRPr lang="nl-NL"/>
           </a:p>
@@ -4022,7 +4022,7 @@
           <a:p>
             <a:fld id="{0596A96E-3739-43D3-93E5-DAA507EA7B79}" type="datetime1">
               <a:rPr lang="nl-NL" smtClean="0"/>
-              <a:t>11-9-2024</a:t>
+              <a:t>18-9-2024</a:t>
             </a:fld>
             <a:endParaRPr lang="nl-NL"/>
           </a:p>
@@ -4277,7 +4277,7 @@
           <a:p>
             <a:fld id="{CFBB0748-A22F-4137-ADB1-6D5A09F7B1DF}" type="datetime1">
               <a:rPr lang="nl-NL" smtClean="0"/>
-              <a:t>11-9-2024</a:t>
+              <a:t>18-9-2024</a:t>
             </a:fld>
             <a:endParaRPr lang="nl-NL"/>
           </a:p>
@@ -4940,13 +4940,13 @@
   <p:clrMapOvr>
     <a:masterClrMapping/>
   </p:clrMapOvr>
-  <mc:AlternateContent xmlns:mc="http://schemas.openxmlformats.org/markup-compatibility/2006">
-    <mc:Choice xmlns:p159="http://schemas.microsoft.com/office/powerpoint/2015/09/main" Requires="p159">
+  <mc:AlternateContent xmlns:mc="http://schemas.openxmlformats.org/markup-compatibility/2006" xmlns:p159="http://schemas.microsoft.com/office/powerpoint/2015/09/main">
+    <mc:Choice Requires="p159">
       <p:transition spd="slow">
         <p159:morph option="byObject"/>
       </p:transition>
     </mc:Choice>
-    <mc:Fallback>
+    <mc:Fallback xmlns="">
       <p:transition spd="slow">
         <p:fade/>
       </p:transition>
@@ -5054,13 +5054,13 @@
   <p:clrMapOvr>
     <a:masterClrMapping/>
   </p:clrMapOvr>
-  <mc:AlternateContent xmlns:mc="http://schemas.openxmlformats.org/markup-compatibility/2006">
-    <mc:Choice xmlns:p159="http://schemas.microsoft.com/office/powerpoint/2015/09/main" Requires="p159">
+  <mc:AlternateContent xmlns:mc="http://schemas.openxmlformats.org/markup-compatibility/2006" xmlns:p159="http://schemas.microsoft.com/office/powerpoint/2015/09/main">
+    <mc:Choice Requires="p159">
       <p:transition spd="slow">
         <p159:morph option="byObject"/>
       </p:transition>
     </mc:Choice>
-    <mc:Fallback>
+    <mc:Fallback xmlns="">
       <p:transition spd="slow">
         <p:fade/>
       </p:transition>
@@ -5168,13 +5168,13 @@
   <p:clrMapOvr>
     <a:masterClrMapping/>
   </p:clrMapOvr>
-  <mc:AlternateContent xmlns:mc="http://schemas.openxmlformats.org/markup-compatibility/2006">
-    <mc:Choice xmlns:p159="http://schemas.microsoft.com/office/powerpoint/2015/09/main" Requires="p159">
+  <mc:AlternateContent xmlns:mc="http://schemas.openxmlformats.org/markup-compatibility/2006" xmlns:p159="http://schemas.microsoft.com/office/powerpoint/2015/09/main">
+    <mc:Choice Requires="p159">
       <p:transition spd="slow">
         <p159:morph option="byObject"/>
       </p:transition>
     </mc:Choice>
-    <mc:Fallback>
+    <mc:Fallback xmlns="">
       <p:transition spd="slow">
         <p:fade/>
       </p:transition>
@@ -5318,13 +5318,13 @@
   <p:clrMapOvr>
     <a:masterClrMapping/>
   </p:clrMapOvr>
-  <mc:AlternateContent xmlns:mc="http://schemas.openxmlformats.org/markup-compatibility/2006">
-    <mc:Choice xmlns:p159="http://schemas.microsoft.com/office/powerpoint/2015/09/main" Requires="p159">
+  <mc:AlternateContent xmlns:mc="http://schemas.openxmlformats.org/markup-compatibility/2006" xmlns:p159="http://schemas.microsoft.com/office/powerpoint/2015/09/main">
+    <mc:Choice Requires="p159">
       <p:transition spd="slow">
         <p159:morph option="byObject"/>
       </p:transition>
     </mc:Choice>
-    <mc:Fallback>
+    <mc:Fallback xmlns="">
       <p:transition spd="slow">
         <p:fade/>
       </p:transition>
@@ -5432,13 +5432,13 @@
   <p:clrMapOvr>
     <a:masterClrMapping/>
   </p:clrMapOvr>
-  <mc:AlternateContent xmlns:mc="http://schemas.openxmlformats.org/markup-compatibility/2006">
-    <mc:Choice xmlns:p159="http://schemas.microsoft.com/office/powerpoint/2015/09/main" Requires="p159">
+  <mc:AlternateContent xmlns:mc="http://schemas.openxmlformats.org/markup-compatibility/2006" xmlns:p159="http://schemas.microsoft.com/office/powerpoint/2015/09/main">
+    <mc:Choice Requires="p159">
       <p:transition spd="slow">
         <p159:morph option="byObject"/>
       </p:transition>
     </mc:Choice>
-    <mc:Fallback>
+    <mc:Fallback xmlns="">
       <p:transition spd="slow">
         <p:fade/>
       </p:transition>
@@ -5546,13 +5546,13 @@
   <p:clrMapOvr>
     <a:masterClrMapping/>
   </p:clrMapOvr>
-  <mc:AlternateContent xmlns:mc="http://schemas.openxmlformats.org/markup-compatibility/2006">
-    <mc:Choice xmlns:p159="http://schemas.microsoft.com/office/powerpoint/2015/09/main" Requires="p159">
+  <mc:AlternateContent xmlns:mc="http://schemas.openxmlformats.org/markup-compatibility/2006" xmlns:p159="http://schemas.microsoft.com/office/powerpoint/2015/09/main">
+    <mc:Choice Requires="p159">
       <p:transition spd="slow">
         <p159:morph option="byObject"/>
       </p:transition>
     </mc:Choice>
-    <mc:Fallback>
+    <mc:Fallback xmlns="">
       <p:transition spd="slow">
         <p:fade/>
       </p:transition>
@@ -5770,13 +5770,13 @@
   <p:clrMapOvr>
     <a:masterClrMapping/>
   </p:clrMapOvr>
-  <mc:AlternateContent xmlns:mc="http://schemas.openxmlformats.org/markup-compatibility/2006">
-    <mc:Choice xmlns:p159="http://schemas.microsoft.com/office/powerpoint/2015/09/main" Requires="p159">
+  <mc:AlternateContent xmlns:mc="http://schemas.openxmlformats.org/markup-compatibility/2006" xmlns:p159="http://schemas.microsoft.com/office/powerpoint/2015/09/main">
+    <mc:Choice Requires="p159">
       <p:transition spd="slow">
         <p159:morph option="byObject"/>
       </p:transition>
     </mc:Choice>
-    <mc:Fallback>
+    <mc:Fallback xmlns="">
       <p:transition spd="slow">
         <p:fade/>
       </p:transition>
@@ -6114,13 +6114,13 @@
   <p:clrMapOvr>
     <a:masterClrMapping/>
   </p:clrMapOvr>
-  <mc:AlternateContent xmlns:mc="http://schemas.openxmlformats.org/markup-compatibility/2006">
-    <mc:Choice xmlns:p159="http://schemas.microsoft.com/office/powerpoint/2015/09/main" Requires="p159">
+  <mc:AlternateContent xmlns:mc="http://schemas.openxmlformats.org/markup-compatibility/2006" xmlns:p159="http://schemas.microsoft.com/office/powerpoint/2015/09/main">
+    <mc:Choice Requires="p159">
       <p:transition spd="slow">
         <p159:morph option="byObject"/>
       </p:transition>
     </mc:Choice>
-    <mc:Fallback>
+    <mc:Fallback xmlns="">
       <p:transition spd="slow">
         <p:fade/>
       </p:transition>
@@ -6193,13 +6193,13 @@
   <p:clrMapOvr>
     <a:masterClrMapping/>
   </p:clrMapOvr>
-  <mc:AlternateContent xmlns:mc="http://schemas.openxmlformats.org/markup-compatibility/2006">
-    <mc:Choice xmlns:p159="http://schemas.microsoft.com/office/powerpoint/2015/09/main" Requires="p159">
+  <mc:AlternateContent xmlns:mc="http://schemas.openxmlformats.org/markup-compatibility/2006" xmlns:p159="http://schemas.microsoft.com/office/powerpoint/2015/09/main">
+    <mc:Choice Requires="p159">
       <p:transition spd="slow">
         <p159:morph option="byObject"/>
       </p:transition>
     </mc:Choice>
-    <mc:Fallback>
+    <mc:Fallback xmlns="">
       <p:transition spd="slow">
         <p:fade/>
       </p:transition>
@@ -7215,13 +7215,13 @@
   <p:clrMapOvr>
     <a:masterClrMapping/>
   </p:clrMapOvr>
-  <mc:AlternateContent xmlns:mc="http://schemas.openxmlformats.org/markup-compatibility/2006">
-    <mc:Choice xmlns:p159="http://schemas.microsoft.com/office/powerpoint/2015/09/main" Requires="p159">
+  <mc:AlternateContent xmlns:mc="http://schemas.openxmlformats.org/markup-compatibility/2006" xmlns:p159="http://schemas.microsoft.com/office/powerpoint/2015/09/main">
+    <mc:Choice Requires="p159">
       <p:transition spd="slow">
         <p159:morph option="byObject"/>
       </p:transition>
     </mc:Choice>
-    <mc:Fallback>
+    <mc:Fallback xmlns="">
       <p:transition spd="slow">
         <p:fade/>
       </p:transition>
@@ -9177,13 +9177,13 @@
   <p:clrMapOvr>
     <a:masterClrMapping/>
   </p:clrMapOvr>
-  <mc:AlternateContent xmlns:mc="http://schemas.openxmlformats.org/markup-compatibility/2006">
-    <mc:Choice xmlns:p159="http://schemas.microsoft.com/office/powerpoint/2015/09/main" Requires="p159">
+  <mc:AlternateContent xmlns:mc="http://schemas.openxmlformats.org/markup-compatibility/2006" xmlns:p159="http://schemas.microsoft.com/office/powerpoint/2015/09/main">
+    <mc:Choice Requires="p159">
       <p:transition spd="slow">
         <p159:morph option="byObject"/>
       </p:transition>
     </mc:Choice>
-    <mc:Fallback>
+    <mc:Fallback xmlns="">
       <p:transition spd="slow">
         <p:fade/>
       </p:transition>
@@ -9256,13 +9256,13 @@
   <p:clrMapOvr>
     <a:masterClrMapping/>
   </p:clrMapOvr>
-  <mc:AlternateContent xmlns:mc="http://schemas.openxmlformats.org/markup-compatibility/2006">
-    <mc:Choice xmlns:p159="http://schemas.microsoft.com/office/powerpoint/2015/09/main" Requires="p159">
+  <mc:AlternateContent xmlns:mc="http://schemas.openxmlformats.org/markup-compatibility/2006" xmlns:p159="http://schemas.microsoft.com/office/powerpoint/2015/09/main">
+    <mc:Choice Requires="p159">
       <p:transition spd="slow">
         <p159:morph option="byObject"/>
       </p:transition>
     </mc:Choice>
-    <mc:Fallback>
+    <mc:Fallback xmlns="">
       <p:transition spd="slow">
         <p:fade/>
       </p:transition>
@@ -15153,7 +15153,7 @@
 </file>
 
 <file path=ppt/slides/slide36.xml><?xml version="1.0" encoding="utf-8"?>
-<p:sld xmlns:a="http://schemas.openxmlformats.org/drawingml/2006/main" xmlns:r="http://schemas.openxmlformats.org/officeDocument/2006/relationships" xmlns:p="http://schemas.openxmlformats.org/presentationml/2006/main">
+<p:sld xmlns:a="http://schemas.openxmlformats.org/drawingml/2006/main" xmlns:r="http://schemas.openxmlformats.org/officeDocument/2006/relationships" xmlns:p="http://schemas.openxmlformats.org/presentationml/2006/main" show="0">
   <p:cSld>
     <p:spTree>
       <p:nvGrpSpPr>
@@ -15214,13 +15214,13 @@
   <p:clrMapOvr>
     <a:masterClrMapping/>
   </p:clrMapOvr>
-  <mc:AlternateContent xmlns:mc="http://schemas.openxmlformats.org/markup-compatibility/2006" xmlns:p159="http://schemas.microsoft.com/office/powerpoint/2015/09/main">
-    <mc:Choice Requires="p159">
+  <mc:AlternateContent xmlns:mc="http://schemas.openxmlformats.org/markup-compatibility/2006">
+    <mc:Choice xmlns:p159="http://schemas.microsoft.com/office/powerpoint/2015/09/main" Requires="p159">
       <p:transition spd="slow">
         <p159:morph option="byObject"/>
       </p:transition>
     </mc:Choice>
-    <mc:Fallback xmlns="">
+    <mc:Fallback>
       <p:transition spd="slow">
         <p:fade/>
       </p:transition>
@@ -15230,7 +15230,7 @@
 </file>
 
 <file path=ppt/slides/slide37.xml><?xml version="1.0" encoding="utf-8"?>
-<p:sld xmlns:a="http://schemas.openxmlformats.org/drawingml/2006/main" xmlns:r="http://schemas.openxmlformats.org/officeDocument/2006/relationships" xmlns:p="http://schemas.openxmlformats.org/presentationml/2006/main">
+<p:sld xmlns:a="http://schemas.openxmlformats.org/drawingml/2006/main" xmlns:r="http://schemas.openxmlformats.org/officeDocument/2006/relationships" xmlns:p="http://schemas.openxmlformats.org/presentationml/2006/main" show="0">
   <p:cSld>
     <p:spTree>
       <p:nvGrpSpPr>
@@ -15565,13 +15565,13 @@
   <p:clrMapOvr>
     <a:masterClrMapping/>
   </p:clrMapOvr>
-  <mc:AlternateContent xmlns:mc="http://schemas.openxmlformats.org/markup-compatibility/2006" xmlns:p159="http://schemas.microsoft.com/office/powerpoint/2015/09/main">
-    <mc:Choice Requires="p159">
+  <mc:AlternateContent xmlns:mc="http://schemas.openxmlformats.org/markup-compatibility/2006">
+    <mc:Choice xmlns:p159="http://schemas.microsoft.com/office/powerpoint/2015/09/main" Requires="p159">
       <p:transition spd="slow">
         <p159:morph option="byObject"/>
       </p:transition>
     </mc:Choice>
-    <mc:Fallback xmlns="">
+    <mc:Fallback>
       <p:transition spd="slow">
         <p:fade/>
       </p:transition>
@@ -15581,7 +15581,7 @@
 </file>
 
 <file path=ppt/slides/slide38.xml><?xml version="1.0" encoding="utf-8"?>
-<p:sld xmlns:a="http://schemas.openxmlformats.org/drawingml/2006/main" xmlns:r="http://schemas.openxmlformats.org/officeDocument/2006/relationships" xmlns:p="http://schemas.openxmlformats.org/presentationml/2006/main">
+<p:sld xmlns:a="http://schemas.openxmlformats.org/drawingml/2006/main" xmlns:r="http://schemas.openxmlformats.org/officeDocument/2006/relationships" xmlns:p="http://schemas.openxmlformats.org/presentationml/2006/main" show="0">
   <p:cSld>
     <p:spTree>
       <p:nvGrpSpPr>
@@ -15934,13 +15934,13 @@
   <p:clrMapOvr>
     <a:masterClrMapping/>
   </p:clrMapOvr>
-  <mc:AlternateContent xmlns:mc="http://schemas.openxmlformats.org/markup-compatibility/2006" xmlns:p159="http://schemas.microsoft.com/office/powerpoint/2015/09/main">
-    <mc:Choice Requires="p159">
+  <mc:AlternateContent xmlns:mc="http://schemas.openxmlformats.org/markup-compatibility/2006">
+    <mc:Choice xmlns:p159="http://schemas.microsoft.com/office/powerpoint/2015/09/main" Requires="p159">
       <p:transition spd="slow">
         <p159:morph option="byObject"/>
       </p:transition>
     </mc:Choice>
-    <mc:Fallback xmlns="">
+    <mc:Fallback>
       <p:transition spd="slow">
         <p:fade/>
       </p:transition>
@@ -15950,7 +15950,7 @@
 </file>
 
 <file path=ppt/slides/slide39.xml><?xml version="1.0" encoding="utf-8"?>
-<p:sld xmlns:a="http://schemas.openxmlformats.org/drawingml/2006/main" xmlns:r="http://schemas.openxmlformats.org/officeDocument/2006/relationships" xmlns:p="http://schemas.openxmlformats.org/presentationml/2006/main">
+<p:sld xmlns:a="http://schemas.openxmlformats.org/drawingml/2006/main" xmlns:r="http://schemas.openxmlformats.org/officeDocument/2006/relationships" xmlns:p="http://schemas.openxmlformats.org/presentationml/2006/main" show="0">
   <p:cSld>
     <p:spTree>
       <p:nvGrpSpPr>
@@ -16426,13 +16426,13 @@
   <p:clrMapOvr>
     <a:masterClrMapping/>
   </p:clrMapOvr>
-  <mc:AlternateContent xmlns:mc="http://schemas.openxmlformats.org/markup-compatibility/2006" xmlns:p159="http://schemas.microsoft.com/office/powerpoint/2015/09/main">
-    <mc:Choice Requires="p159">
+  <mc:AlternateContent xmlns:mc="http://schemas.openxmlformats.org/markup-compatibility/2006">
+    <mc:Choice xmlns:p159="http://schemas.microsoft.com/office/powerpoint/2015/09/main" Requires="p159">
       <p:transition spd="slow">
         <p159:morph option="byObject"/>
       </p:transition>
     </mc:Choice>
-    <mc:Fallback xmlns="">
+    <mc:Fallback>
       <p:transition spd="slow">
         <p:fade/>
       </p:transition>
@@ -16853,7 +16853,7 @@
 </file>
 
 <file path=ppt/slides/slide40.xml><?xml version="1.0" encoding="utf-8"?>
-<p:sld xmlns:a="http://schemas.openxmlformats.org/drawingml/2006/main" xmlns:r="http://schemas.openxmlformats.org/officeDocument/2006/relationships" xmlns:p="http://schemas.openxmlformats.org/presentationml/2006/main">
+<p:sld xmlns:a="http://schemas.openxmlformats.org/drawingml/2006/main" xmlns:r="http://schemas.openxmlformats.org/officeDocument/2006/relationships" xmlns:p="http://schemas.openxmlformats.org/presentationml/2006/main" show="0">
   <p:cSld>
     <p:spTree>
       <p:nvGrpSpPr>
@@ -17047,13 +17047,13 @@
   <p:clrMapOvr>
     <a:masterClrMapping/>
   </p:clrMapOvr>
-  <mc:AlternateContent xmlns:mc="http://schemas.openxmlformats.org/markup-compatibility/2006" xmlns:p159="http://schemas.microsoft.com/office/powerpoint/2015/09/main">
-    <mc:Choice Requires="p159">
+  <mc:AlternateContent xmlns:mc="http://schemas.openxmlformats.org/markup-compatibility/2006">
+    <mc:Choice xmlns:p159="http://schemas.microsoft.com/office/powerpoint/2015/09/main" Requires="p159">
       <p:transition spd="slow">
         <p159:morph option="byObject"/>
       </p:transition>
     </mc:Choice>
-    <mc:Fallback xmlns="">
+    <mc:Fallback>
       <p:transition spd="slow">
         <p:fade/>
       </p:transition>
@@ -19205,13 +19205,13 @@
   <p:clrMapOvr>
     <a:masterClrMapping/>
   </p:clrMapOvr>
-  <mc:AlternateContent xmlns:mc="http://schemas.openxmlformats.org/markup-compatibility/2006">
-    <mc:Choice xmlns:p159="http://schemas.microsoft.com/office/powerpoint/2015/09/main" Requires="p159">
+  <mc:AlternateContent xmlns:mc="http://schemas.openxmlformats.org/markup-compatibility/2006" xmlns:p159="http://schemas.microsoft.com/office/powerpoint/2015/09/main">
+    <mc:Choice Requires="p159">
       <p:transition spd="slow">
         <p159:morph option="byObject"/>
       </p:transition>
     </mc:Choice>
-    <mc:Fallback>
+    <mc:Fallback xmlns="">
       <p:transition spd="slow">
         <p:fade/>
       </p:transition>
@@ -19481,13 +19481,13 @@
   <p:clrMapOvr>
     <a:masterClrMapping/>
   </p:clrMapOvr>
-  <mc:AlternateContent xmlns:mc="http://schemas.openxmlformats.org/markup-compatibility/2006">
-    <mc:Choice xmlns:p159="http://schemas.microsoft.com/office/powerpoint/2015/09/main" Requires="p159">
+  <mc:AlternateContent xmlns:mc="http://schemas.openxmlformats.org/markup-compatibility/2006" xmlns:p159="http://schemas.microsoft.com/office/powerpoint/2015/09/main">
+    <mc:Choice Requires="p159">
       <p:transition spd="slow">
         <p159:morph option="byObject"/>
       </p:transition>
     </mc:Choice>
-    <mc:Fallback>
+    <mc:Fallback xmlns="">
       <p:transition spd="slow">
         <p:fade/>
       </p:transition>
@@ -19673,13 +19673,13 @@
   <p:clrMapOvr>
     <a:masterClrMapping/>
   </p:clrMapOvr>
-  <mc:AlternateContent xmlns:mc="http://schemas.openxmlformats.org/markup-compatibility/2006">
-    <mc:Choice xmlns:p159="http://schemas.microsoft.com/office/powerpoint/2015/09/main" Requires="p159">
+  <mc:AlternateContent xmlns:mc="http://schemas.openxmlformats.org/markup-compatibility/2006" xmlns:p159="http://schemas.microsoft.com/office/powerpoint/2015/09/main">
+    <mc:Choice Requires="p159">
       <p:transition spd="slow">
         <p159:morph option="byObject"/>
       </p:transition>
     </mc:Choice>
-    <mc:Fallback>
+    <mc:Fallback xmlns="">
       <p:transition spd="slow">
         <p:fade/>
       </p:transition>

</xml_diff>